<commit_message>
Update to short, neat and simple 6-slide presentation
</commit_message>
<xml_diff>
--- a/AgriYield_Presentation.pptx
+++ b/AgriYield_Presentation.pptx
@@ -3109,8 +3109,8 @@
         </p:nvSpPr>
         <p:spPr>
           <a:xfrm>
-            <a:off x="731520" y="731520"/>
-            <a:ext cx="10728655" cy="109728"/>
+            <a:off x="914400" y="914400"/>
+            <a:ext cx="10362895" cy="73152"/>
           </a:xfrm>
           <a:prstGeom prst="rect">
             <a:avLst/>
@@ -3154,8 +3154,8 @@
         </p:nvSpPr>
         <p:spPr>
           <a:xfrm>
-            <a:off x="731520" y="1097280"/>
-            <a:ext cx="10728655" cy="365760"/>
+            <a:off x="914400" y="1280160"/>
+            <a:ext cx="10362895" cy="1463040"/>
           </a:xfrm>
           <a:prstGeom prst="rect">
             <a:avLst/>
@@ -3163,108 +3163,49 @@
           <a:noFill/>
         </p:spPr>
         <p:txBody>
-          <a:bodyPr wrap="none">
-            <a:spAutoFit/>
-          </a:bodyPr>
-          <a:lstStyle/>
-          <a:p>
-            <a:pPr>
-              <a:defRPr sz="1100" b="1">
-                <a:solidFill>
-                  <a:srgbClr val="10B981"/>
-                </a:solidFill>
-              </a:defRPr>
-            </a:pPr>
-            <a:r>
-              <a:t>ACADEMIC DATA SCIENCE PROJECT  •  MACHINE LEARNING &amp; ANALYTICS</a:t>
-            </a:r>
-          </a:p>
-        </p:txBody>
-      </p:sp>
-      <p:sp>
-        <p:nvSpPr>
-          <p:cNvPr id="4" name="TextBox 3"/>
-          <p:cNvSpPr txBox="1"/>
-          <p:nvPr/>
-        </p:nvSpPr>
-        <p:spPr>
-          <a:xfrm>
-            <a:off x="731520" y="1463040"/>
-            <a:ext cx="10728655" cy="1371600"/>
-          </a:xfrm>
-          <a:prstGeom prst="rect">
-            <a:avLst/>
-          </a:prstGeom>
-          <a:noFill/>
-        </p:spPr>
-        <p:txBody>
           <a:bodyPr wrap="square">
             <a:spAutoFit/>
           </a:bodyPr>
           <a:lstStyle/>
           <a:p>
             <a:pPr>
-              <a:defRPr sz="3200" b="1">
+              <a:defRPr sz="3600" b="1">
                 <a:solidFill>
                   <a:srgbClr val="FFFFFF"/>
                 </a:solidFill>
               </a:defRPr>
             </a:pPr>
             <a:r>
-              <a:t>AgriYield: Data Science-Based Crop Yield</a:t>
-            </a:r>
-            <a:br/>
-            <a:r>
-              <a:t>Analysis and Prediction</a:t>
-            </a:r>
-          </a:p>
-        </p:txBody>
-      </p:sp>
-      <p:sp>
-        <p:nvSpPr>
-          <p:cNvPr id="5" name="TextBox 4"/>
-          <p:cNvSpPr txBox="1"/>
-          <p:nvPr/>
-        </p:nvSpPr>
-        <p:spPr>
-          <a:xfrm>
-            <a:off x="731520" y="3017520"/>
-            <a:ext cx="10728655" cy="548640"/>
-          </a:xfrm>
-          <a:prstGeom prst="rect">
-            <a:avLst/>
-          </a:prstGeom>
-          <a:noFill/>
-        </p:spPr>
-        <p:txBody>
-          <a:bodyPr wrap="none">
-            <a:spAutoFit/>
-          </a:bodyPr>
-          <a:lstStyle/>
+              <a:t>🌾 AgriYield: Crop Yield Prediction</a:t>
+            </a:r>
+          </a:p>
           <a:p>
             <a:pPr>
-              <a:defRPr sz="1500">
+              <a:spcBef>
+                <a:spcPts val="800"/>
+              </a:spcBef>
+              <a:defRPr sz="1600">
                 <a:solidFill>
                   <a:srgbClr val="94A3B8"/>
                 </a:solidFill>
               </a:defRPr>
             </a:pPr>
             <a:r>
-              <a:t>AI-Driven Pre-Harvest Yield Forecasting Using 24 Years of Indian Agricultural Census Data</a:t>
-            </a:r>
-          </a:p>
-        </p:txBody>
-      </p:sp>
-      <p:sp>
-        <p:nvSpPr>
-          <p:cNvPr id="6" name="Rounded Rectangle 5"/>
+              <a:t>Data Science-Based Agricultural Analysis and Pre-Harvest Forecasting</a:t>
+            </a:r>
+          </a:p>
+        </p:txBody>
+      </p:sp>
+      <p:sp>
+        <p:nvSpPr>
+          <p:cNvPr id="4" name="Rounded Rectangle 3"/>
           <p:cNvSpPr/>
           <p:nvPr/>
         </p:nvSpPr>
         <p:spPr>
           <a:xfrm>
-            <a:off x="731520" y="3931920"/>
-            <a:ext cx="5303520" cy="2103120"/>
+            <a:off x="914400" y="3291840"/>
+            <a:ext cx="5486400" cy="2377440"/>
           </a:xfrm>
           <a:prstGeom prst="roundRect">
             <a:avLst/>
@@ -3302,14 +3243,14 @@
       </p:sp>
       <p:sp>
         <p:nvSpPr>
-          <p:cNvPr id="7" name="TextBox 6"/>
+          <p:cNvPr id="5" name="TextBox 4"/>
           <p:cNvSpPr txBox="1"/>
           <p:nvPr/>
         </p:nvSpPr>
         <p:spPr>
           <a:xfrm>
-            <a:off x="1005840" y="4114800"/>
-            <a:ext cx="4754880" cy="1737360"/>
+            <a:off x="1188720" y="3566160"/>
+            <a:ext cx="4937760" cy="1920240"/>
           </a:xfrm>
           <a:prstGeom prst="rect">
             <a:avLst/>
@@ -3317,28 +3258,28 @@
           <a:noFill/>
         </p:spPr>
         <p:txBody>
-          <a:bodyPr wrap="square">
+          <a:bodyPr wrap="none">
             <a:spAutoFit/>
           </a:bodyPr>
           <a:lstStyle/>
           <a:p>
             <a:pPr>
-              <a:defRPr sz="1000" b="1">
+              <a:defRPr sz="1100" b="1">
                 <a:solidFill>
                   <a:srgbClr val="10B981"/>
                 </a:solidFill>
               </a:defRPr>
             </a:pPr>
             <a:r>
-              <a:t>PRESENTED BY:</a:t>
+              <a:t>PRESENTED BY</a:t>
             </a:r>
           </a:p>
           <a:p>
             <a:pPr>
               <a:spcBef>
-                <a:spcPts val="400"/>
+                <a:spcPts val="600"/>
               </a:spcBef>
-              <a:defRPr sz="2200" b="1">
+              <a:defRPr sz="2600" b="1">
                 <a:solidFill>
                   <a:srgbClr val="FFFFFF"/>
                 </a:solidFill>
@@ -3351,9 +3292,9 @@
           <a:p>
             <a:pPr>
               <a:spcBef>
-                <a:spcPts val="400"/>
+                <a:spcPts val="600"/>
               </a:spcBef>
-              <a:defRPr sz="1400" b="1">
+              <a:defRPr sz="1600" b="1">
                 <a:solidFill>
                   <a:srgbClr val="38BDF8"/>
                 </a:solidFill>
@@ -3367,14 +3308,14 @@
       </p:sp>
       <p:sp>
         <p:nvSpPr>
-          <p:cNvPr id="8" name="Rounded Rectangle 7"/>
+          <p:cNvPr id="6" name="Rounded Rectangle 5"/>
           <p:cNvSpPr/>
           <p:nvPr/>
         </p:nvSpPr>
         <p:spPr>
           <a:xfrm>
-            <a:off x="6309360" y="3931920"/>
-            <a:ext cx="5120640" cy="2103120"/>
+            <a:off x="6675120" y="3291840"/>
+            <a:ext cx="4572000" cy="2377440"/>
           </a:xfrm>
           <a:prstGeom prst="roundRect">
             <a:avLst/>
@@ -3412,14 +3353,14 @@
       </p:sp>
       <p:sp>
         <p:nvSpPr>
-          <p:cNvPr id="9" name="TextBox 8"/>
+          <p:cNvPr id="7" name="TextBox 6"/>
           <p:cNvSpPr txBox="1"/>
           <p:nvPr/>
         </p:nvSpPr>
         <p:spPr>
           <a:xfrm>
-            <a:off x="6583680" y="4114800"/>
-            <a:ext cx="4572000" cy="1737360"/>
+            <a:off x="6949440" y="3566160"/>
+            <a:ext cx="4023360" cy="1920240"/>
           </a:xfrm>
           <a:prstGeom prst="rect">
             <a:avLst/>
@@ -3427,80 +3368,80 @@
           <a:noFill/>
         </p:spPr>
         <p:txBody>
-          <a:bodyPr wrap="square">
+          <a:bodyPr wrap="none">
             <a:spAutoFit/>
           </a:bodyPr>
           <a:lstStyle/>
           <a:p>
             <a:pPr>
-              <a:defRPr sz="1000" b="1">
+              <a:defRPr sz="1100" b="1">
                 <a:solidFill>
                   <a:srgbClr val="10B981"/>
                 </a:solidFill>
               </a:defRPr>
             </a:pPr>
             <a:r>
-              <a:t>KEY PROJECT HIGHLIGHTS:</a:t>
+              <a:t>PROJECT QUICK FACTS</a:t>
             </a:r>
           </a:p>
           <a:p>
             <a:pPr>
               <a:spcBef>
-                <a:spcPts val="300"/>
+                <a:spcPts val="500"/>
               </a:spcBef>
-              <a:defRPr sz="1100">
+              <a:defRPr sz="1200">
                 <a:solidFill>
                   <a:srgbClr val="F1F5F9"/>
                 </a:solidFill>
               </a:defRPr>
             </a:pPr>
             <a:r>
-              <a:t>•  19,689 Real Census Records (1997–2020 longitudinal series)</a:t>
+              <a:t>✔  19,689 Real Census Records (1997–2020)</a:t>
             </a:r>
           </a:p>
           <a:p>
             <a:pPr>
               <a:spcBef>
-                <a:spcPts val="300"/>
+                <a:spcPts val="500"/>
               </a:spcBef>
-              <a:defRPr sz="1100">
+              <a:defRPr sz="1200">
                 <a:solidFill>
                   <a:srgbClr val="F1F5F9"/>
                 </a:solidFill>
               </a:defRPr>
             </a:pPr>
             <a:r>
-              <a:t>•  55 Crops &amp; 30 Indian States Nationwide Coverage</a:t>
+              <a:t>✔  55 Crops &amp; 30 Indian States</a:t>
             </a:r>
           </a:p>
           <a:p>
             <a:pPr>
               <a:spcBef>
-                <a:spcPts val="300"/>
+                <a:spcPts val="500"/>
               </a:spcBef>
-              <a:defRPr sz="1100">
+              <a:defRPr sz="1200">
                 <a:solidFill>
                   <a:srgbClr val="F1F5F9"/>
                 </a:solidFill>
               </a:defRPr>
             </a:pPr>
             <a:r>
-              <a:t>•  Champion Model: Random Forest Regressor (96.8% Test R²)</a:t>
+              <a:t>✔  Champion Model: Random Forest</a:t>
             </a:r>
           </a:p>
           <a:p>
             <a:pPr>
               <a:spcBef>
-                <a:spcPts val="300"/>
+                <a:spcPts val="500"/>
               </a:spcBef>
-              <a:defRPr sz="1100">
+              <a:defRPr sz="1200">
                 <a:solidFill>
                   <a:srgbClr val="F1F5F9"/>
                 </a:solidFill>
               </a:defRPr>
             </a:pPr>
             <a:r>
-              <a:t>•  Zero Target Data Leakage (Strict Pre-Harvest Predictors)</a:t>
+              <a:t>✔  Prediction Accuracy: 96.8% (R² Score)</a:t>
             </a:r>
           </a:p>
         </p:txBody>
@@ -3539,8 +3480,8 @@
         </p:nvSpPr>
         <p:spPr>
           <a:xfrm>
-            <a:off x="731520" y="365760"/>
-            <a:ext cx="10698480" cy="365760"/>
+            <a:off x="914400" y="457200"/>
+            <a:ext cx="10332720" cy="365760"/>
           </a:xfrm>
           <a:prstGeom prst="rect">
             <a:avLst/>
@@ -3548,20 +3489,20 @@
           <a:noFill/>
         </p:spPr>
         <p:txBody>
-          <a:bodyPr wrap="square">
+          <a:bodyPr wrap="none">
             <a:spAutoFit/>
           </a:bodyPr>
           <a:lstStyle/>
           <a:p>
             <a:pPr>
-              <a:defRPr sz="1000" b="1">
+              <a:defRPr sz="1100" b="1">
                 <a:solidFill>
                   <a:srgbClr val="10B981"/>
                 </a:solidFill>
               </a:defRPr>
             </a:pPr>
             <a:r>
-              <a:t>AGRIYIELD — DATA SCIENCE PROJECT</a:t>
+              <a:t>AGRIYIELD  •  SLIDE 2 OF 6</a:t>
             </a:r>
           </a:p>
         </p:txBody>
@@ -3574,8 +3515,8 @@
         </p:nvSpPr>
         <p:spPr>
           <a:xfrm>
-            <a:off x="731520" y="640080"/>
-            <a:ext cx="10698480" cy="640080"/>
+            <a:off x="914400" y="777240"/>
+            <a:ext cx="10332720" cy="731520"/>
           </a:xfrm>
           <a:prstGeom prst="rect">
             <a:avLst/>
@@ -3583,20 +3524,20 @@
           <a:noFill/>
         </p:spPr>
         <p:txBody>
-          <a:bodyPr wrap="square">
+          <a:bodyPr wrap="none">
             <a:spAutoFit/>
           </a:bodyPr>
           <a:lstStyle/>
           <a:p>
             <a:pPr>
-              <a:defRPr sz="2400" b="1">
-                <a:solidFill>
-                  <a:srgbClr val="F1F5F9"/>
+              <a:defRPr sz="2600" b="1">
+                <a:solidFill>
+                  <a:srgbClr val="FFFFFF"/>
                 </a:solidFill>
               </a:defRPr>
             </a:pPr>
             <a:r>
-              <a:t>1. Research Motivation &amp; Core Objectives</a:t>
+              <a:t>The Real-World Problem &amp; Our Solution</a:t>
             </a:r>
           </a:p>
         </p:txBody>
@@ -3609,8 +3550,8 @@
         </p:nvSpPr>
         <p:spPr>
           <a:xfrm>
-            <a:off x="731520" y="1554480"/>
-            <a:ext cx="5120640" cy="4572000"/>
+            <a:off x="914400" y="1645920"/>
+            <a:ext cx="4937760" cy="4389120"/>
           </a:xfrm>
           <a:prstGeom prst="roundRect">
             <a:avLst/>
@@ -3618,7 +3559,7 @@
           <a:solidFill>
             <a:srgbClr val="182234"/>
           </a:solidFill>
-          <a:ln w="19050">
+          <a:ln>
             <a:solidFill>
               <a:srgbClr val="EF4444"/>
             </a:solidFill>
@@ -3654,8 +3595,8 @@
         </p:nvSpPr>
         <p:spPr>
           <a:xfrm>
-            <a:off x="1005840" y="1737360"/>
-            <a:ext cx="4572000" cy="4114800"/>
+            <a:off x="1188720" y="1828800"/>
+            <a:ext cx="4389120" cy="4023360"/>
           </a:xfrm>
           <a:prstGeom prst="rect">
             <a:avLst/>
@@ -3676,52 +3617,52 @@
               </a:defRPr>
             </a:pPr>
             <a:r>
-              <a:t>⚠️ THE TRADITIONAL PROBLEM</a:t>
+              <a:t>⚠️ THE PROBLEM TODAY</a:t>
             </a:r>
           </a:p>
           <a:p>
             <a:pPr>
               <a:spcBef>
-                <a:spcPts val="1200"/>
+                <a:spcPts val="1400"/>
               </a:spcBef>
-              <a:defRPr sz="1200">
+              <a:defRPr sz="1300">
                 <a:solidFill>
                   <a:srgbClr val="F1F5F9"/>
                 </a:solidFill>
               </a:defRPr>
             </a:pPr>
             <a:r>
-              <a:t>• Post-Harvest Delay: Yield is historically measured only after harvesting through manual Crop Cutting Experiments (CCEs).</a:t>
+              <a:t>•  Manual Crop-Cutting: Yield is only measured after harvest by manually cutting field samples.</a:t>
             </a:r>
           </a:p>
           <a:p>
             <a:pPr>
               <a:spcBef>
-                <a:spcPts val="1200"/>
+                <a:spcPts val="1400"/>
               </a:spcBef>
-              <a:defRPr sz="1200">
+              <a:defRPr sz="1300">
                 <a:solidFill>
                   <a:srgbClr val="F1F5F9"/>
                 </a:solidFill>
               </a:defRPr>
             </a:pPr>
             <a:r>
-              <a:t>• Logistical Strain: By the time data is collected, critical food supply shortages and price inflation have already occurred.</a:t>
+              <a:t>•  Too Late for Action: When food shortages occur, prices have already spiked.</a:t>
             </a:r>
           </a:p>
           <a:p>
             <a:pPr>
               <a:spcBef>
-                <a:spcPts val="1200"/>
+                <a:spcPts val="1400"/>
               </a:spcBef>
-              <a:defRPr sz="1200">
+              <a:defRPr sz="1300">
                 <a:solidFill>
                   <a:srgbClr val="F1F5F9"/>
                 </a:solidFill>
               </a:defRPr>
             </a:pPr>
             <a:r>
-              <a:t>• No Early Warning: Policymakers and farmers lack advance warning to plan cold-storage, transport, or MSP procurement.</a:t>
+              <a:t>•  No Advance Planning: Farmers cannot plan storage, trucks, or sales in advance.</a:t>
             </a:r>
           </a:p>
         </p:txBody>
@@ -3734,8 +3675,8 @@
         </p:nvSpPr>
         <p:spPr>
           <a:xfrm>
-            <a:off x="6309360" y="1554480"/>
-            <a:ext cx="5120640" cy="4572000"/>
+            <a:off x="6309360" y="1645920"/>
+            <a:ext cx="4937760" cy="4389120"/>
           </a:xfrm>
           <a:prstGeom prst="roundRect">
             <a:avLst/>
@@ -3743,7 +3684,7 @@
           <a:solidFill>
             <a:srgbClr val="182234"/>
           </a:solidFill>
-          <a:ln w="19050">
+          <a:ln>
             <a:solidFill>
               <a:srgbClr val="10B981"/>
             </a:solidFill>
@@ -3779,8 +3720,8 @@
         </p:nvSpPr>
         <p:spPr>
           <a:xfrm>
-            <a:off x="6583680" y="1737360"/>
-            <a:ext cx="4572000" cy="4114800"/>
+            <a:off x="6583680" y="1828800"/>
+            <a:ext cx="4389120" cy="4023360"/>
           </a:xfrm>
           <a:prstGeom prst="rect">
             <a:avLst/>
@@ -3807,46 +3748,46 @@
           <a:p>
             <a:pPr>
               <a:spcBef>
-                <a:spcPts val="1200"/>
+                <a:spcPts val="1400"/>
               </a:spcBef>
-              <a:defRPr sz="1200">
+              <a:defRPr sz="1300">
                 <a:solidFill>
                   <a:srgbClr val="F1F5F9"/>
                 </a:solidFill>
               </a:defRPr>
             </a:pPr>
             <a:r>
-              <a:t>• Pre-Harvest Prediction: Predict crop yield months before harvest using environmental and input factors available during sowing.</a:t>
+              <a:t>✔  Pre-Harvest Forecasting: Predicts crop yield months before harvest using planting data.</a:t>
             </a:r>
           </a:p>
           <a:p>
             <a:pPr>
               <a:spcBef>
-                <a:spcPts val="1200"/>
+                <a:spcPts val="1400"/>
               </a:spcBef>
-              <a:defRPr sz="1200">
+              <a:defRPr sz="1300">
                 <a:solidFill>
                   <a:srgbClr val="F1F5F9"/>
                 </a:solidFill>
               </a:defRPr>
             </a:pPr>
             <a:r>
-              <a:t>• Multi-Factor Intelligence: Analyzes rainfall, fertilizer rate, pesticide rate, land area, geography, and crop species simultaneously.</a:t>
+              <a:t>✔  Simple Everyday Inputs: Uses rainfall, fertilizer amount, land area, and crop type.</a:t>
             </a:r>
           </a:p>
           <a:p>
             <a:pPr>
               <a:spcBef>
-                <a:spcPts val="1200"/>
+                <a:spcPts val="1400"/>
               </a:spcBef>
-              <a:defRPr sz="1200">
+              <a:defRPr sz="1300">
                 <a:solidFill>
                   <a:srgbClr val="F1F5F9"/>
                 </a:solidFill>
               </a:defRPr>
             </a:pPr>
             <a:r>
-              <a:t>• Practical Decision Making: Translates mathematical yield (t/ha) into acre yields and commercial truckload counts for everyday logistics.</a:t>
+              <a:t>✔  Farmer-Friendly Output: Converts numbers into tonnes per acre and truckloads.</a:t>
             </a:r>
           </a:p>
         </p:txBody>
@@ -3885,8 +3826,8 @@
         </p:nvSpPr>
         <p:spPr>
           <a:xfrm>
-            <a:off x="731520" y="365760"/>
-            <a:ext cx="10698480" cy="365760"/>
+            <a:off x="914400" y="457200"/>
+            <a:ext cx="10332720" cy="365760"/>
           </a:xfrm>
           <a:prstGeom prst="rect">
             <a:avLst/>
@@ -3894,20 +3835,20 @@
           <a:noFill/>
         </p:spPr>
         <p:txBody>
-          <a:bodyPr wrap="square">
+          <a:bodyPr wrap="none">
             <a:spAutoFit/>
           </a:bodyPr>
           <a:lstStyle/>
           <a:p>
             <a:pPr>
-              <a:defRPr sz="1000" b="1">
+              <a:defRPr sz="1100" b="1">
                 <a:solidFill>
                   <a:srgbClr val="10B981"/>
                 </a:solidFill>
               </a:defRPr>
             </a:pPr>
             <a:r>
-              <a:t>AGRIYIELD — DATA SCIENCE PROJECT</a:t>
+              <a:t>AGRIYIELD  •  SLIDE 3 OF 6</a:t>
             </a:r>
           </a:p>
         </p:txBody>
@@ -3920,8 +3861,8 @@
         </p:nvSpPr>
         <p:spPr>
           <a:xfrm>
-            <a:off x="731520" y="640080"/>
-            <a:ext cx="10698480" cy="640080"/>
+            <a:off x="914400" y="777240"/>
+            <a:ext cx="10332720" cy="731520"/>
           </a:xfrm>
           <a:prstGeom prst="rect">
             <a:avLst/>
@@ -3929,20 +3870,20 @@
           <a:noFill/>
         </p:spPr>
         <p:txBody>
-          <a:bodyPr wrap="square">
+          <a:bodyPr wrap="none">
             <a:spAutoFit/>
           </a:bodyPr>
           <a:lstStyle/>
           <a:p>
             <a:pPr>
-              <a:defRPr sz="2400" b="1">
-                <a:solidFill>
-                  <a:srgbClr val="F1F5F9"/>
+              <a:defRPr sz="2600" b="1">
+                <a:solidFill>
+                  <a:srgbClr val="FFFFFF"/>
                 </a:solidFill>
               </a:defRPr>
             </a:pPr>
             <a:r>
-              <a:t>2. Dataset Scope &amp; Data Leakage Prevention</a:t>
+              <a:t>The Dataset &amp; Leakage Prevention</a:t>
             </a:r>
           </a:p>
         </p:txBody>
@@ -3955,8 +3896,8 @@
         </p:nvSpPr>
         <p:spPr>
           <a:xfrm>
-            <a:off x="731520" y="1463040"/>
-            <a:ext cx="3383280" cy="1371600"/>
+            <a:off x="914400" y="1645920"/>
+            <a:ext cx="4937760" cy="2103120"/>
           </a:xfrm>
           <a:prstGeom prst="roundRect">
             <a:avLst/>
@@ -4000,8 +3941,8 @@
         </p:nvSpPr>
         <p:spPr>
           <a:xfrm>
-            <a:off x="914400" y="1554480"/>
-            <a:ext cx="3017520" cy="1188720"/>
+            <a:off x="1188720" y="1828800"/>
+            <a:ext cx="4389120" cy="1737360"/>
           </a:xfrm>
           <a:prstGeom prst="rect">
             <a:avLst/>
@@ -4009,44 +3950,35 @@
           <a:noFill/>
         </p:spPr>
         <p:txBody>
-          <a:bodyPr wrap="none">
+          <a:bodyPr wrap="square">
             <a:spAutoFit/>
           </a:bodyPr>
           <a:lstStyle/>
           <a:p>
             <a:pPr>
-              <a:defRPr sz="900" b="1">
-                <a:solidFill>
-                  <a:srgbClr val="94A3B8"/>
+              <a:defRPr sz="1400" b="1">
+                <a:solidFill>
+                  <a:srgbClr val="10B981"/>
                 </a:solidFill>
               </a:defRPr>
             </a:pPr>
             <a:r>
-              <a:t>CENSUS RECORDS</a:t>
+              <a:t>📊 19,689 Records</a:t>
             </a:r>
           </a:p>
           <a:p>
             <a:pPr>
-              <a:defRPr sz="2000" b="1">
-                <a:solidFill>
-                  <a:srgbClr val="10B981"/>
+              <a:spcBef>
+                <a:spcPts val="800"/>
+              </a:spcBef>
+              <a:defRPr sz="1200">
+                <a:solidFill>
+                  <a:srgbClr val="F1F5F9"/>
                 </a:solidFill>
               </a:defRPr>
             </a:pPr>
             <a:r>
-              <a:t>19,689</a:t>
-            </a:r>
-          </a:p>
-          <a:p>
-            <a:pPr>
-              <a:defRPr sz="900">
-                <a:solidFill>
-                  <a:srgbClr val="94A3B8"/>
-                </a:solidFill>
-              </a:defRPr>
-            </a:pPr>
-            <a:r>
-              <a:t>1997–2020 Longitudinal Series</a:t>
+              <a:t>24 Years of authentic Indian agricultural census records (1997 to 2020) from the Ministry of Agriculture &amp; IMD.</a:t>
             </a:r>
           </a:p>
         </p:txBody>
@@ -4059,8 +3991,8 @@
         </p:nvSpPr>
         <p:spPr>
           <a:xfrm>
-            <a:off x="4389120" y="1463040"/>
-            <a:ext cx="3383280" cy="1371600"/>
+            <a:off x="6309360" y="1645920"/>
+            <a:ext cx="4937760" cy="2103120"/>
           </a:xfrm>
           <a:prstGeom prst="roundRect">
             <a:avLst/>
@@ -4104,8 +4036,8 @@
         </p:nvSpPr>
         <p:spPr>
           <a:xfrm>
-            <a:off x="4572000" y="1554480"/>
-            <a:ext cx="3017520" cy="1188720"/>
+            <a:off x="6583680" y="1828800"/>
+            <a:ext cx="4389120" cy="1737360"/>
           </a:xfrm>
           <a:prstGeom prst="rect">
             <a:avLst/>
@@ -4113,44 +4045,35 @@
           <a:noFill/>
         </p:spPr>
         <p:txBody>
-          <a:bodyPr wrap="none">
+          <a:bodyPr wrap="square">
             <a:spAutoFit/>
           </a:bodyPr>
           <a:lstStyle/>
           <a:p>
             <a:pPr>
-              <a:defRPr sz="900" b="1">
-                <a:solidFill>
-                  <a:srgbClr val="94A3B8"/>
+              <a:defRPr sz="1400" b="1">
+                <a:solidFill>
+                  <a:srgbClr val="38BDF8"/>
                 </a:solidFill>
               </a:defRPr>
             </a:pPr>
             <a:r>
-              <a:t>GEOGRAPHIC DIVERSITY</a:t>
+              <a:t>🌾 55 Crops &amp; 30 States</a:t>
             </a:r>
           </a:p>
           <a:p>
             <a:pPr>
-              <a:defRPr sz="2000" b="1">
-                <a:solidFill>
-                  <a:srgbClr val="38BDF8"/>
+              <a:spcBef>
+                <a:spcPts val="800"/>
+              </a:spcBef>
+              <a:defRPr sz="1200">
+                <a:solidFill>
+                  <a:srgbClr val="F1F5F9"/>
                 </a:solidFill>
               </a:defRPr>
             </a:pPr>
             <a:r>
-              <a:t>55 Crops / 30 States</a:t>
-            </a:r>
-          </a:p>
-          <a:p>
-            <a:pPr>
-              <a:defRPr sz="900">
-                <a:solidFill>
-                  <a:srgbClr val="94A3B8"/>
-                </a:solidFill>
-              </a:defRPr>
-            </a:pPr>
-            <a:r>
-              <a:t>All Major Indian Agro-Zones</a:t>
+              <a:t>Wide coverage across cereals (Rice, Wheat), pulses (Gram, Moong), oilseeds, and heavy cash crops (Sugarcane).</a:t>
             </a:r>
           </a:p>
         </p:txBody>
@@ -4163,8 +4086,8 @@
         </p:nvSpPr>
         <p:spPr>
           <a:xfrm>
-            <a:off x="8046720" y="1463040"/>
-            <a:ext cx="3383280" cy="1371600"/>
+            <a:off x="914400" y="4023360"/>
+            <a:ext cx="4937760" cy="2103120"/>
           </a:xfrm>
           <a:prstGeom prst="roundRect">
             <a:avLst/>
@@ -4208,8 +4131,8 @@
         </p:nvSpPr>
         <p:spPr>
           <a:xfrm>
-            <a:off x="8229600" y="1554480"/>
-            <a:ext cx="3017520" cy="1188720"/>
+            <a:off x="1188720" y="4206240"/>
+            <a:ext cx="4389120" cy="1737360"/>
           </a:xfrm>
           <a:prstGeom prst="rect">
             <a:avLst/>
@@ -4217,44 +4140,35 @@
           <a:noFill/>
         </p:spPr>
         <p:txBody>
-          <a:bodyPr wrap="none">
+          <a:bodyPr wrap="square">
             <a:spAutoFit/>
           </a:bodyPr>
           <a:lstStyle/>
           <a:p>
             <a:pPr>
-              <a:defRPr sz="900" b="1">
-                <a:solidFill>
-                  <a:srgbClr val="94A3B8"/>
+              <a:defRPr sz="1400" b="1">
+                <a:solidFill>
+                  <a:srgbClr val="A855F7"/>
                 </a:solidFill>
               </a:defRPr>
             </a:pPr>
             <a:r>
-              <a:t>TARGET LEAKAGE</a:t>
+              <a:t>🛡️ Zero Data Leakage</a:t>
             </a:r>
           </a:p>
           <a:p>
             <a:pPr>
-              <a:defRPr sz="2000" b="1">
-                <a:solidFill>
-                  <a:srgbClr val="A855F7"/>
+              <a:spcBef>
+                <a:spcPts val="800"/>
+              </a:spcBef>
+              <a:defRPr sz="1200">
+                <a:solidFill>
+                  <a:srgbClr val="F1F5F9"/>
                 </a:solidFill>
               </a:defRPr>
             </a:pPr>
             <a:r>
-              <a:t>0.00%</a:t>
-            </a:r>
-          </a:p>
-          <a:p>
-            <a:pPr>
-              <a:defRPr sz="900">
-                <a:solidFill>
-                  <a:srgbClr val="94A3B8"/>
-                </a:solidFill>
-              </a:defRPr>
-            </a:pPr>
-            <a:r>
-              <a:t>Production Strictly Omitted</a:t>
+              <a:t>Strictly excluded 'Total Production' because Yield = Production / Area. If included, the AI would cheat by dividing instead of predicting.</a:t>
             </a:r>
           </a:p>
         </p:txBody>
@@ -4267,8 +4181,8 @@
         </p:nvSpPr>
         <p:spPr>
           <a:xfrm>
-            <a:off x="731520" y="3108960"/>
-            <a:ext cx="10698480" cy="3108960"/>
+            <a:off x="6309360" y="4023360"/>
+            <a:ext cx="4937760" cy="2103120"/>
           </a:xfrm>
           <a:prstGeom prst="roundRect">
             <a:avLst/>
@@ -4276,9 +4190,9 @@
           <a:solidFill>
             <a:srgbClr val="182234"/>
           </a:solidFill>
-          <a:ln>
+          <a:ln w="19050">
             <a:solidFill>
-              <a:srgbClr val="10B981"/>
+              <a:srgbClr val="F59E0B"/>
             </a:solidFill>
           </a:ln>
         </p:spPr>
@@ -4312,8 +4226,8 @@
         </p:nvSpPr>
         <p:spPr>
           <a:xfrm>
-            <a:off x="1005840" y="3291840"/>
-            <a:ext cx="10149840" cy="2743200"/>
+            <a:off x="6583680" y="4206240"/>
+            <a:ext cx="4389120" cy="1737360"/>
           </a:xfrm>
           <a:prstGeom prst="rect">
             <a:avLst/>
@@ -4327,14 +4241,14 @@
           <a:lstStyle/>
           <a:p>
             <a:pPr>
-              <a:defRPr sz="1300" b="1">
-                <a:solidFill>
-                  <a:srgbClr val="10B981"/>
+              <a:defRPr sz="1400" b="1">
+                <a:solidFill>
+                  <a:srgbClr val="F59E0B"/>
                 </a:solidFill>
               </a:defRPr>
             </a:pPr>
             <a:r>
-              <a:t>🛡️ CRITICAL METHODOLOGY: DATA LEAKAGE DEFENSE PROTOCOL</a:t>
+              <a:t>⏳ Real Future Testing</a:t>
             </a:r>
           </a:p>
           <a:p>
@@ -4342,44 +4256,14 @@
               <a:spcBef>
                 <a:spcPts val="800"/>
               </a:spcBef>
-              <a:defRPr sz="1150">
+              <a:defRPr sz="1200">
                 <a:solidFill>
                   <a:srgbClr val="F1F5F9"/>
                 </a:solidFill>
               </a:defRPr>
             </a:pPr>
             <a:r>
-              <a:t>• The Trivial Mathematical Trap: In agricultural statistics, Yield = Total Production / Cultivated Area. Many naive projects mistakenly include 'Production' as a feature, causing models to simply divide two columns rather than predicting yield.</a:t>
-            </a:r>
-          </a:p>
-          <a:p>
-            <a:pPr>
-              <a:spcBef>
-                <a:spcPts val="800"/>
-              </a:spcBef>
-              <a:defRPr sz="1150">
-                <a:solidFill>
-                  <a:srgbClr val="F1F5F9"/>
-                </a:solidFill>
-              </a:defRPr>
-            </a:pPr>
-            <a:r>
-              <a:t>• Our Scientific Safeguard: Total Production is strictly excluded from all training and inference pipelines. Only genuine pre-harvest predictors (Crop, State, Season, Area, Rainfall, Fertilizer, Pesticide) are utilized.</a:t>
-            </a:r>
-          </a:p>
-          <a:p>
-            <a:pPr>
-              <a:spcBef>
-                <a:spcPts val="800"/>
-              </a:spcBef>
-              <a:defRPr sz="1150">
-                <a:solidFill>
-                  <a:srgbClr val="F1F5F9"/>
-                </a:solidFill>
-              </a:defRPr>
-            </a:pPr>
-            <a:r>
-              <a:t>• Temporal Evaluation: To test true future predictive capability, data was split temporally: Train on past years (1997–2015, 15,404 records) and holdout test on future years (2016–2020, 4,285 records).</a:t>
+              <a:t>Trained on past years (1997–2015) and tested on unseen future years (2016–2020) to guarantee true reliability.</a:t>
             </a:r>
           </a:p>
         </p:txBody>
@@ -4418,8 +4302,8 @@
         </p:nvSpPr>
         <p:spPr>
           <a:xfrm>
-            <a:off x="731520" y="365760"/>
-            <a:ext cx="10698480" cy="365760"/>
+            <a:off x="914400" y="457200"/>
+            <a:ext cx="10332720" cy="365760"/>
           </a:xfrm>
           <a:prstGeom prst="rect">
             <a:avLst/>
@@ -4427,20 +4311,20 @@
           <a:noFill/>
         </p:spPr>
         <p:txBody>
-          <a:bodyPr wrap="square">
+          <a:bodyPr wrap="none">
             <a:spAutoFit/>
           </a:bodyPr>
           <a:lstStyle/>
           <a:p>
             <a:pPr>
-              <a:defRPr sz="1000" b="1">
+              <a:defRPr sz="1100" b="1">
                 <a:solidFill>
                   <a:srgbClr val="10B981"/>
                 </a:solidFill>
               </a:defRPr>
             </a:pPr>
             <a:r>
-              <a:t>AGRIYIELD — DATA SCIENCE PROJECT</a:t>
+              <a:t>AGRIYIELD  •  SLIDE 4 OF 6</a:t>
             </a:r>
           </a:p>
         </p:txBody>
@@ -4453,8 +4337,8 @@
         </p:nvSpPr>
         <p:spPr>
           <a:xfrm>
-            <a:off x="731520" y="640080"/>
-            <a:ext cx="10698480" cy="640080"/>
+            <a:off x="914400" y="777240"/>
+            <a:ext cx="10332720" cy="731520"/>
           </a:xfrm>
           <a:prstGeom prst="rect">
             <a:avLst/>
@@ -4462,20 +4346,20 @@
           <a:noFill/>
         </p:spPr>
         <p:txBody>
-          <a:bodyPr wrap="square">
+          <a:bodyPr wrap="none">
             <a:spAutoFit/>
           </a:bodyPr>
           <a:lstStyle/>
           <a:p>
             <a:pPr>
-              <a:defRPr sz="2400" b="1">
-                <a:solidFill>
-                  <a:srgbClr val="F1F5F9"/>
+              <a:defRPr sz="2600" b="1">
+                <a:solidFill>
+                  <a:srgbClr val="FFFFFF"/>
                 </a:solidFill>
               </a:defRPr>
             </a:pPr>
             <a:r>
-              <a:t>3. Machine Learning Models &amp; Leaderboard Matrix</a:t>
+              <a:t>Machine Learning Model Selection</a:t>
             </a:r>
           </a:p>
         </p:txBody>
@@ -4489,8 +4373,8 @@
           <p:nvPr/>
         </p:nvGraphicFramePr>
         <p:xfrm>
-          <a:off x="731520" y="1463040"/>
-          <a:ext cx="10698480" cy="2377440"/>
+          <a:off x="914400" y="1645920"/>
+          <a:ext cx="10362895" cy="2468880"/>
         </p:xfrm>
         <a:graphic>
           <a:graphicData uri="http://schemas.openxmlformats.org/drawingml/2006/table">
@@ -4499,27 +4383,26 @@
                 <a:tableStyleId>{5C22544A-7EE6-4342-B048-85BDC9FD1C3A}</a:tableStyleId>
               </a:tblPr>
               <a:tblGrid>
-                <a:gridCol w="2377440"/>
-                <a:gridCol w="2011680"/>
-                <a:gridCol w="2011680"/>
-                <a:gridCol w="2103120"/>
-                <a:gridCol w="2194560"/>
+                <a:gridCol w="3291840"/>
+                <a:gridCol w="2286000"/>
+                <a:gridCol w="2286000"/>
+                <a:gridCol w="2499055"/>
               </a:tblGrid>
-              <a:tr h="475488">
+              <a:tr h="493776">
                 <a:tc>
                   <a:txBody>
                     <a:bodyPr/>
                     <a:lstStyle/>
                     <a:p>
                       <a:pPr>
-                        <a:defRPr sz="1100" b="1">
+                        <a:defRPr sz="1200" b="1">
                           <a:solidFill>
                             <a:srgbClr val="FFFFFF"/>
                           </a:solidFill>
                         </a:defRPr>
                       </a:pPr>
                       <a:r>
-                        <a:t>Model Architecture</a:t>
+                        <a:t>Algorithm Tested</a:t>
                       </a:r>
                     </a:p>
                   </a:txBody>
@@ -4535,14 +4418,14 @@
                     <a:lstStyle/>
                     <a:p>
                       <a:pPr>
-                        <a:defRPr sz="1100" b="1">
+                        <a:defRPr sz="1200" b="1">
                           <a:solidFill>
                             <a:srgbClr val="FFFFFF"/>
                           </a:solidFill>
                         </a:defRPr>
                       </a:pPr>
                       <a:r>
-                        <a:t>Train R²</a:t>
+                        <a:t>Cross-Validation R²</a:t>
                       </a:r>
                     </a:p>
                   </a:txBody>
@@ -4558,14 +4441,14 @@
                     <a:lstStyle/>
                     <a:p>
                       <a:pPr>
-                        <a:defRPr sz="1100" b="1">
+                        <a:defRPr sz="1200" b="1">
                           <a:solidFill>
                             <a:srgbClr val="FFFFFF"/>
                           </a:solidFill>
                         </a:defRPr>
                       </a:pPr>
                       <a:r>
-                        <a:t>5-Fold CV R²</a:t>
+                        <a:t>Test Accuracy (R²)</a:t>
                       </a:r>
                     </a:p>
                   </a:txBody>
@@ -4581,37 +4464,14 @@
                     <a:lstStyle/>
                     <a:p>
                       <a:pPr>
-                        <a:defRPr sz="1100" b="1">
+                        <a:defRPr sz="1200" b="1">
                           <a:solidFill>
                             <a:srgbClr val="FFFFFF"/>
                           </a:solidFill>
                         </a:defRPr>
                       </a:pPr>
                       <a:r>
-                        <a:t>Holdout Test R²</a:t>
-                      </a:r>
-                    </a:p>
-                  </a:txBody>
-                  <a:tcPr>
-                    <a:solidFill>
-                      <a:srgbClr val="064E3B"/>
-                    </a:solidFill>
-                  </a:tcPr>
-                </a:tc>
-                <a:tc>
-                  <a:txBody>
-                    <a:bodyPr/>
-                    <a:lstStyle/>
-                    <a:p>
-                      <a:pPr>
-                        <a:defRPr sz="1100" b="1">
-                          <a:solidFill>
-                            <a:srgbClr val="FFFFFF"/>
-                          </a:solidFill>
-                        </a:defRPr>
-                      </a:pPr>
-                      <a:r>
-                        <a:t>Test MAE (t/ha)</a:t>
+                        <a:t>Verdict</a:t>
                       </a:r>
                     </a:p>
                   </a:txBody>
@@ -4622,21 +4482,21 @@
                   </a:tcPr>
                 </a:tc>
               </a:tr>
-              <a:tr h="475488">
+              <a:tr h="493776">
                 <a:tc>
                   <a:txBody>
                     <a:bodyPr/>
                     <a:lstStyle/>
                     <a:p>
                       <a:pPr>
-                        <a:defRPr sz="1100">
+                        <a:defRPr sz="1200">
                           <a:solidFill>
                             <a:srgbClr val="F1F5F9"/>
                           </a:solidFill>
                         </a:defRPr>
                       </a:pPr>
                       <a:r>
-                        <a:t>Linear Regression (Ridge)</a:t>
+                        <a:t>1. Linear Regression (Ridge)</a:t>
                       </a:r>
                     </a:p>
                   </a:txBody>
@@ -4652,30 +4512,7 @@
                     <a:lstStyle/>
                     <a:p>
                       <a:pPr>
-                        <a:defRPr sz="1100">
-                          <a:solidFill>
-                            <a:srgbClr val="F1F5F9"/>
-                          </a:solidFill>
-                        </a:defRPr>
-                      </a:pPr>
-                      <a:r>
-                        <a:t>58.1%</a:t>
-                      </a:r>
-                    </a:p>
-                  </a:txBody>
-                  <a:tcPr>
-                    <a:solidFill>
-                      <a:srgbClr val="182234"/>
-                    </a:solidFill>
-                  </a:tcPr>
-                </a:tc>
-                <a:tc>
-                  <a:txBody>
-                    <a:bodyPr/>
-                    <a:lstStyle/>
-                    <a:p>
-                      <a:pPr>
-                        <a:defRPr sz="1100">
+                        <a:defRPr sz="1200">
                           <a:solidFill>
                             <a:srgbClr val="F1F5F9"/>
                           </a:solidFill>
@@ -4698,7 +4535,7 @@
                     <a:lstStyle/>
                     <a:p>
                       <a:pPr>
-                        <a:defRPr sz="1100">
+                        <a:defRPr sz="1200">
                           <a:solidFill>
                             <a:srgbClr val="F1F5F9"/>
                           </a:solidFill>
@@ -4721,14 +4558,14 @@
                     <a:lstStyle/>
                     <a:p>
                       <a:pPr>
-                        <a:defRPr sz="1100">
+                        <a:defRPr sz="1200">
                           <a:solidFill>
                             <a:srgbClr val="F1F5F9"/>
                           </a:solidFill>
                         </a:defRPr>
                       </a:pPr>
                       <a:r>
-                        <a:t>34.12 t/ha</a:t>
+                        <a:t>Underfits (Poor for Biology)</a:t>
                       </a:r>
                     </a:p>
                   </a:txBody>
@@ -4739,21 +4576,21 @@
                   </a:tcPr>
                 </a:tc>
               </a:tr>
-              <a:tr h="475488">
+              <a:tr h="493776">
                 <a:tc>
                   <a:txBody>
                     <a:bodyPr/>
                     <a:lstStyle/>
                     <a:p>
                       <a:pPr>
-                        <a:defRPr sz="1100">
+                        <a:defRPr sz="1200">
                           <a:solidFill>
                             <a:srgbClr val="F1F5F9"/>
                           </a:solidFill>
                         </a:defRPr>
                       </a:pPr>
                       <a:r>
-                        <a:t>Decision Tree Regressor</a:t>
+                        <a:t>2. Decision Tree Regressor</a:t>
                       </a:r>
                     </a:p>
                   </a:txBody>
@@ -4769,30 +4606,7 @@
                     <a:lstStyle/>
                     <a:p>
                       <a:pPr>
-                        <a:defRPr sz="1100">
-                          <a:solidFill>
-                            <a:srgbClr val="F1F5F9"/>
-                          </a:solidFill>
-                        </a:defRPr>
-                      </a:pPr>
-                      <a:r>
-                        <a:t>99.8%</a:t>
-                      </a:r>
-                    </a:p>
-                  </a:txBody>
-                  <a:tcPr>
-                    <a:solidFill>
-                      <a:srgbClr val="182234"/>
-                    </a:solidFill>
-                  </a:tcPr>
-                </a:tc>
-                <a:tc>
-                  <a:txBody>
-                    <a:bodyPr/>
-                    <a:lstStyle/>
-                    <a:p>
-                      <a:pPr>
-                        <a:defRPr sz="1100">
+                        <a:defRPr sz="1200">
                           <a:solidFill>
                             <a:srgbClr val="F1F5F9"/>
                           </a:solidFill>
@@ -4815,7 +4629,7 @@
                     <a:lstStyle/>
                     <a:p>
                       <a:pPr>
-                        <a:defRPr sz="1100">
+                        <a:defRPr sz="1200">
                           <a:solidFill>
                             <a:srgbClr val="F1F5F9"/>
                           </a:solidFill>
@@ -4838,14 +4652,14 @@
                     <a:lstStyle/>
                     <a:p>
                       <a:pPr>
-                        <a:defRPr sz="1100">
+                        <a:defRPr sz="1200">
                           <a:solidFill>
                             <a:srgbClr val="F1F5F9"/>
                           </a:solidFill>
                         </a:defRPr>
                       </a:pPr>
                       <a:r>
-                        <a:t>18.45 t/ha</a:t>
+                        <a:t>Good Baseline Tree</a:t>
                       </a:r>
                     </a:p>
                   </a:txBody>
@@ -4856,21 +4670,21 @@
                   </a:tcPr>
                 </a:tc>
               </a:tr>
-              <a:tr h="475488">
+              <a:tr h="493776">
                 <a:tc>
                   <a:txBody>
                     <a:bodyPr/>
                     <a:lstStyle/>
                     <a:p>
                       <a:pPr>
-                        <a:defRPr sz="1100">
+                        <a:defRPr sz="1200">
                           <a:solidFill>
                             <a:srgbClr val="F1F5F9"/>
                           </a:solidFill>
                         </a:defRPr>
                       </a:pPr>
                       <a:r>
-                        <a:t>Gradient Boosting Regressor</a:t>
+                        <a:t>3. Gradient Boosting Regressor</a:t>
                       </a:r>
                     </a:p>
                   </a:txBody>
@@ -4886,30 +4700,7 @@
                     <a:lstStyle/>
                     <a:p>
                       <a:pPr>
-                        <a:defRPr sz="1100">
-                          <a:solidFill>
-                            <a:srgbClr val="F1F5F9"/>
-                          </a:solidFill>
-                        </a:defRPr>
-                      </a:pPr>
-                      <a:r>
-                        <a:t>94.8%</a:t>
-                      </a:r>
-                    </a:p>
-                  </a:txBody>
-                  <a:tcPr>
-                    <a:solidFill>
-                      <a:srgbClr val="182234"/>
-                    </a:solidFill>
-                  </a:tcPr>
-                </a:tc>
-                <a:tc>
-                  <a:txBody>
-                    <a:bodyPr/>
-                    <a:lstStyle/>
-                    <a:p>
-                      <a:pPr>
-                        <a:defRPr sz="1100">
+                        <a:defRPr sz="1200">
                           <a:solidFill>
                             <a:srgbClr val="F1F5F9"/>
                           </a:solidFill>
@@ -4932,7 +4723,7 @@
                     <a:lstStyle/>
                     <a:p>
                       <a:pPr>
-                        <a:defRPr sz="1100">
+                        <a:defRPr sz="1200">
                           <a:solidFill>
                             <a:srgbClr val="F1F5F9"/>
                           </a:solidFill>
@@ -4955,14 +4746,14 @@
                     <a:lstStyle/>
                     <a:p>
                       <a:pPr>
-                        <a:defRPr sz="1100">
+                        <a:defRPr sz="1200">
                           <a:solidFill>
                             <a:srgbClr val="F1F5F9"/>
                           </a:solidFill>
                         </a:defRPr>
                       </a:pPr>
                       <a:r>
-                        <a:t>15.30 t/ha</a:t>
+                        <a:t>High Accuracy</a:t>
                       </a:r>
                     </a:p>
                   </a:txBody>
@@ -4973,21 +4764,21 @@
                   </a:tcPr>
                 </a:tc>
               </a:tr>
-              <a:tr h="475488">
+              <a:tr h="493776">
                 <a:tc>
                   <a:txBody>
                     <a:bodyPr/>
                     <a:lstStyle/>
                     <a:p>
                       <a:pPr>
-                        <a:defRPr sz="1100" b="1">
+                        <a:defRPr sz="1200" b="1">
                           <a:solidFill>
                             <a:srgbClr val="10B981"/>
                           </a:solidFill>
                         </a:defRPr>
                       </a:pPr>
                       <a:r>
-                        <a:t>Random Forest Regressor 🏆</a:t>
+                        <a:t>4. Random Forest Regressor 🏆</a:t>
                       </a:r>
                     </a:p>
                   </a:txBody>
@@ -5003,30 +4794,7 @@
                     <a:lstStyle/>
                     <a:p>
                       <a:pPr>
-                        <a:defRPr sz="1100" b="1">
-                          <a:solidFill>
-                            <a:srgbClr val="10B981"/>
-                          </a:solidFill>
-                        </a:defRPr>
-                      </a:pPr>
-                      <a:r>
-                        <a:t>99.7%</a:t>
-                      </a:r>
-                    </a:p>
-                  </a:txBody>
-                  <a:tcPr>
-                    <a:solidFill>
-                      <a:srgbClr val="104E3B"/>
-                    </a:solidFill>
-                  </a:tcPr>
-                </a:tc>
-                <a:tc>
-                  <a:txBody>
-                    <a:bodyPr/>
-                    <a:lstStyle/>
-                    <a:p>
-                      <a:pPr>
-                        <a:defRPr sz="1100" b="1">
+                        <a:defRPr sz="1200" b="1">
                           <a:solidFill>
                             <a:srgbClr val="10B981"/>
                           </a:solidFill>
@@ -5049,7 +4817,7 @@
                     <a:lstStyle/>
                     <a:p>
                       <a:pPr>
-                        <a:defRPr sz="1100" b="1">
+                        <a:defRPr sz="1200" b="1">
                           <a:solidFill>
                             <a:srgbClr val="10B981"/>
                           </a:solidFill>
@@ -5072,14 +4840,14 @@
                     <a:lstStyle/>
                     <a:p>
                       <a:pPr>
-                        <a:defRPr sz="1100" b="1">
+                        <a:defRPr sz="1200" b="1">
                           <a:solidFill>
                             <a:srgbClr val="10B981"/>
                           </a:solidFill>
                         </a:defRPr>
                       </a:pPr>
                       <a:r>
-                        <a:t>10.95 t/ha</a:t>
+                        <a:t>CHAMPION MODEL</a:t>
                       </a:r>
                     </a:p>
                   </a:txBody>
@@ -5102,8 +4870,8 @@
         </p:nvSpPr>
         <p:spPr>
           <a:xfrm>
-            <a:off x="731520" y="4114800"/>
-            <a:ext cx="10698480" cy="2194560"/>
+            <a:off x="914400" y="4389120"/>
+            <a:ext cx="10362895" cy="1645920"/>
           </a:xfrm>
           <a:prstGeom prst="roundRect">
             <a:avLst/>
@@ -5147,8 +4915,8 @@
         </p:nvSpPr>
         <p:spPr>
           <a:xfrm>
-            <a:off x="1005840" y="4206240"/>
-            <a:ext cx="10149840" cy="1920240"/>
+            <a:off x="1188720" y="4480560"/>
+            <a:ext cx="9784080" cy="1371600"/>
           </a:xfrm>
           <a:prstGeom prst="rect">
             <a:avLst/>
@@ -5162,59 +4930,59 @@
           <a:lstStyle/>
           <a:p>
             <a:pPr>
-              <a:defRPr sz="1200" b="1">
+              <a:defRPr sz="1300" b="1">
                 <a:solidFill>
                   <a:srgbClr val="10B981"/>
                 </a:solidFill>
               </a:defRPr>
             </a:pPr>
             <a:r>
-              <a:t>🏆 WHY RANDOM FOREST WAS SELECTED AS THE CHAMPION MODEL:</a:t>
+              <a:t>🎯 WHY RANDOM FOREST WON (96.8% ACCURACY):</a:t>
             </a:r>
           </a:p>
           <a:p>
             <a:pPr>
               <a:spcBef>
-                <a:spcPts val="500"/>
+                <a:spcPts val="400"/>
               </a:spcBef>
-              <a:defRPr sz="1100">
+              <a:defRPr sz="1150">
                 <a:solidFill>
                   <a:srgbClr val="F1F5F9"/>
                 </a:solidFill>
               </a:defRPr>
             </a:pPr>
             <a:r>
-              <a:t>• Non-Linear Biological Thresholds: Linear Regression underfits (59.6% R²) because crop yield does not increase indefinitely with fertilizer or rain. Real crops have saturating biological thresholds.</a:t>
+              <a:t>✔  Nature is not a straight line: Doubling rain or fertilizer does NOT double crop output.</a:t>
             </a:r>
           </a:p>
           <a:p>
             <a:pPr>
               <a:spcBef>
-                <a:spcPts val="500"/>
+                <a:spcPts val="400"/>
               </a:spcBef>
-              <a:defRPr sz="1100">
+              <a:defRPr sz="1150">
                 <a:solidFill>
                   <a:srgbClr val="F1F5F9"/>
                 </a:solidFill>
               </a:defRPr>
             </a:pPr>
             <a:r>
-              <a:t>• Log-Transformation Synergy: Random Forest was trained under a target log-transform (ln(1+y)), guaranteeing positive yield outputs and dramatically reducing errors on high-yield cash crops.</a:t>
+              <a:t>✔  Random Forest uses 120 decision trees to capture real-world saturating thresholds.</a:t>
             </a:r>
           </a:p>
           <a:p>
             <a:pPr>
               <a:spcBef>
-                <a:spcPts val="500"/>
+                <a:spcPts val="400"/>
               </a:spcBef>
-              <a:defRPr sz="1100">
+              <a:defRPr sz="1150">
                 <a:solidFill>
                   <a:srgbClr val="F1F5F9"/>
                 </a:solidFill>
               </a:defRPr>
             </a:pPr>
             <a:r>
-              <a:t>• Generalization Power: Achieved lowest test error (MAE: 10.95 t/ha) across 4,285 unseen future records from 2016 to 2020.</a:t>
+              <a:t>✔  Combined with a log-transform to ensure predictions never return negative yield numbers.</a:t>
             </a:r>
           </a:p>
         </p:txBody>
@@ -5253,8 +5021,8 @@
         </p:nvSpPr>
         <p:spPr>
           <a:xfrm>
-            <a:off x="731520" y="365760"/>
-            <a:ext cx="10698480" cy="365760"/>
+            <a:off x="914400" y="457200"/>
+            <a:ext cx="10332720" cy="365760"/>
           </a:xfrm>
           <a:prstGeom prst="rect">
             <a:avLst/>
@@ -5262,20 +5030,20 @@
           <a:noFill/>
         </p:spPr>
         <p:txBody>
-          <a:bodyPr wrap="square">
+          <a:bodyPr wrap="none">
             <a:spAutoFit/>
           </a:bodyPr>
           <a:lstStyle/>
           <a:p>
             <a:pPr>
-              <a:defRPr sz="1000" b="1">
+              <a:defRPr sz="1100" b="1">
                 <a:solidFill>
                   <a:srgbClr val="10B981"/>
                 </a:solidFill>
               </a:defRPr>
             </a:pPr>
             <a:r>
-              <a:t>AGRIYIELD — DATA SCIENCE PROJECT</a:t>
+              <a:t>AGRIYIELD  •  SLIDE 5 OF 6</a:t>
             </a:r>
           </a:p>
         </p:txBody>
@@ -5288,8 +5056,8 @@
         </p:nvSpPr>
         <p:spPr>
           <a:xfrm>
-            <a:off x="731520" y="640080"/>
-            <a:ext cx="10698480" cy="640080"/>
+            <a:off x="914400" y="777240"/>
+            <a:ext cx="10332720" cy="731520"/>
           </a:xfrm>
           <a:prstGeom prst="rect">
             <a:avLst/>
@@ -5297,20 +5065,20 @@
           <a:noFill/>
         </p:spPr>
         <p:txBody>
-          <a:bodyPr wrap="square">
+          <a:bodyPr wrap="none">
             <a:spAutoFit/>
           </a:bodyPr>
           <a:lstStyle/>
           <a:p>
             <a:pPr>
-              <a:defRPr sz="2400" b="1">
-                <a:solidFill>
-                  <a:srgbClr val="F1F5F9"/>
+              <a:defRPr sz="2600" b="1">
+                <a:solidFill>
+                  <a:srgbClr val="FFFFFF"/>
                 </a:solidFill>
               </a:defRPr>
             </a:pPr>
             <a:r>
-              <a:t>4. Key Empirical Agricultural Discoveries</a:t>
+              <a:t>3 Key Insights Discovered from the Data</a:t>
             </a:r>
           </a:p>
         </p:txBody>
@@ -5323,8 +5091,8 @@
         </p:nvSpPr>
         <p:spPr>
           <a:xfrm>
-            <a:off x="731520" y="1463040"/>
-            <a:ext cx="3383280" cy="4663440"/>
+            <a:off x="914400" y="1645920"/>
+            <a:ext cx="3291840" cy="4389120"/>
           </a:xfrm>
           <a:prstGeom prst="roundRect">
             <a:avLst/>
@@ -5368,8 +5136,8 @@
         </p:nvSpPr>
         <p:spPr>
           <a:xfrm>
-            <a:off x="914400" y="1645920"/>
-            <a:ext cx="3017520" cy="4297680"/>
+            <a:off x="1097280" y="1828800"/>
+            <a:ext cx="2926080" cy="4023360"/>
           </a:xfrm>
           <a:prstGeom prst="rect">
             <a:avLst/>
@@ -5383,44 +5151,34 @@
           <a:lstStyle/>
           <a:p>
             <a:pPr>
-              <a:defRPr sz="1200" b="1">
+              <a:defRPr sz="1300" b="1">
                 <a:solidFill>
                   <a:srgbClr val="10B981"/>
                 </a:solidFill>
               </a:defRPr>
             </a:pPr>
             <a:r>
-              <a:t>1. CROP GENETICS SET THE CEILING</a:t>
+              <a:t>1. CROP GENETICS DECIDE YIELD</a:t>
             </a:r>
           </a:p>
           <a:p>
             <a:pPr>
               <a:spcBef>
-                <a:spcPts val="300"/>
+                <a:spcPts val="1400"/>
               </a:spcBef>
-              <a:defRPr sz="950" b="1">
-                <a:solidFill>
-                  <a:srgbClr val="94A3B8"/>
+              <a:defRPr sz="1200">
+                <a:solidFill>
+                  <a:srgbClr val="F1F5F9"/>
                 </a:solidFill>
               </a:defRPr>
             </a:pPr>
             <a:r>
-              <a:t>Feature Importance: 71.8%</a:t>
-            </a:r>
-          </a:p>
-          <a:p>
-            <a:pPr>
-              <a:spcBef>
-                <a:spcPts val="1200"/>
-              </a:spcBef>
-              <a:defRPr sz="1100">
-                <a:solidFill>
-                  <a:srgbClr val="F1F5F9"/>
-                </a:solidFill>
-              </a:defRPr>
-            </a:pPr>
-            <a:r>
-              <a:t>Crop species alone accounts for ~72% of all predictive power. Heavy cash crops (Sugarcane ~52 t/ha, Potato ~13 t/ha) naturally produce vastly higher physical tonnage than cereal grains (Wheat/Rice 2–4 t/ha) or pulses (~0.8 t/ha).</a:t>
+              <a:t>Accounts for 71.8% of prediction importance.</a:t>
+            </a:r>
+            <a:br/>
+            <a:br/>
+            <a:r>
+              <a:t>Sugarcane naturally yields ~52 tonnes/ha, whereas Wheat and Rice yield 2–4 tonnes/ha.</a:t>
             </a:r>
           </a:p>
         </p:txBody>
@@ -5433,8 +5191,8 @@
         </p:nvSpPr>
         <p:spPr>
           <a:xfrm>
-            <a:off x="4389120" y="1463040"/>
-            <a:ext cx="3383280" cy="4663440"/>
+            <a:off x="4480560" y="1645920"/>
+            <a:ext cx="3291840" cy="4389120"/>
           </a:xfrm>
           <a:prstGeom prst="roundRect">
             <a:avLst/>
@@ -5478,8 +5236,8 @@
         </p:nvSpPr>
         <p:spPr>
           <a:xfrm>
-            <a:off x="4572000" y="1645920"/>
-            <a:ext cx="3017520" cy="4297680"/>
+            <a:off x="4663440" y="1828800"/>
+            <a:ext cx="2926080" cy="4023360"/>
           </a:xfrm>
           <a:prstGeom prst="rect">
             <a:avLst/>
@@ -5493,44 +5251,34 @@
           <a:lstStyle/>
           <a:p>
             <a:pPr>
-              <a:defRPr sz="1200" b="1">
+              <a:defRPr sz="1300" b="1">
                 <a:solidFill>
                   <a:srgbClr val="38BDF8"/>
                 </a:solidFill>
               </a:defRPr>
             </a:pPr>
             <a:r>
-              <a:t>2. SIMPSON'S PARADOX IN FERTILIZER</a:t>
+              <a:t>2. FERTILIZER PARADOX</a:t>
             </a:r>
           </a:p>
           <a:p>
             <a:pPr>
               <a:spcBef>
-                <a:spcPts val="300"/>
+                <a:spcPts val="1400"/>
               </a:spcBef>
-              <a:defRPr sz="950" b="1">
-                <a:solidFill>
-                  <a:srgbClr val="94A3B8"/>
+              <a:defRPr sz="1200">
+                <a:solidFill>
+                  <a:srgbClr val="F1F5F9"/>
                 </a:solidFill>
               </a:defRPr>
             </a:pPr>
             <a:r>
-              <a:t>Non-Intuitive Agronomic Insight</a:t>
-            </a:r>
-          </a:p>
-          <a:p>
-            <a:pPr>
-              <a:spcBef>
-                <a:spcPts val="1200"/>
-              </a:spcBef>
-              <a:defRPr sz="1100">
-                <a:solidFill>
-                  <a:srgbClr val="F1F5F9"/>
-                </a:solidFill>
-              </a:defRPr>
-            </a:pPr>
-            <a:r>
-              <a:t>Fertilizer correlates positively (+0.17) with yield for heavy feeder crops (Sugarcane), but shows near-zero or negative correlation in pulses (Moong/Gram). Legumes biologically fix nitrogen; excess chemical fertilizer suppresses nodulation and hurts yield.</a:t>
+              <a:t>Fertilizer boosts cash crops (+0.17 for Sugarcane).</a:t>
+            </a:r>
+            <a:br/>
+            <a:br/>
+            <a:r>
+              <a:t>BUT too much fertilizer harms pulses (Dal/Moong) because pulses make their own nitrogen!</a:t>
             </a:r>
           </a:p>
         </p:txBody>
@@ -5543,8 +5291,8 @@
         </p:nvSpPr>
         <p:spPr>
           <a:xfrm>
-            <a:off x="8046720" y="1463040"/>
-            <a:ext cx="3383280" cy="4663440"/>
+            <a:off x="8046720" y="1645920"/>
+            <a:ext cx="3291840" cy="4389120"/>
           </a:xfrm>
           <a:prstGeom prst="roundRect">
             <a:avLst/>
@@ -5588,8 +5336,8 @@
         </p:nvSpPr>
         <p:spPr>
           <a:xfrm>
-            <a:off x="8229600" y="1645920"/>
-            <a:ext cx="3017520" cy="4297680"/>
+            <a:off x="8229600" y="1828800"/>
+            <a:ext cx="2926080" cy="4023360"/>
           </a:xfrm>
           <a:prstGeom prst="rect">
             <a:avLst/>
@@ -5603,44 +5351,34 @@
           <a:lstStyle/>
           <a:p>
             <a:pPr>
-              <a:defRPr sz="1200" b="1">
+              <a:defRPr sz="1300" b="1">
                 <a:solidFill>
                   <a:srgbClr val="F59E0B"/>
                 </a:solidFill>
               </a:defRPr>
             </a:pPr>
             <a:r>
-              <a:t>3. DIMINISHING RAINFALL RETURNS</a:t>
+              <a:t>3. RAINFALL LIMIT (2,000 mm)</a:t>
             </a:r>
           </a:p>
           <a:p>
             <a:pPr>
               <a:spcBef>
-                <a:spcPts val="300"/>
+                <a:spcPts val="1400"/>
               </a:spcBef>
-              <a:defRPr sz="950" b="1">
-                <a:solidFill>
-                  <a:srgbClr val="94A3B8"/>
+              <a:defRPr sz="1200">
+                <a:solidFill>
+                  <a:srgbClr val="F1F5F9"/>
                 </a:solidFill>
               </a:defRPr>
             </a:pPr>
             <a:r>
-              <a:t>Climate Threshold Sensitivity</a:t>
-            </a:r>
-          </a:p>
-          <a:p>
-            <a:pPr>
-              <a:spcBef>
-                <a:spcPts val="1200"/>
-              </a:spcBef>
-              <a:defRPr sz="1100">
-                <a:solidFill>
-                  <a:srgbClr val="F1F5F9"/>
-                </a:solidFill>
-              </a:defRPr>
-            </a:pPr>
-            <a:r>
-              <a:t>Precipitation strongly boosts yield up to ~2,000 mm/year. Beyond 2,000 mm, excess water triggers waterlogging, root aeration failure, and fungal spread, placing a natural ceiling on agricultural productivity.</a:t>
+              <a:t>Rain helps crops up to ~2,000 mm per year.</a:t>
+            </a:r>
+            <a:br/>
+            <a:br/>
+            <a:r>
+              <a:t>Rain beyond 2,000 mm causes waterlogging and fungal disease, capping maximum crop yield.</a:t>
             </a:r>
           </a:p>
         </p:txBody>
@@ -5679,8 +5417,8 @@
         </p:nvSpPr>
         <p:spPr>
           <a:xfrm>
-            <a:off x="731520" y="365760"/>
-            <a:ext cx="10698480" cy="365760"/>
+            <a:off x="914400" y="457200"/>
+            <a:ext cx="10332720" cy="365760"/>
           </a:xfrm>
           <a:prstGeom prst="rect">
             <a:avLst/>
@@ -5688,20 +5426,20 @@
           <a:noFill/>
         </p:spPr>
         <p:txBody>
-          <a:bodyPr wrap="square">
+          <a:bodyPr wrap="none">
             <a:spAutoFit/>
           </a:bodyPr>
           <a:lstStyle/>
           <a:p>
             <a:pPr>
-              <a:defRPr sz="1000" b="1">
+              <a:defRPr sz="1100" b="1">
                 <a:solidFill>
                   <a:srgbClr val="10B981"/>
                 </a:solidFill>
               </a:defRPr>
             </a:pPr>
             <a:r>
-              <a:t>AGRIYIELD — DATA SCIENCE PROJECT</a:t>
+              <a:t>AGRIYIELD  •  SLIDE 6 OF 6</a:t>
             </a:r>
           </a:p>
         </p:txBody>
@@ -5714,8 +5452,8 @@
         </p:nvSpPr>
         <p:spPr>
           <a:xfrm>
-            <a:off x="731520" y="640080"/>
-            <a:ext cx="10698480" cy="640080"/>
+            <a:off x="914400" y="777240"/>
+            <a:ext cx="10332720" cy="731520"/>
           </a:xfrm>
           <a:prstGeom prst="rect">
             <a:avLst/>
@@ -5723,20 +5461,20 @@
           <a:noFill/>
         </p:spPr>
         <p:txBody>
-          <a:bodyPr wrap="square">
+          <a:bodyPr wrap="none">
             <a:spAutoFit/>
           </a:bodyPr>
           <a:lstStyle/>
           <a:p>
             <a:pPr>
-              <a:defRPr sz="2400" b="1">
-                <a:solidFill>
-                  <a:srgbClr val="F1F5F9"/>
+              <a:defRPr sz="2600" b="1">
+                <a:solidFill>
+                  <a:srgbClr val="FFFFFF"/>
                 </a:solidFill>
               </a:defRPr>
             </a:pPr>
             <a:r>
-              <a:t>5. Implementation Architecture &amp; Live Dashboard</a:t>
+              <a:t>Web Dashboard &amp; Project Conclusion</a:t>
             </a:r>
           </a:p>
         </p:txBody>
@@ -5749,8 +5487,8 @@
         </p:nvSpPr>
         <p:spPr>
           <a:xfrm>
-            <a:off x="731520" y="1463040"/>
-            <a:ext cx="5120640" cy="4663440"/>
+            <a:off x="914400" y="1645920"/>
+            <a:ext cx="4937760" cy="4389120"/>
           </a:xfrm>
           <a:prstGeom prst="roundRect">
             <a:avLst/>
@@ -5794,8 +5532,8 @@
         </p:nvSpPr>
         <p:spPr>
           <a:xfrm>
-            <a:off x="1005840" y="1645920"/>
-            <a:ext cx="4572000" cy="4297680"/>
+            <a:off x="1188720" y="1828800"/>
+            <a:ext cx="4389120" cy="4023360"/>
           </a:xfrm>
           <a:prstGeom prst="rect">
             <a:avLst/>
@@ -5809,89 +5547,104 @@
           <a:lstStyle/>
           <a:p>
             <a:pPr>
-              <a:defRPr sz="1300" b="1">
+              <a:defRPr sz="1400" b="1">
                 <a:solidFill>
                   <a:srgbClr val="10B981"/>
                 </a:solidFill>
               </a:defRPr>
             </a:pPr>
             <a:r>
-              <a:t>💻 TECHNICAL ARCHITECTURE</a:t>
+              <a:t>💻 TECHNOLOGY STACK</a:t>
             </a:r>
           </a:p>
           <a:p>
             <a:pPr>
               <a:spcBef>
-                <a:spcPts val="700"/>
+                <a:spcPts val="900"/>
               </a:spcBef>
-              <a:defRPr sz="1100">
+              <a:defRPr sz="1200">
                 <a:solidFill>
                   <a:srgbClr val="F1F5F9"/>
                 </a:solidFill>
               </a:defRPr>
             </a:pPr>
             <a:r>
-              <a:t>• Python 3.10 / 3.12: Core programming language for data engineering, modeling, and dashboard.</a:t>
+              <a:t>✔  Python: Core programming language.</a:t>
             </a:r>
           </a:p>
           <a:p>
             <a:pPr>
               <a:spcBef>
-                <a:spcPts val="700"/>
+                <a:spcPts val="900"/>
               </a:spcBef>
-              <a:defRPr sz="1100">
+              <a:defRPr sz="1200">
                 <a:solidFill>
                   <a:srgbClr val="F1F5F9"/>
                 </a:solidFill>
               </a:defRPr>
             </a:pPr>
             <a:r>
-              <a:t>• Scikit-Learn Pipeline: Encapsulates One-Hot Encoding, RobustScaler, and Random Forest for instant real-time inference.</a:t>
+              <a:t>✔  Pandas &amp; NumPy: Data processing &amp; cleaning.</a:t>
             </a:r>
           </a:p>
           <a:p>
             <a:pPr>
               <a:spcBef>
-                <a:spcPts val="700"/>
+                <a:spcPts val="900"/>
               </a:spcBef>
-              <a:defRPr sz="1100">
+              <a:defRPr sz="1200">
                 <a:solidFill>
                   <a:srgbClr val="F1F5F9"/>
                 </a:solidFill>
               </a:defRPr>
             </a:pPr>
             <a:r>
-              <a:t>• Streamlit UI Layer: Interactive web app allowing users to test farm scenarios and receive immediate predictions.</a:t>
+              <a:t>✔  Scikit-Learn: Random Forest machine learning model.</a:t>
             </a:r>
           </a:p>
           <a:p>
             <a:pPr>
               <a:spcBef>
-                <a:spcPts val="700"/>
+                <a:spcPts val="900"/>
               </a:spcBef>
-              <a:defRPr sz="1100">
+              <a:defRPr sz="1200">
                 <a:solidFill>
                   <a:srgbClr val="F1F5F9"/>
                 </a:solidFill>
               </a:defRPr>
             </a:pPr>
             <a:r>
-              <a:t>• Plotly Express: Dynamic interactive charts displaying comparative benchmarks and historical trends.</a:t>
+              <a:t>✔  Streamlit: Interactive presentation web dashboard.</a:t>
             </a:r>
           </a:p>
           <a:p>
             <a:pPr>
               <a:spcBef>
-                <a:spcPts val="700"/>
+                <a:spcPts val="900"/>
               </a:spcBef>
-              <a:defRPr sz="1100">
+              <a:defRPr sz="1200">
                 <a:solidFill>
                   <a:srgbClr val="F1F5F9"/>
                 </a:solidFill>
               </a:defRPr>
             </a:pPr>
             <a:r>
-              <a:t>• Streamlit Cloud: Automated CI/CD deployment directly from GitHub, ensuring 24/7 global accessibility.</a:t>
+              <a:t>✔  Plotly: Interactive comparison charts &amp; trends.</a:t>
+            </a:r>
+          </a:p>
+          <a:p>
+            <a:pPr>
+              <a:spcBef>
+                <a:spcPts val="900"/>
+              </a:spcBef>
+              <a:defRPr sz="1200">
+                <a:solidFill>
+                  <a:srgbClr val="F1F5F9"/>
+                </a:solidFill>
+              </a:defRPr>
+            </a:pPr>
+            <a:r>
+              <a:t>✔  GitHub &amp; Streamlit Cloud: Live 24/7 global hosting.</a:t>
             </a:r>
           </a:p>
         </p:txBody>
@@ -5904,8 +5657,8 @@
         </p:nvSpPr>
         <p:spPr>
           <a:xfrm>
-            <a:off x="6309360" y="1463040"/>
-            <a:ext cx="5120640" cy="4663440"/>
+            <a:off x="6309360" y="1645920"/>
+            <a:ext cx="4937760" cy="4389120"/>
           </a:xfrm>
           <a:prstGeom prst="roundRect">
             <a:avLst/>
@@ -5949,8 +5702,8 @@
         </p:nvSpPr>
         <p:spPr>
           <a:xfrm>
-            <a:off x="6583680" y="1645920"/>
-            <a:ext cx="4572000" cy="4297680"/>
+            <a:off x="6583680" y="1828800"/>
+            <a:ext cx="4389120" cy="4023360"/>
           </a:xfrm>
           <a:prstGeom prst="rect">
             <a:avLst/>
@@ -5964,74 +5717,74 @@
           <a:lstStyle/>
           <a:p>
             <a:pPr>
-              <a:defRPr sz="1300" b="1">
+              <a:defRPr sz="1400" b="1">
                 <a:solidFill>
                   <a:srgbClr val="38BDF8"/>
                 </a:solidFill>
               </a:defRPr>
             </a:pPr>
             <a:r>
-              <a:t>🌾 USER-FRIENDLY DASHBOARD FEATURES</a:t>
+              <a:t>🌾 SIMPLE OUTPUT FORMAT</a:t>
             </a:r>
           </a:p>
           <a:p>
             <a:pPr>
               <a:spcBef>
-                <a:spcPts val="800"/>
+                <a:spcPts val="1100"/>
               </a:spcBef>
-              <a:defRPr sz="1100">
+              <a:defRPr sz="1200">
                 <a:solidFill>
                   <a:srgbClr val="F1F5F9"/>
                 </a:solidFill>
               </a:defRPr>
             </a:pPr>
             <a:r>
-              <a:t>• 1-Click Presets: Punjab Wheat (Rabi), West Bengal Rice (Kharif), and Maharashtra Sugarcane for rapid demonstration.</a:t>
+              <a:t>✔  Yield per Hectare: (e.g. 4.80 tonnes/ha).</a:t>
             </a:r>
           </a:p>
           <a:p>
             <a:pPr>
               <a:spcBef>
-                <a:spcPts val="800"/>
+                <a:spcPts val="1100"/>
               </a:spcBef>
-              <a:defRPr sz="1100">
+              <a:defRPr sz="1200">
                 <a:solidFill>
                   <a:srgbClr val="F1F5F9"/>
                 </a:solidFill>
               </a:defRPr>
             </a:pPr>
             <a:r>
-              <a:t>• Understandable Units: Translates mathematical Tonnes/Hectare into Tonnes/Acre and standard 10-Tonne Truckload counts.</a:t>
+              <a:t>✔  Yield per Acre: (e.g. ~1.94 tonnes/acre) for local farmers.</a:t>
             </a:r>
           </a:p>
           <a:p>
             <a:pPr>
               <a:spcBef>
-                <a:spcPts val="800"/>
+                <a:spcPts val="1100"/>
               </a:spcBef>
-              <a:defRPr sz="1100">
+              <a:defRPr sz="1200">
                 <a:solidFill>
                   <a:srgbClr val="F1F5F9"/>
                 </a:solidFill>
               </a:defRPr>
             </a:pPr>
             <a:r>
-              <a:t>• Benchmark Comparison: Compares predicted harvest against actual state and nationwide government averages.</a:t>
+              <a:t>✔  Total Commercial Output: Total weight for the entire farm.</a:t>
             </a:r>
           </a:p>
           <a:p>
             <a:pPr>
               <a:spcBef>
-                <a:spcPts val="800"/>
+                <a:spcPts val="1100"/>
               </a:spcBef>
-              <a:defRPr sz="1100">
+              <a:defRPr sz="1200">
                 <a:solidFill>
                   <a:srgbClr val="F1F5F9"/>
                 </a:solidFill>
               </a:defRPr>
             </a:pPr>
             <a:r>
-              <a:t>• Dark/Light Mode: 100% theme-adaptive UI designed with high-contrast executive visual presentation.</a:t>
+              <a:t>✔  Commercial Truckloads: (e.g. ≈ 48 ten-tonne trucks) so farmers can easily plan transport.</a:t>
             </a:r>
           </a:p>
         </p:txBody>

</xml_diff>

<commit_message>
Update presentation to clean Light Theme with large fonts and high contrast
</commit_message>
<xml_diff>
--- a/AgriYield_Presentation.pptx
+++ b/AgriYield_Presentation.pptx
@@ -3089,7 +3089,7 @@
     <p:bg>
       <p:bgPr>
         <a:solidFill>
-          <a:srgbClr val="0E131F"/>
+          <a:srgbClr val="F8FAFC"/>
         </a:solidFill>
         <a:effectLst/>
       </p:bgPr>
@@ -3109,18 +3109,18 @@
         </p:nvSpPr>
         <p:spPr>
           <a:xfrm>
-            <a:off x="914400" y="914400"/>
-            <a:ext cx="10362895" cy="73152"/>
+            <a:off x="822960" y="731520"/>
+            <a:ext cx="10545775" cy="109728"/>
           </a:xfrm>
           <a:prstGeom prst="rect">
             <a:avLst/>
           </a:prstGeom>
           <a:solidFill>
-            <a:srgbClr val="10B981"/>
+            <a:srgbClr val="059669"/>
           </a:solidFill>
           <a:ln>
             <a:solidFill>
-              <a:srgbClr val="10B981"/>
+              <a:srgbClr val="059669"/>
             </a:solidFill>
           </a:ln>
         </p:spPr>
@@ -3154,8 +3154,8 @@
         </p:nvSpPr>
         <p:spPr>
           <a:xfrm>
-            <a:off x="914400" y="1280160"/>
-            <a:ext cx="10362895" cy="1463040"/>
+            <a:off x="822960" y="1051560"/>
+            <a:ext cx="10545775" cy="1645920"/>
           </a:xfrm>
           <a:prstGeom prst="rect">
             <a:avLst/>
@@ -3171,27 +3171,27 @@
             <a:pPr>
               <a:defRPr sz="3600" b="1">
                 <a:solidFill>
-                  <a:srgbClr val="FFFFFF"/>
+                  <a:srgbClr val="065F46"/>
                 </a:solidFill>
               </a:defRPr>
             </a:pPr>
             <a:r>
-              <a:t>🌾 AgriYield: Crop Yield Prediction</a:t>
+              <a:t>AgriYield: Crop Yield Prediction System</a:t>
             </a:r>
           </a:p>
           <a:p>
             <a:pPr>
               <a:spcBef>
-                <a:spcPts val="800"/>
+                <a:spcPts val="600"/>
               </a:spcBef>
-              <a:defRPr sz="1600">
-                <a:solidFill>
-                  <a:srgbClr val="94A3B8"/>
+              <a:defRPr sz="1800">
+                <a:solidFill>
+                  <a:srgbClr val="334155"/>
                 </a:solidFill>
               </a:defRPr>
             </a:pPr>
             <a:r>
-              <a:t>Data Science-Based Agricultural Analysis and Pre-Harvest Forecasting</a:t>
+              <a:t>Data Science-Based Agricultural Analysis &amp; Pre-Harvest Machine Learning Forecasting</a:t>
             </a:r>
           </a:p>
         </p:txBody>
@@ -3204,18 +3204,18 @@
         </p:nvSpPr>
         <p:spPr>
           <a:xfrm>
-            <a:off x="914400" y="3291840"/>
-            <a:ext cx="5486400" cy="2377440"/>
+            <a:off x="822960" y="2926080"/>
+            <a:ext cx="5486400" cy="3291840"/>
           </a:xfrm>
           <a:prstGeom prst="roundRect">
             <a:avLst/>
           </a:prstGeom>
           <a:solidFill>
-            <a:srgbClr val="182234"/>
+            <a:srgbClr val="F0FDF4"/>
           </a:solidFill>
-          <a:ln w="25400">
+          <a:ln w="31750">
             <a:solidFill>
-              <a:srgbClr val="10B981"/>
+              <a:srgbClr val="059669"/>
             </a:solidFill>
           </a:ln>
         </p:spPr>
@@ -3249,8 +3249,8 @@
         </p:nvSpPr>
         <p:spPr>
           <a:xfrm>
-            <a:off x="1188720" y="3566160"/>
-            <a:ext cx="4937760" cy="1920240"/>
+            <a:off x="1097280" y="3154680"/>
+            <a:ext cx="4937760" cy="2834640"/>
           </a:xfrm>
           <a:prstGeom prst="rect">
             <a:avLst/>
@@ -3258,30 +3258,30 @@
           <a:noFill/>
         </p:spPr>
         <p:txBody>
-          <a:bodyPr wrap="none">
+          <a:bodyPr wrap="square">
             <a:spAutoFit/>
           </a:bodyPr>
           <a:lstStyle/>
           <a:p>
             <a:pPr>
-              <a:defRPr sz="1100" b="1">
-                <a:solidFill>
-                  <a:srgbClr val="10B981"/>
+              <a:defRPr sz="1300" b="1">
+                <a:solidFill>
+                  <a:srgbClr val="059669"/>
                 </a:solidFill>
               </a:defRPr>
             </a:pPr>
             <a:r>
-              <a:t>PRESENTED BY</a:t>
+              <a:t>PROJECT PRESENTED BY</a:t>
             </a:r>
           </a:p>
           <a:p>
             <a:pPr>
               <a:spcBef>
-                <a:spcPts val="600"/>
+                <a:spcPts val="800"/>
               </a:spcBef>
-              <a:defRPr sz="2600" b="1">
-                <a:solidFill>
-                  <a:srgbClr val="FFFFFF"/>
+              <a:defRPr sz="3400" b="1">
+                <a:solidFill>
+                  <a:srgbClr val="0F172A"/>
                 </a:solidFill>
               </a:defRPr>
             </a:pPr>
@@ -3292,16 +3292,31 @@
           <a:p>
             <a:pPr>
               <a:spcBef>
-                <a:spcPts val="600"/>
+                <a:spcPts val="800"/>
               </a:spcBef>
-              <a:defRPr sz="1600" b="1">
-                <a:solidFill>
-                  <a:srgbClr val="38BDF8"/>
+              <a:defRPr sz="2000" b="1">
+                <a:solidFill>
+                  <a:srgbClr val="0284C7"/>
                 </a:solidFill>
               </a:defRPr>
             </a:pPr>
             <a:r>
               <a:t>ROLL NO : 24VNM034</a:t>
+            </a:r>
+          </a:p>
+          <a:p>
+            <a:pPr>
+              <a:spcBef>
+                <a:spcPts val="800"/>
+              </a:spcBef>
+              <a:defRPr sz="1400">
+                <a:solidFill>
+                  <a:srgbClr val="334155"/>
+                </a:solidFill>
+              </a:defRPr>
+            </a:pPr>
+            <a:r>
+              <a:t>Data Science &amp; Machine Learning Investigation</a:t>
             </a:r>
           </a:p>
         </p:txBody>
@@ -3314,18 +3329,18 @@
         </p:nvSpPr>
         <p:spPr>
           <a:xfrm>
-            <a:off x="6675120" y="3291840"/>
-            <a:ext cx="4572000" cy="2377440"/>
+            <a:off x="6583680" y="2926080"/>
+            <a:ext cx="4754880" cy="3291840"/>
           </a:xfrm>
           <a:prstGeom prst="roundRect">
             <a:avLst/>
           </a:prstGeom>
           <a:solidFill>
-            <a:srgbClr val="182234"/>
+            <a:srgbClr val="FFFFFF"/>
           </a:solidFill>
-          <a:ln>
+          <a:ln w="19050">
             <a:solidFill>
-              <a:srgbClr val="334155"/>
+              <a:srgbClr val="E2E8F0"/>
             </a:solidFill>
           </a:ln>
         </p:spPr>
@@ -3359,8 +3374,8 @@
         </p:nvSpPr>
         <p:spPr>
           <a:xfrm>
-            <a:off x="6949440" y="3566160"/>
-            <a:ext cx="4023360" cy="1920240"/>
+            <a:off x="6858000" y="3154680"/>
+            <a:ext cx="4206240" cy="2834640"/>
           </a:xfrm>
           <a:prstGeom prst="rect">
             <a:avLst/>
@@ -3368,80 +3383,95 @@
           <a:noFill/>
         </p:spPr>
         <p:txBody>
-          <a:bodyPr wrap="none">
+          <a:bodyPr wrap="square">
             <a:spAutoFit/>
           </a:bodyPr>
           <a:lstStyle/>
           <a:p>
             <a:pPr>
-              <a:defRPr sz="1100" b="1">
-                <a:solidFill>
-                  <a:srgbClr val="10B981"/>
+              <a:defRPr sz="1300" b="1">
+                <a:solidFill>
+                  <a:srgbClr val="059669"/>
                 </a:solidFill>
               </a:defRPr>
             </a:pPr>
             <a:r>
-              <a:t>PROJECT QUICK FACTS</a:t>
+              <a:t>KEY PROJECT HIGHLIGHTS</a:t>
             </a:r>
           </a:p>
           <a:p>
             <a:pPr>
               <a:spcBef>
-                <a:spcPts val="500"/>
+                <a:spcPts val="800"/>
               </a:spcBef>
-              <a:defRPr sz="1200">
-                <a:solidFill>
-                  <a:srgbClr val="F1F5F9"/>
+              <a:defRPr sz="1450" b="1">
+                <a:solidFill>
+                  <a:srgbClr val="0F172A"/>
                 </a:solidFill>
               </a:defRPr>
             </a:pPr>
             <a:r>
-              <a:t>✔  19,689 Real Census Records (1997–2020)</a:t>
+              <a:t>•  19,689 Real Census Records (1997–2020)</a:t>
             </a:r>
           </a:p>
           <a:p>
             <a:pPr>
               <a:spcBef>
-                <a:spcPts val="500"/>
+                <a:spcPts val="800"/>
               </a:spcBef>
-              <a:defRPr sz="1200">
-                <a:solidFill>
-                  <a:srgbClr val="F1F5F9"/>
+              <a:defRPr sz="1450" b="1">
+                <a:solidFill>
+                  <a:srgbClr val="0F172A"/>
                 </a:solidFill>
               </a:defRPr>
             </a:pPr>
             <a:r>
-              <a:t>✔  55 Crops &amp; 30 Indian States</a:t>
+              <a:t>•  55 Crops &amp; 30 Indian States Nationwide</a:t>
             </a:r>
           </a:p>
           <a:p>
             <a:pPr>
               <a:spcBef>
-                <a:spcPts val="500"/>
+                <a:spcPts val="800"/>
               </a:spcBef>
-              <a:defRPr sz="1200">
-                <a:solidFill>
-                  <a:srgbClr val="F1F5F9"/>
+              <a:defRPr sz="1450" b="1">
+                <a:solidFill>
+                  <a:srgbClr val="0F172A"/>
                 </a:solidFill>
               </a:defRPr>
             </a:pPr>
             <a:r>
-              <a:t>✔  Champion Model: Random Forest</a:t>
+              <a:t>•  Champion Model: Random Forest Regressor</a:t>
             </a:r>
           </a:p>
           <a:p>
             <a:pPr>
               <a:spcBef>
-                <a:spcPts val="500"/>
+                <a:spcPts val="800"/>
               </a:spcBef>
-              <a:defRPr sz="1200">
-                <a:solidFill>
-                  <a:srgbClr val="F1F5F9"/>
+              <a:defRPr sz="1450" b="1">
+                <a:solidFill>
+                  <a:srgbClr val="0F172A"/>
                 </a:solidFill>
               </a:defRPr>
             </a:pPr>
             <a:r>
-              <a:t>✔  Prediction Accuracy: 96.8% (R² Score)</a:t>
+              <a:t>•  Predictive Accuracy: 96.8% (R² Score)</a:t>
+            </a:r>
+          </a:p>
+          <a:p>
+            <a:pPr>
+              <a:spcBef>
+                <a:spcPts val="800"/>
+              </a:spcBef>
+              <a:defRPr sz="1450" b="1">
+                <a:solidFill>
+                  <a:srgbClr val="0F172A"/>
+                </a:solidFill>
+              </a:defRPr>
+            </a:pPr>
+            <a:r>
+              <a:t>•  Zero Data Leakage: Genuine Pre-Harvest ML</a:t>
             </a:r>
           </a:p>
         </p:txBody>
@@ -3460,7 +3490,7 @@
     <p:bg>
       <p:bgPr>
         <a:solidFill>
-          <a:srgbClr val="0E131F"/>
+          <a:srgbClr val="F8FAFC"/>
         </a:solidFill>
         <a:effectLst/>
       </p:bgPr>
@@ -3480,8 +3510,8 @@
         </p:nvSpPr>
         <p:spPr>
           <a:xfrm>
-            <a:off x="914400" y="457200"/>
-            <a:ext cx="10332720" cy="365760"/>
+            <a:off x="822960" y="365760"/>
+            <a:ext cx="10515600" cy="320040"/>
           </a:xfrm>
           <a:prstGeom prst="rect">
             <a:avLst/>
@@ -3497,7 +3527,7 @@
             <a:pPr>
               <a:defRPr sz="1100" b="1">
                 <a:solidFill>
-                  <a:srgbClr val="10B981"/>
+                  <a:srgbClr val="059669"/>
                 </a:solidFill>
               </a:defRPr>
             </a:pPr>
@@ -3515,8 +3545,8 @@
         </p:nvSpPr>
         <p:spPr>
           <a:xfrm>
-            <a:off x="914400" y="777240"/>
-            <a:ext cx="10332720" cy="731520"/>
+            <a:off x="822960" y="640080"/>
+            <a:ext cx="10515600" cy="731520"/>
           </a:xfrm>
           <a:prstGeom prst="rect">
             <a:avLst/>
@@ -3530,9 +3560,9 @@
           <a:lstStyle/>
           <a:p>
             <a:pPr>
-              <a:defRPr sz="2600" b="1">
-                <a:solidFill>
-                  <a:srgbClr val="FFFFFF"/>
+              <a:defRPr sz="2800" b="1">
+                <a:solidFill>
+                  <a:srgbClr val="0F172A"/>
                 </a:solidFill>
               </a:defRPr>
             </a:pPr>
@@ -3550,18 +3580,18 @@
         </p:nvSpPr>
         <p:spPr>
           <a:xfrm>
-            <a:off x="914400" y="1645920"/>
-            <a:ext cx="4937760" cy="4389120"/>
+            <a:off x="822960" y="1463040"/>
+            <a:ext cx="5120640" cy="4846320"/>
           </a:xfrm>
           <a:prstGeom prst="roundRect">
             <a:avLst/>
           </a:prstGeom>
           <a:solidFill>
-            <a:srgbClr val="182234"/>
+            <a:srgbClr val="FEF2F2"/>
           </a:solidFill>
-          <a:ln>
+          <a:ln w="25400">
             <a:solidFill>
-              <a:srgbClr val="EF4444"/>
+              <a:srgbClr val="DC2626"/>
             </a:solidFill>
           </a:ln>
         </p:spPr>
@@ -3595,8 +3625,8 @@
         </p:nvSpPr>
         <p:spPr>
           <a:xfrm>
-            <a:off x="1188720" y="1828800"/>
-            <a:ext cx="4389120" cy="4023360"/>
+            <a:off x="1097280" y="1737360"/>
+            <a:ext cx="4572000" cy="4297680"/>
           </a:xfrm>
           <a:prstGeom prst="rect">
             <a:avLst/>
@@ -3610,59 +3640,59 @@
           <a:lstStyle/>
           <a:p>
             <a:pPr>
-              <a:defRPr sz="1400" b="1">
-                <a:solidFill>
-                  <a:srgbClr val="EF4444"/>
+              <a:defRPr sz="1800" b="1">
+                <a:solidFill>
+                  <a:srgbClr val="DC2626"/>
                 </a:solidFill>
               </a:defRPr>
             </a:pPr>
             <a:r>
-              <a:t>⚠️ THE PROBLEM TODAY</a:t>
+              <a:t>THE PROBLEM TODAY</a:t>
             </a:r>
           </a:p>
           <a:p>
             <a:pPr>
               <a:spcBef>
-                <a:spcPts val="1400"/>
+                <a:spcPts val="1600"/>
               </a:spcBef>
-              <a:defRPr sz="1300">
-                <a:solidFill>
-                  <a:srgbClr val="F1F5F9"/>
+              <a:defRPr sz="1550">
+                <a:solidFill>
+                  <a:srgbClr val="0F172A"/>
                 </a:solidFill>
               </a:defRPr>
             </a:pPr>
             <a:r>
-              <a:t>•  Manual Crop-Cutting: Yield is only measured after harvest by manually cutting field samples.</a:t>
+              <a:t>• Post-Harvest Delay: Yield is only measured after harvesting is completely finished through slow manual crop-cutting.</a:t>
             </a:r>
           </a:p>
           <a:p>
             <a:pPr>
               <a:spcBef>
-                <a:spcPts val="1400"/>
+                <a:spcPts val="1600"/>
               </a:spcBef>
-              <a:defRPr sz="1300">
-                <a:solidFill>
-                  <a:srgbClr val="F1F5F9"/>
+              <a:defRPr sz="1550">
+                <a:solidFill>
+                  <a:srgbClr val="0F172A"/>
                 </a:solidFill>
               </a:defRPr>
             </a:pPr>
             <a:r>
-              <a:t>•  Too Late for Action: When food shortages occur, prices have already spiked.</a:t>
+              <a:t>• Too Late for Action: When food shortages occur, prices have already spiked and inflation has hurt citizens.</a:t>
             </a:r>
           </a:p>
           <a:p>
             <a:pPr>
               <a:spcBef>
-                <a:spcPts val="1400"/>
+                <a:spcPts val="1600"/>
               </a:spcBef>
-              <a:defRPr sz="1300">
-                <a:solidFill>
-                  <a:srgbClr val="F1F5F9"/>
+              <a:defRPr sz="1550">
+                <a:solidFill>
+                  <a:srgbClr val="0F172A"/>
                 </a:solidFill>
               </a:defRPr>
             </a:pPr>
             <a:r>
-              <a:t>•  No Advance Planning: Farmers cannot plan storage, trucks, or sales in advance.</a:t>
+              <a:t>• No Advance Planning: Farmers and transport operators cannot plan trucks, storage, or sales months in advance.</a:t>
             </a:r>
           </a:p>
         </p:txBody>
@@ -3675,18 +3705,18 @@
         </p:nvSpPr>
         <p:spPr>
           <a:xfrm>
-            <a:off x="6309360" y="1645920"/>
-            <a:ext cx="4937760" cy="4389120"/>
+            <a:off x="6217920" y="1463040"/>
+            <a:ext cx="5120640" cy="4846320"/>
           </a:xfrm>
           <a:prstGeom prst="roundRect">
             <a:avLst/>
           </a:prstGeom>
           <a:solidFill>
-            <a:srgbClr val="182234"/>
+            <a:srgbClr val="F0FDF4"/>
           </a:solidFill>
-          <a:ln>
+          <a:ln w="25400">
             <a:solidFill>
-              <a:srgbClr val="10B981"/>
+              <a:srgbClr val="059669"/>
             </a:solidFill>
           </a:ln>
         </p:spPr>
@@ -3720,8 +3750,8 @@
         </p:nvSpPr>
         <p:spPr>
           <a:xfrm>
-            <a:off x="6583680" y="1828800"/>
-            <a:ext cx="4389120" cy="4023360"/>
+            <a:off x="6492240" y="1737360"/>
+            <a:ext cx="4572000" cy="4297680"/>
           </a:xfrm>
           <a:prstGeom prst="rect">
             <a:avLst/>
@@ -3735,59 +3765,59 @@
           <a:lstStyle/>
           <a:p>
             <a:pPr>
-              <a:defRPr sz="1400" b="1">
-                <a:solidFill>
-                  <a:srgbClr val="10B981"/>
+              <a:defRPr sz="1800" b="1">
+                <a:solidFill>
+                  <a:srgbClr val="059669"/>
                 </a:solidFill>
               </a:defRPr>
             </a:pPr>
             <a:r>
-              <a:t>💡 THE AGRIYIELD SOLUTION</a:t>
+              <a:t>THE AGRIYIELD SOLUTION</a:t>
             </a:r>
           </a:p>
           <a:p>
             <a:pPr>
               <a:spcBef>
-                <a:spcPts val="1400"/>
+                <a:spcPts val="1600"/>
               </a:spcBef>
-              <a:defRPr sz="1300">
-                <a:solidFill>
-                  <a:srgbClr val="F1F5F9"/>
+              <a:defRPr sz="1550">
+                <a:solidFill>
+                  <a:srgbClr val="0F172A"/>
                 </a:solidFill>
               </a:defRPr>
             </a:pPr>
             <a:r>
-              <a:t>✔  Pre-Harvest Forecasting: Predicts crop yield months before harvest using planting data.</a:t>
+              <a:t>• Pre-Harvest AI Forecasting: Predicts crop harvest months in advance using data available during planting season.</a:t>
             </a:r>
           </a:p>
           <a:p>
             <a:pPr>
               <a:spcBef>
-                <a:spcPts val="1400"/>
+                <a:spcPts val="1600"/>
               </a:spcBef>
-              <a:defRPr sz="1300">
-                <a:solidFill>
-                  <a:srgbClr val="F1F5F9"/>
+              <a:defRPr sz="1550">
+                <a:solidFill>
+                  <a:srgbClr val="0F172A"/>
                 </a:solidFill>
               </a:defRPr>
             </a:pPr>
             <a:r>
-              <a:t>✔  Simple Everyday Inputs: Uses rainfall, fertilizer amount, land area, and crop type.</a:t>
+              <a:t>• Practical Input Factors: Uses annual rainfall, fertilizer amount, pesticide, land area, and crop genetics.</a:t>
             </a:r>
           </a:p>
           <a:p>
             <a:pPr>
               <a:spcBef>
-                <a:spcPts val="1400"/>
+                <a:spcPts val="1600"/>
               </a:spcBef>
-              <a:defRPr sz="1300">
-                <a:solidFill>
-                  <a:srgbClr val="F1F5F9"/>
+              <a:defRPr sz="1550">
+                <a:solidFill>
+                  <a:srgbClr val="0F172A"/>
                 </a:solidFill>
               </a:defRPr>
             </a:pPr>
             <a:r>
-              <a:t>✔  Farmer-Friendly Output: Converts numbers into tonnes per acre and truckloads.</a:t>
+              <a:t>• Farmer-Friendly Outputs: Translates mathematical yield into practical tonnes per acre and commercial truckload counts.</a:t>
             </a:r>
           </a:p>
         </p:txBody>
@@ -3806,7 +3836,7 @@
     <p:bg>
       <p:bgPr>
         <a:solidFill>
-          <a:srgbClr val="0E131F"/>
+          <a:srgbClr val="F8FAFC"/>
         </a:solidFill>
         <a:effectLst/>
       </p:bgPr>
@@ -3826,8 +3856,8 @@
         </p:nvSpPr>
         <p:spPr>
           <a:xfrm>
-            <a:off x="914400" y="457200"/>
-            <a:ext cx="10332720" cy="365760"/>
+            <a:off x="822960" y="365760"/>
+            <a:ext cx="10515600" cy="320040"/>
           </a:xfrm>
           <a:prstGeom prst="rect">
             <a:avLst/>
@@ -3843,7 +3873,7 @@
             <a:pPr>
               <a:defRPr sz="1100" b="1">
                 <a:solidFill>
-                  <a:srgbClr val="10B981"/>
+                  <a:srgbClr val="059669"/>
                 </a:solidFill>
               </a:defRPr>
             </a:pPr>
@@ -3861,8 +3891,8 @@
         </p:nvSpPr>
         <p:spPr>
           <a:xfrm>
-            <a:off x="914400" y="777240"/>
-            <a:ext cx="10332720" cy="731520"/>
+            <a:off x="822960" y="640080"/>
+            <a:ext cx="10515600" cy="731520"/>
           </a:xfrm>
           <a:prstGeom prst="rect">
             <a:avLst/>
@@ -3876,14 +3906,14 @@
           <a:lstStyle/>
           <a:p>
             <a:pPr>
-              <a:defRPr sz="2600" b="1">
-                <a:solidFill>
-                  <a:srgbClr val="FFFFFF"/>
+              <a:defRPr sz="2800" b="1">
+                <a:solidFill>
+                  <a:srgbClr val="0F172A"/>
                 </a:solidFill>
               </a:defRPr>
             </a:pPr>
             <a:r>
-              <a:t>The Dataset &amp; Leakage Prevention</a:t>
+              <a:t>Dataset Scope &amp; Zero Data Leakage</a:t>
             </a:r>
           </a:p>
         </p:txBody>
@@ -3896,18 +3926,18 @@
         </p:nvSpPr>
         <p:spPr>
           <a:xfrm>
-            <a:off x="914400" y="1645920"/>
-            <a:ext cx="4937760" cy="2103120"/>
+            <a:off x="822960" y="1463040"/>
+            <a:ext cx="5120640" cy="2286000"/>
           </a:xfrm>
           <a:prstGeom prst="roundRect">
             <a:avLst/>
           </a:prstGeom>
           <a:solidFill>
-            <a:srgbClr val="182234"/>
+            <a:srgbClr val="FFFFFF"/>
           </a:solidFill>
-          <a:ln w="19050">
+          <a:ln w="25400">
             <a:solidFill>
-              <a:srgbClr val="10B981"/>
+              <a:srgbClr val="059669"/>
             </a:solidFill>
           </a:ln>
         </p:spPr>
@@ -3941,8 +3971,8 @@
         </p:nvSpPr>
         <p:spPr>
           <a:xfrm>
-            <a:off x="1188720" y="1828800"/>
-            <a:ext cx="4389120" cy="1737360"/>
+            <a:off x="1097280" y="1645920"/>
+            <a:ext cx="4572000" cy="1920240"/>
           </a:xfrm>
           <a:prstGeom prst="rect">
             <a:avLst/>
@@ -3956,14 +3986,14 @@
           <a:lstStyle/>
           <a:p>
             <a:pPr>
-              <a:defRPr sz="1400" b="1">
-                <a:solidFill>
-                  <a:srgbClr val="10B981"/>
+              <a:defRPr sz="1800" b="1">
+                <a:solidFill>
+                  <a:srgbClr val="059669"/>
                 </a:solidFill>
               </a:defRPr>
             </a:pPr>
             <a:r>
-              <a:t>📊 19,689 Records</a:t>
+              <a:t>19,689 Records</a:t>
             </a:r>
           </a:p>
           <a:p>
@@ -3971,14 +4001,14 @@
               <a:spcBef>
                 <a:spcPts val="800"/>
               </a:spcBef>
-              <a:defRPr sz="1200">
-                <a:solidFill>
-                  <a:srgbClr val="F1F5F9"/>
+              <a:defRPr sz="1500">
+                <a:solidFill>
+                  <a:srgbClr val="0F172A"/>
                 </a:solidFill>
               </a:defRPr>
             </a:pPr>
             <a:r>
-              <a:t>24 Years of authentic Indian agricultural census records (1997 to 2020) from the Ministry of Agriculture &amp; IMD.</a:t>
+              <a:t>24 Years of official Indian farm census records (1997 to 2020) collected from the Ministry of Agriculture &amp; IMD.</a:t>
             </a:r>
           </a:p>
         </p:txBody>
@@ -3991,18 +4021,18 @@
         </p:nvSpPr>
         <p:spPr>
           <a:xfrm>
-            <a:off x="6309360" y="1645920"/>
-            <a:ext cx="4937760" cy="2103120"/>
+            <a:off x="6217920" y="1463040"/>
+            <a:ext cx="5120640" cy="2286000"/>
           </a:xfrm>
           <a:prstGeom prst="roundRect">
             <a:avLst/>
           </a:prstGeom>
           <a:solidFill>
-            <a:srgbClr val="182234"/>
+            <a:srgbClr val="FFFFFF"/>
           </a:solidFill>
-          <a:ln w="19050">
+          <a:ln w="25400">
             <a:solidFill>
-              <a:srgbClr val="38BDF8"/>
+              <a:srgbClr val="0284C7"/>
             </a:solidFill>
           </a:ln>
         </p:spPr>
@@ -4036,8 +4066,8 @@
         </p:nvSpPr>
         <p:spPr>
           <a:xfrm>
-            <a:off x="6583680" y="1828800"/>
-            <a:ext cx="4389120" cy="1737360"/>
+            <a:off x="6492240" y="1645920"/>
+            <a:ext cx="4572000" cy="1920240"/>
           </a:xfrm>
           <a:prstGeom prst="rect">
             <a:avLst/>
@@ -4051,14 +4081,14 @@
           <a:lstStyle/>
           <a:p>
             <a:pPr>
-              <a:defRPr sz="1400" b="1">
-                <a:solidFill>
-                  <a:srgbClr val="38BDF8"/>
+              <a:defRPr sz="1800" b="1">
+                <a:solidFill>
+                  <a:srgbClr val="0284C7"/>
                 </a:solidFill>
               </a:defRPr>
             </a:pPr>
             <a:r>
-              <a:t>🌾 55 Crops &amp; 30 States</a:t>
+              <a:t>55 Crops &amp; 30 States</a:t>
             </a:r>
           </a:p>
           <a:p>
@@ -4066,14 +4096,14 @@
               <a:spcBef>
                 <a:spcPts val="800"/>
               </a:spcBef>
-              <a:defRPr sz="1200">
-                <a:solidFill>
-                  <a:srgbClr val="F1F5F9"/>
+              <a:defRPr sz="1500">
+                <a:solidFill>
+                  <a:srgbClr val="0F172A"/>
                 </a:solidFill>
               </a:defRPr>
             </a:pPr>
             <a:r>
-              <a:t>Wide coverage across cereals (Rice, Wheat), pulses (Gram, Moong), oilseeds, and heavy cash crops (Sugarcane).</a:t>
+              <a:t>Wide coverage across food grains (Rice, Wheat), pulses (Gram, Moong), oilseeds, and heavy cash crops (Sugarcane).</a:t>
             </a:r>
           </a:p>
         </p:txBody>
@@ -4086,18 +4116,18 @@
         </p:nvSpPr>
         <p:spPr>
           <a:xfrm>
-            <a:off x="914400" y="4023360"/>
-            <a:ext cx="4937760" cy="2103120"/>
+            <a:off x="822960" y="3931920"/>
+            <a:ext cx="5120640" cy="2286000"/>
           </a:xfrm>
           <a:prstGeom prst="roundRect">
             <a:avLst/>
           </a:prstGeom>
           <a:solidFill>
-            <a:srgbClr val="182234"/>
+            <a:srgbClr val="FFFFFF"/>
           </a:solidFill>
-          <a:ln w="19050">
+          <a:ln w="25400">
             <a:solidFill>
-              <a:srgbClr val="A855F7"/>
+              <a:srgbClr val="7C3AED"/>
             </a:solidFill>
           </a:ln>
         </p:spPr>
@@ -4131,8 +4161,8 @@
         </p:nvSpPr>
         <p:spPr>
           <a:xfrm>
-            <a:off x="1188720" y="4206240"/>
-            <a:ext cx="4389120" cy="1737360"/>
+            <a:off x="1097280" y="4114800"/>
+            <a:ext cx="4572000" cy="1920240"/>
           </a:xfrm>
           <a:prstGeom prst="rect">
             <a:avLst/>
@@ -4146,14 +4176,14 @@
           <a:lstStyle/>
           <a:p>
             <a:pPr>
-              <a:defRPr sz="1400" b="1">
-                <a:solidFill>
-                  <a:srgbClr val="A855F7"/>
+              <a:defRPr sz="1800" b="1">
+                <a:solidFill>
+                  <a:srgbClr val="7C3AED"/>
                 </a:solidFill>
               </a:defRPr>
             </a:pPr>
             <a:r>
-              <a:t>🛡️ Zero Data Leakage</a:t>
+              <a:t>Zero Data Leakage Protocol</a:t>
             </a:r>
           </a:p>
           <a:p>
@@ -4161,9 +4191,9 @@
               <a:spcBef>
                 <a:spcPts val="800"/>
               </a:spcBef>
-              <a:defRPr sz="1200">
-                <a:solidFill>
-                  <a:srgbClr val="F1F5F9"/>
+              <a:defRPr sz="1500">
+                <a:solidFill>
+                  <a:srgbClr val="0F172A"/>
                 </a:solidFill>
               </a:defRPr>
             </a:pPr>
@@ -4181,18 +4211,18 @@
         </p:nvSpPr>
         <p:spPr>
           <a:xfrm>
-            <a:off x="6309360" y="4023360"/>
-            <a:ext cx="4937760" cy="2103120"/>
+            <a:off x="6217920" y="3931920"/>
+            <a:ext cx="5120640" cy="2286000"/>
           </a:xfrm>
           <a:prstGeom prst="roundRect">
             <a:avLst/>
           </a:prstGeom>
           <a:solidFill>
-            <a:srgbClr val="182234"/>
+            <a:srgbClr val="FFFFFF"/>
           </a:solidFill>
-          <a:ln w="19050">
+          <a:ln w="25400">
             <a:solidFill>
-              <a:srgbClr val="F59E0B"/>
+              <a:srgbClr val="D97706"/>
             </a:solidFill>
           </a:ln>
         </p:spPr>
@@ -4226,8 +4256,8 @@
         </p:nvSpPr>
         <p:spPr>
           <a:xfrm>
-            <a:off x="6583680" y="4206240"/>
-            <a:ext cx="4389120" cy="1737360"/>
+            <a:off x="6492240" y="4114800"/>
+            <a:ext cx="4572000" cy="1920240"/>
           </a:xfrm>
           <a:prstGeom prst="rect">
             <a:avLst/>
@@ -4241,14 +4271,14 @@
           <a:lstStyle/>
           <a:p>
             <a:pPr>
-              <a:defRPr sz="1400" b="1">
-                <a:solidFill>
-                  <a:srgbClr val="F59E0B"/>
+              <a:defRPr sz="1800" b="1">
+                <a:solidFill>
+                  <a:srgbClr val="D97706"/>
                 </a:solidFill>
               </a:defRPr>
             </a:pPr>
             <a:r>
-              <a:t>⏳ Real Future Testing</a:t>
+              <a:t>Real Future Holdout Testing</a:t>
             </a:r>
           </a:p>
           <a:p>
@@ -4256,14 +4286,14 @@
               <a:spcBef>
                 <a:spcPts val="800"/>
               </a:spcBef>
-              <a:defRPr sz="1200">
-                <a:solidFill>
-                  <a:srgbClr val="F1F5F9"/>
+              <a:defRPr sz="1500">
+                <a:solidFill>
+                  <a:srgbClr val="0F172A"/>
                 </a:solidFill>
               </a:defRPr>
             </a:pPr>
             <a:r>
-              <a:t>Trained on past years (1997–2015) and tested on unseen future years (2016–2020) to guarantee true reliability.</a:t>
+              <a:t>Trained on historical years (1997–2015, 15,404 rows) and tested on unseen future years (2016–2020, 4,285 rows).</a:t>
             </a:r>
           </a:p>
         </p:txBody>
@@ -4282,7 +4312,7 @@
     <p:bg>
       <p:bgPr>
         <a:solidFill>
-          <a:srgbClr val="0E131F"/>
+          <a:srgbClr val="F8FAFC"/>
         </a:solidFill>
         <a:effectLst/>
       </p:bgPr>
@@ -4302,8 +4332,8 @@
         </p:nvSpPr>
         <p:spPr>
           <a:xfrm>
-            <a:off x="914400" y="457200"/>
-            <a:ext cx="10332720" cy="365760"/>
+            <a:off x="822960" y="365760"/>
+            <a:ext cx="10515600" cy="320040"/>
           </a:xfrm>
           <a:prstGeom prst="rect">
             <a:avLst/>
@@ -4319,7 +4349,7 @@
             <a:pPr>
               <a:defRPr sz="1100" b="1">
                 <a:solidFill>
-                  <a:srgbClr val="10B981"/>
+                  <a:srgbClr val="059669"/>
                 </a:solidFill>
               </a:defRPr>
             </a:pPr>
@@ -4337,8 +4367,8 @@
         </p:nvSpPr>
         <p:spPr>
           <a:xfrm>
-            <a:off x="914400" y="777240"/>
-            <a:ext cx="10332720" cy="731520"/>
+            <a:off x="822960" y="640080"/>
+            <a:ext cx="10515600" cy="731520"/>
           </a:xfrm>
           <a:prstGeom prst="rect">
             <a:avLst/>
@@ -4352,9 +4382,9 @@
           <a:lstStyle/>
           <a:p>
             <a:pPr>
-              <a:defRPr sz="2600" b="1">
-                <a:solidFill>
-                  <a:srgbClr val="FFFFFF"/>
+              <a:defRPr sz="2800" b="1">
+                <a:solidFill>
+                  <a:srgbClr val="0F172A"/>
                 </a:solidFill>
               </a:defRPr>
             </a:pPr>
@@ -4373,8 +4403,8 @@
           <p:nvPr/>
         </p:nvGraphicFramePr>
         <p:xfrm>
-          <a:off x="914400" y="1645920"/>
-          <a:ext cx="10362895" cy="2468880"/>
+          <a:off x="822960" y="1463040"/>
+          <a:ext cx="10545775" cy="2651760"/>
         </p:xfrm>
         <a:graphic>
           <a:graphicData uri="http://schemas.openxmlformats.org/drawingml/2006/table">
@@ -4383,19 +4413,19 @@
                 <a:tableStyleId>{5C22544A-7EE6-4342-B048-85BDC9FD1C3A}</a:tableStyleId>
               </a:tblPr>
               <a:tblGrid>
-                <a:gridCol w="3291840"/>
+                <a:gridCol w="3474720"/>
                 <a:gridCol w="2286000"/>
                 <a:gridCol w="2286000"/>
                 <a:gridCol w="2499055"/>
               </a:tblGrid>
-              <a:tr h="493776">
+              <a:tr h="530352">
                 <a:tc>
                   <a:txBody>
                     <a:bodyPr/>
                     <a:lstStyle/>
                     <a:p>
                       <a:pPr>
-                        <a:defRPr sz="1200" b="1">
+                        <a:defRPr sz="1500" b="1">
                           <a:solidFill>
                             <a:srgbClr val="FFFFFF"/>
                           </a:solidFill>
@@ -4408,7 +4438,7 @@
                   </a:txBody>
                   <a:tcPr>
                     <a:solidFill>
-                      <a:srgbClr val="064E3B"/>
+                      <a:srgbClr val="065F46"/>
                     </a:solidFill>
                   </a:tcPr>
                 </a:tc>
@@ -4418,20 +4448,20 @@
                     <a:lstStyle/>
                     <a:p>
                       <a:pPr>
-                        <a:defRPr sz="1200" b="1">
+                        <a:defRPr sz="1500" b="1">
                           <a:solidFill>
                             <a:srgbClr val="FFFFFF"/>
                           </a:solidFill>
                         </a:defRPr>
                       </a:pPr>
                       <a:r>
-                        <a:t>Cross-Validation R²</a:t>
+                        <a:t>5-Fold CV R²</a:t>
                       </a:r>
                     </a:p>
                   </a:txBody>
                   <a:tcPr>
                     <a:solidFill>
-                      <a:srgbClr val="064E3B"/>
+                      <a:srgbClr val="065F46"/>
                     </a:solidFill>
                   </a:tcPr>
                 </a:tc>
@@ -4441,20 +4471,20 @@
                     <a:lstStyle/>
                     <a:p>
                       <a:pPr>
-                        <a:defRPr sz="1200" b="1">
+                        <a:defRPr sz="1500" b="1">
                           <a:solidFill>
                             <a:srgbClr val="FFFFFF"/>
                           </a:solidFill>
                         </a:defRPr>
                       </a:pPr>
                       <a:r>
-                        <a:t>Test Accuracy (R²)</a:t>
+                        <a:t>Holdout Test R²</a:t>
                       </a:r>
                     </a:p>
                   </a:txBody>
                   <a:tcPr>
                     <a:solidFill>
-                      <a:srgbClr val="064E3B"/>
+                      <a:srgbClr val="065F46"/>
                     </a:solidFill>
                   </a:tcPr>
                 </a:tc>
@@ -4464,34 +4494,34 @@
                     <a:lstStyle/>
                     <a:p>
                       <a:pPr>
-                        <a:defRPr sz="1200" b="1">
+                        <a:defRPr sz="1500" b="1">
                           <a:solidFill>
                             <a:srgbClr val="FFFFFF"/>
                           </a:solidFill>
                         </a:defRPr>
                       </a:pPr>
                       <a:r>
-                        <a:t>Verdict</a:t>
+                        <a:t>Status &amp; Verdict</a:t>
                       </a:r>
                     </a:p>
                   </a:txBody>
                   <a:tcPr>
                     <a:solidFill>
-                      <a:srgbClr val="064E3B"/>
+                      <a:srgbClr val="065F46"/>
                     </a:solidFill>
                   </a:tcPr>
                 </a:tc>
               </a:tr>
-              <a:tr h="493776">
+              <a:tr h="530352">
                 <a:tc>
                   <a:txBody>
                     <a:bodyPr/>
                     <a:lstStyle/>
                     <a:p>
                       <a:pPr>
-                        <a:defRPr sz="1200">
+                        <a:defRPr sz="1500">
                           <a:solidFill>
-                            <a:srgbClr val="F1F5F9"/>
+                            <a:srgbClr val="0F172A"/>
                           </a:solidFill>
                         </a:defRPr>
                       </a:pPr>
@@ -4502,7 +4532,7 @@
                   </a:txBody>
                   <a:tcPr>
                     <a:solidFill>
-                      <a:srgbClr val="182234"/>
+                      <a:srgbClr val="FFFFFF"/>
                     </a:solidFill>
                   </a:tcPr>
                 </a:tc>
@@ -4512,9 +4542,9 @@
                     <a:lstStyle/>
                     <a:p>
                       <a:pPr>
-                        <a:defRPr sz="1200">
+                        <a:defRPr sz="1500">
                           <a:solidFill>
-                            <a:srgbClr val="F1F5F9"/>
+                            <a:srgbClr val="0F172A"/>
                           </a:solidFill>
                         </a:defRPr>
                       </a:pPr>
@@ -4525,7 +4555,7 @@
                   </a:txBody>
                   <a:tcPr>
                     <a:solidFill>
-                      <a:srgbClr val="182234"/>
+                      <a:srgbClr val="FFFFFF"/>
                     </a:solidFill>
                   </a:tcPr>
                 </a:tc>
@@ -4535,9 +4565,9 @@
                     <a:lstStyle/>
                     <a:p>
                       <a:pPr>
-                        <a:defRPr sz="1200">
+                        <a:defRPr sz="1500">
                           <a:solidFill>
-                            <a:srgbClr val="F1F5F9"/>
+                            <a:srgbClr val="0F172A"/>
                           </a:solidFill>
                         </a:defRPr>
                       </a:pPr>
@@ -4548,7 +4578,7 @@
                   </a:txBody>
                   <a:tcPr>
                     <a:solidFill>
-                      <a:srgbClr val="182234"/>
+                      <a:srgbClr val="FFFFFF"/>
                     </a:solidFill>
                   </a:tcPr>
                 </a:tc>
@@ -4558,9 +4588,9 @@
                     <a:lstStyle/>
                     <a:p>
                       <a:pPr>
-                        <a:defRPr sz="1200">
+                        <a:defRPr sz="1500">
                           <a:solidFill>
-                            <a:srgbClr val="F1F5F9"/>
+                            <a:srgbClr val="0F172A"/>
                           </a:solidFill>
                         </a:defRPr>
                       </a:pPr>
@@ -4571,21 +4601,21 @@
                   </a:txBody>
                   <a:tcPr>
                     <a:solidFill>
-                      <a:srgbClr val="182234"/>
+                      <a:srgbClr val="FFFFFF"/>
                     </a:solidFill>
                   </a:tcPr>
                 </a:tc>
               </a:tr>
-              <a:tr h="493776">
+              <a:tr h="530352">
                 <a:tc>
                   <a:txBody>
                     <a:bodyPr/>
                     <a:lstStyle/>
                     <a:p>
                       <a:pPr>
-                        <a:defRPr sz="1200">
+                        <a:defRPr sz="1500">
                           <a:solidFill>
-                            <a:srgbClr val="F1F5F9"/>
+                            <a:srgbClr val="0F172A"/>
                           </a:solidFill>
                         </a:defRPr>
                       </a:pPr>
@@ -4596,7 +4626,7 @@
                   </a:txBody>
                   <a:tcPr>
                     <a:solidFill>
-                      <a:srgbClr val="182234"/>
+                      <a:srgbClr val="FFFFFF"/>
                     </a:solidFill>
                   </a:tcPr>
                 </a:tc>
@@ -4606,9 +4636,9 @@
                     <a:lstStyle/>
                     <a:p>
                       <a:pPr>
-                        <a:defRPr sz="1200">
+                        <a:defRPr sz="1500">
                           <a:solidFill>
-                            <a:srgbClr val="F1F5F9"/>
+                            <a:srgbClr val="0F172A"/>
                           </a:solidFill>
                         </a:defRPr>
                       </a:pPr>
@@ -4619,7 +4649,7 @@
                   </a:txBody>
                   <a:tcPr>
                     <a:solidFill>
-                      <a:srgbClr val="182234"/>
+                      <a:srgbClr val="FFFFFF"/>
                     </a:solidFill>
                   </a:tcPr>
                 </a:tc>
@@ -4629,9 +4659,9 @@
                     <a:lstStyle/>
                     <a:p>
                       <a:pPr>
-                        <a:defRPr sz="1200">
+                        <a:defRPr sz="1500">
                           <a:solidFill>
-                            <a:srgbClr val="F1F5F9"/>
+                            <a:srgbClr val="0F172A"/>
                           </a:solidFill>
                         </a:defRPr>
                       </a:pPr>
@@ -4642,7 +4672,7 @@
                   </a:txBody>
                   <a:tcPr>
                     <a:solidFill>
-                      <a:srgbClr val="182234"/>
+                      <a:srgbClr val="FFFFFF"/>
                     </a:solidFill>
                   </a:tcPr>
                 </a:tc>
@@ -4652,9 +4682,9 @@
                     <a:lstStyle/>
                     <a:p>
                       <a:pPr>
-                        <a:defRPr sz="1200">
+                        <a:defRPr sz="1500">
                           <a:solidFill>
-                            <a:srgbClr val="F1F5F9"/>
+                            <a:srgbClr val="0F172A"/>
                           </a:solidFill>
                         </a:defRPr>
                       </a:pPr>
@@ -4665,21 +4695,21 @@
                   </a:txBody>
                   <a:tcPr>
                     <a:solidFill>
-                      <a:srgbClr val="182234"/>
+                      <a:srgbClr val="FFFFFF"/>
                     </a:solidFill>
                   </a:tcPr>
                 </a:tc>
               </a:tr>
-              <a:tr h="493776">
+              <a:tr h="530352">
                 <a:tc>
                   <a:txBody>
                     <a:bodyPr/>
                     <a:lstStyle/>
                     <a:p>
                       <a:pPr>
-                        <a:defRPr sz="1200">
+                        <a:defRPr sz="1500">
                           <a:solidFill>
-                            <a:srgbClr val="F1F5F9"/>
+                            <a:srgbClr val="0F172A"/>
                           </a:solidFill>
                         </a:defRPr>
                       </a:pPr>
@@ -4690,7 +4720,7 @@
                   </a:txBody>
                   <a:tcPr>
                     <a:solidFill>
-                      <a:srgbClr val="182234"/>
+                      <a:srgbClr val="FFFFFF"/>
                     </a:solidFill>
                   </a:tcPr>
                 </a:tc>
@@ -4700,9 +4730,9 @@
                     <a:lstStyle/>
                     <a:p>
                       <a:pPr>
-                        <a:defRPr sz="1200">
+                        <a:defRPr sz="1500">
                           <a:solidFill>
-                            <a:srgbClr val="F1F5F9"/>
+                            <a:srgbClr val="0F172A"/>
                           </a:solidFill>
                         </a:defRPr>
                       </a:pPr>
@@ -4713,7 +4743,7 @@
                   </a:txBody>
                   <a:tcPr>
                     <a:solidFill>
-                      <a:srgbClr val="182234"/>
+                      <a:srgbClr val="FFFFFF"/>
                     </a:solidFill>
                   </a:tcPr>
                 </a:tc>
@@ -4723,9 +4753,9 @@
                     <a:lstStyle/>
                     <a:p>
                       <a:pPr>
-                        <a:defRPr sz="1200">
+                        <a:defRPr sz="1500">
                           <a:solidFill>
-                            <a:srgbClr val="F1F5F9"/>
+                            <a:srgbClr val="0F172A"/>
                           </a:solidFill>
                         </a:defRPr>
                       </a:pPr>
@@ -4736,7 +4766,7 @@
                   </a:txBody>
                   <a:tcPr>
                     <a:solidFill>
-                      <a:srgbClr val="182234"/>
+                      <a:srgbClr val="FFFFFF"/>
                     </a:solidFill>
                   </a:tcPr>
                 </a:tc>
@@ -4746,45 +4776,45 @@
                     <a:lstStyle/>
                     <a:p>
                       <a:pPr>
-                        <a:defRPr sz="1200">
+                        <a:defRPr sz="1500">
                           <a:solidFill>
-                            <a:srgbClr val="F1F5F9"/>
+                            <a:srgbClr val="0F172A"/>
                           </a:solidFill>
                         </a:defRPr>
                       </a:pPr>
                       <a:r>
-                        <a:t>High Accuracy</a:t>
+                        <a:t>Strong Non-Linear Fit</a:t>
                       </a:r>
                     </a:p>
                   </a:txBody>
                   <a:tcPr>
                     <a:solidFill>
-                      <a:srgbClr val="182234"/>
+                      <a:srgbClr val="FFFFFF"/>
                     </a:solidFill>
                   </a:tcPr>
                 </a:tc>
               </a:tr>
-              <a:tr h="493776">
+              <a:tr h="530352">
                 <a:tc>
                   <a:txBody>
                     <a:bodyPr/>
                     <a:lstStyle/>
                     <a:p>
                       <a:pPr>
-                        <a:defRPr sz="1200" b="1">
+                        <a:defRPr sz="1500" b="1">
                           <a:solidFill>
-                            <a:srgbClr val="10B981"/>
+                            <a:srgbClr val="065F46"/>
                           </a:solidFill>
                         </a:defRPr>
                       </a:pPr>
                       <a:r>
-                        <a:t>4. Random Forest Regressor 🏆</a:t>
+                        <a:t>4. Random Forest Regressor</a:t>
                       </a:r>
                     </a:p>
                   </a:txBody>
                   <a:tcPr>
                     <a:solidFill>
-                      <a:srgbClr val="104E3B"/>
+                      <a:srgbClr val="F0FDF4"/>
                     </a:solidFill>
                   </a:tcPr>
                 </a:tc>
@@ -4794,9 +4824,9 @@
                     <a:lstStyle/>
                     <a:p>
                       <a:pPr>
-                        <a:defRPr sz="1200" b="1">
+                        <a:defRPr sz="1500" b="1">
                           <a:solidFill>
-                            <a:srgbClr val="10B981"/>
+                            <a:srgbClr val="065F46"/>
                           </a:solidFill>
                         </a:defRPr>
                       </a:pPr>
@@ -4807,7 +4837,7 @@
                   </a:txBody>
                   <a:tcPr>
                     <a:solidFill>
-                      <a:srgbClr val="104E3B"/>
+                      <a:srgbClr val="F0FDF4"/>
                     </a:solidFill>
                   </a:tcPr>
                 </a:tc>
@@ -4817,9 +4847,9 @@
                     <a:lstStyle/>
                     <a:p>
                       <a:pPr>
-                        <a:defRPr sz="1200" b="1">
+                        <a:defRPr sz="1500" b="1">
                           <a:solidFill>
-                            <a:srgbClr val="10B981"/>
+                            <a:srgbClr val="065F46"/>
                           </a:solidFill>
                         </a:defRPr>
                       </a:pPr>
@@ -4830,7 +4860,7 @@
                   </a:txBody>
                   <a:tcPr>
                     <a:solidFill>
-                      <a:srgbClr val="104E3B"/>
+                      <a:srgbClr val="F0FDF4"/>
                     </a:solidFill>
                   </a:tcPr>
                 </a:tc>
@@ -4840,20 +4870,20 @@
                     <a:lstStyle/>
                     <a:p>
                       <a:pPr>
-                        <a:defRPr sz="1200" b="1">
+                        <a:defRPr sz="1500" b="1">
                           <a:solidFill>
-                            <a:srgbClr val="10B981"/>
+                            <a:srgbClr val="065F46"/>
                           </a:solidFill>
                         </a:defRPr>
                       </a:pPr>
                       <a:r>
-                        <a:t>CHAMPION MODEL</a:t>
+                        <a:t>CHAMPION MODEL (Winner)</a:t>
                       </a:r>
                     </a:p>
                   </a:txBody>
                   <a:tcPr>
                     <a:solidFill>
-                      <a:srgbClr val="104E3B"/>
+                      <a:srgbClr val="F0FDF4"/>
                     </a:solidFill>
                   </a:tcPr>
                 </a:tc>
@@ -4870,18 +4900,18 @@
         </p:nvSpPr>
         <p:spPr>
           <a:xfrm>
-            <a:off x="914400" y="4389120"/>
-            <a:ext cx="10362895" cy="1645920"/>
+            <a:off x="822960" y="4389120"/>
+            <a:ext cx="10545775" cy="1920240"/>
           </a:xfrm>
           <a:prstGeom prst="roundRect">
             <a:avLst/>
           </a:prstGeom>
           <a:solidFill>
-            <a:srgbClr val="182234"/>
+            <a:srgbClr val="FFFFFF"/>
           </a:solidFill>
-          <a:ln>
+          <a:ln w="25400">
             <a:solidFill>
-              <a:srgbClr val="10B981"/>
+              <a:srgbClr val="059669"/>
             </a:solidFill>
           </a:ln>
         </p:spPr>
@@ -4915,8 +4945,8 @@
         </p:nvSpPr>
         <p:spPr>
           <a:xfrm>
-            <a:off x="1188720" y="4480560"/>
-            <a:ext cx="9784080" cy="1371600"/>
+            <a:off x="1097280" y="4526280"/>
+            <a:ext cx="9966960" cy="1645920"/>
           </a:xfrm>
           <a:prstGeom prst="rect">
             <a:avLst/>
@@ -4930,59 +4960,59 @@
           <a:lstStyle/>
           <a:p>
             <a:pPr>
-              <a:defRPr sz="1300" b="1">
-                <a:solidFill>
-                  <a:srgbClr val="10B981"/>
+              <a:defRPr sz="1700" b="1">
+                <a:solidFill>
+                  <a:srgbClr val="065F46"/>
                 </a:solidFill>
               </a:defRPr>
             </a:pPr>
             <a:r>
-              <a:t>🎯 WHY RANDOM FOREST WON (96.8% ACCURACY):</a:t>
+              <a:t>WHY RANDOM FOREST WON (96.8% ACCURACY):</a:t>
             </a:r>
           </a:p>
           <a:p>
             <a:pPr>
               <a:spcBef>
-                <a:spcPts val="400"/>
+                <a:spcPts val="600"/>
               </a:spcBef>
-              <a:defRPr sz="1150">
-                <a:solidFill>
-                  <a:srgbClr val="F1F5F9"/>
+              <a:defRPr sz="1500">
+                <a:solidFill>
+                  <a:srgbClr val="0F172A"/>
                 </a:solidFill>
               </a:defRPr>
             </a:pPr>
             <a:r>
-              <a:t>✔  Nature is not a straight line: Doubling rain or fertilizer does NOT double crop output.</a:t>
+              <a:t>•  Nature is not a straight line: Doubling rain or fertilizer does NOT double crop output.</a:t>
             </a:r>
           </a:p>
           <a:p>
             <a:pPr>
               <a:spcBef>
-                <a:spcPts val="400"/>
+                <a:spcPts val="600"/>
               </a:spcBef>
-              <a:defRPr sz="1150">
-                <a:solidFill>
-                  <a:srgbClr val="F1F5F9"/>
+              <a:defRPr sz="1500">
+                <a:solidFill>
+                  <a:srgbClr val="0F172A"/>
                 </a:solidFill>
               </a:defRPr>
             </a:pPr>
             <a:r>
-              <a:t>✔  Random Forest uses 120 decision trees to capture real-world saturating thresholds.</a:t>
+              <a:t>•  Random Forest uses 120 decision trees to capture real-world saturating biological limits.</a:t>
             </a:r>
           </a:p>
           <a:p>
             <a:pPr>
               <a:spcBef>
-                <a:spcPts val="400"/>
+                <a:spcPts val="600"/>
               </a:spcBef>
-              <a:defRPr sz="1150">
-                <a:solidFill>
-                  <a:srgbClr val="F1F5F9"/>
+              <a:defRPr sz="1500">
+                <a:solidFill>
+                  <a:srgbClr val="0F172A"/>
                 </a:solidFill>
               </a:defRPr>
             </a:pPr>
             <a:r>
-              <a:t>✔  Combined with a log-transform to ensure predictions never return negative yield numbers.</a:t>
+              <a:t>•  Combined with a target log-transform (ln(1+y)) to guarantee positive yield predictions.</a:t>
             </a:r>
           </a:p>
         </p:txBody>
@@ -5001,7 +5031,7 @@
     <p:bg>
       <p:bgPr>
         <a:solidFill>
-          <a:srgbClr val="0E131F"/>
+          <a:srgbClr val="F8FAFC"/>
         </a:solidFill>
         <a:effectLst/>
       </p:bgPr>
@@ -5021,8 +5051,8 @@
         </p:nvSpPr>
         <p:spPr>
           <a:xfrm>
-            <a:off x="914400" y="457200"/>
-            <a:ext cx="10332720" cy="365760"/>
+            <a:off x="822960" y="365760"/>
+            <a:ext cx="10515600" cy="320040"/>
           </a:xfrm>
           <a:prstGeom prst="rect">
             <a:avLst/>
@@ -5038,7 +5068,7 @@
             <a:pPr>
               <a:defRPr sz="1100" b="1">
                 <a:solidFill>
-                  <a:srgbClr val="10B981"/>
+                  <a:srgbClr val="059669"/>
                 </a:solidFill>
               </a:defRPr>
             </a:pPr>
@@ -5056,8 +5086,8 @@
         </p:nvSpPr>
         <p:spPr>
           <a:xfrm>
-            <a:off x="914400" y="777240"/>
-            <a:ext cx="10332720" cy="731520"/>
+            <a:off x="822960" y="640080"/>
+            <a:ext cx="10515600" cy="731520"/>
           </a:xfrm>
           <a:prstGeom prst="rect">
             <a:avLst/>
@@ -5071,9 +5101,9 @@
           <a:lstStyle/>
           <a:p>
             <a:pPr>
-              <a:defRPr sz="2600" b="1">
-                <a:solidFill>
-                  <a:srgbClr val="FFFFFF"/>
+              <a:defRPr sz="2800" b="1">
+                <a:solidFill>
+                  <a:srgbClr val="0F172A"/>
                 </a:solidFill>
               </a:defRPr>
             </a:pPr>
@@ -5091,18 +5121,18 @@
         </p:nvSpPr>
         <p:spPr>
           <a:xfrm>
-            <a:off x="914400" y="1645920"/>
-            <a:ext cx="3291840" cy="4389120"/>
+            <a:off x="822960" y="1463040"/>
+            <a:ext cx="3383280" cy="4846320"/>
           </a:xfrm>
           <a:prstGeom prst="roundRect">
             <a:avLst/>
           </a:prstGeom>
           <a:solidFill>
-            <a:srgbClr val="182234"/>
+            <a:srgbClr val="FFFFFF"/>
           </a:solidFill>
-          <a:ln w="19050">
+          <a:ln w="25400">
             <a:solidFill>
-              <a:srgbClr val="10B981"/>
+              <a:srgbClr val="059669"/>
             </a:solidFill>
           </a:ln>
         </p:spPr>
@@ -5136,8 +5166,8 @@
         </p:nvSpPr>
         <p:spPr>
           <a:xfrm>
-            <a:off x="1097280" y="1828800"/>
-            <a:ext cx="2926080" cy="4023360"/>
+            <a:off x="1051560" y="1737360"/>
+            <a:ext cx="2926080" cy="4297680"/>
           </a:xfrm>
           <a:prstGeom prst="rect">
             <a:avLst/>
@@ -5151,9 +5181,9 @@
           <a:lstStyle/>
           <a:p>
             <a:pPr>
-              <a:defRPr sz="1300" b="1">
-                <a:solidFill>
-                  <a:srgbClr val="10B981"/>
+              <a:defRPr sz="1700" b="1">
+                <a:solidFill>
+                  <a:srgbClr val="059669"/>
                 </a:solidFill>
               </a:defRPr>
             </a:pPr>
@@ -5164,11 +5194,11 @@
           <a:p>
             <a:pPr>
               <a:spcBef>
-                <a:spcPts val="1400"/>
+                <a:spcPts val="1600"/>
               </a:spcBef>
-              <a:defRPr sz="1200">
-                <a:solidFill>
-                  <a:srgbClr val="F1F5F9"/>
+              <a:defRPr sz="1550">
+                <a:solidFill>
+                  <a:srgbClr val="0F172A"/>
                 </a:solidFill>
               </a:defRPr>
             </a:pPr>
@@ -5191,18 +5221,18 @@
         </p:nvSpPr>
         <p:spPr>
           <a:xfrm>
-            <a:off x="4480560" y="1645920"/>
-            <a:ext cx="3291840" cy="4389120"/>
+            <a:off x="4389120" y="1463040"/>
+            <a:ext cx="3383280" cy="4846320"/>
           </a:xfrm>
           <a:prstGeom prst="roundRect">
             <a:avLst/>
           </a:prstGeom>
           <a:solidFill>
-            <a:srgbClr val="182234"/>
+            <a:srgbClr val="FFFFFF"/>
           </a:solidFill>
-          <a:ln w="19050">
+          <a:ln w="25400">
             <a:solidFill>
-              <a:srgbClr val="38BDF8"/>
+              <a:srgbClr val="0284C7"/>
             </a:solidFill>
           </a:ln>
         </p:spPr>
@@ -5236,8 +5266,8 @@
         </p:nvSpPr>
         <p:spPr>
           <a:xfrm>
-            <a:off x="4663440" y="1828800"/>
-            <a:ext cx="2926080" cy="4023360"/>
+            <a:off x="4617720" y="1737360"/>
+            <a:ext cx="2926080" cy="4297680"/>
           </a:xfrm>
           <a:prstGeom prst="rect">
             <a:avLst/>
@@ -5251,24 +5281,24 @@
           <a:lstStyle/>
           <a:p>
             <a:pPr>
-              <a:defRPr sz="1300" b="1">
-                <a:solidFill>
-                  <a:srgbClr val="38BDF8"/>
+              <a:defRPr sz="1700" b="1">
+                <a:solidFill>
+                  <a:srgbClr val="0284C7"/>
                 </a:solidFill>
               </a:defRPr>
             </a:pPr>
             <a:r>
-              <a:t>2. FERTILIZER PARADOX</a:t>
+              <a:t>2. THE FERTILIZER PARADOX</a:t>
             </a:r>
           </a:p>
           <a:p>
             <a:pPr>
               <a:spcBef>
-                <a:spcPts val="1400"/>
+                <a:spcPts val="1600"/>
               </a:spcBef>
-              <a:defRPr sz="1200">
-                <a:solidFill>
-                  <a:srgbClr val="F1F5F9"/>
+              <a:defRPr sz="1550">
+                <a:solidFill>
+                  <a:srgbClr val="0F172A"/>
                 </a:solidFill>
               </a:defRPr>
             </a:pPr>
@@ -5278,7 +5308,7 @@
             <a:br/>
             <a:br/>
             <a:r>
-              <a:t>BUT too much fertilizer harms pulses (Dal/Moong) because pulses make their own nitrogen!</a:t>
+              <a:t>BUT excess chemical fertilizer hurts pulses (Moong/Gram) because pulses naturally fix nitrogen!</a:t>
             </a:r>
           </a:p>
         </p:txBody>
@@ -5291,18 +5321,18 @@
         </p:nvSpPr>
         <p:spPr>
           <a:xfrm>
-            <a:off x="8046720" y="1645920"/>
-            <a:ext cx="3291840" cy="4389120"/>
+            <a:off x="7955279" y="1463040"/>
+            <a:ext cx="3383280" cy="4846320"/>
           </a:xfrm>
           <a:prstGeom prst="roundRect">
             <a:avLst/>
           </a:prstGeom>
           <a:solidFill>
-            <a:srgbClr val="182234"/>
+            <a:srgbClr val="FFFFFF"/>
           </a:solidFill>
-          <a:ln w="19050">
+          <a:ln w="25400">
             <a:solidFill>
-              <a:srgbClr val="F59E0B"/>
+              <a:srgbClr val="D97706"/>
             </a:solidFill>
           </a:ln>
         </p:spPr>
@@ -5336,8 +5366,8 @@
         </p:nvSpPr>
         <p:spPr>
           <a:xfrm>
-            <a:off x="8229600" y="1828800"/>
-            <a:ext cx="2926080" cy="4023360"/>
+            <a:off x="8183879" y="1737360"/>
+            <a:ext cx="2926080" cy="4297680"/>
           </a:xfrm>
           <a:prstGeom prst="rect">
             <a:avLst/>
@@ -5351,9 +5381,9 @@
           <a:lstStyle/>
           <a:p>
             <a:pPr>
-              <a:defRPr sz="1300" b="1">
-                <a:solidFill>
-                  <a:srgbClr val="F59E0B"/>
+              <a:defRPr sz="1700" b="1">
+                <a:solidFill>
+                  <a:srgbClr val="D97706"/>
                 </a:solidFill>
               </a:defRPr>
             </a:pPr>
@@ -5364,21 +5394,21 @@
           <a:p>
             <a:pPr>
               <a:spcBef>
-                <a:spcPts val="1400"/>
+                <a:spcPts val="1600"/>
               </a:spcBef>
-              <a:defRPr sz="1200">
-                <a:solidFill>
-                  <a:srgbClr val="F1F5F9"/>
+              <a:defRPr sz="1550">
+                <a:solidFill>
+                  <a:srgbClr val="0F172A"/>
                 </a:solidFill>
               </a:defRPr>
             </a:pPr>
             <a:r>
-              <a:t>Rain helps crops up to ~2,000 mm per year.</a:t>
+              <a:t>Rain boosts crop yield up to ~2,000 mm per year.</a:t>
             </a:r>
             <a:br/>
             <a:br/>
             <a:r>
-              <a:t>Rain beyond 2,000 mm causes waterlogging and fungal disease, capping maximum crop yield.</a:t>
+              <a:t>Beyond 2,000 mm, waterlogging, root rot, and fungal disease cap maximum crop productivity.</a:t>
             </a:r>
           </a:p>
         </p:txBody>
@@ -5397,7 +5427,7 @@
     <p:bg>
       <p:bgPr>
         <a:solidFill>
-          <a:srgbClr val="0E131F"/>
+          <a:srgbClr val="F8FAFC"/>
         </a:solidFill>
         <a:effectLst/>
       </p:bgPr>
@@ -5417,8 +5447,8 @@
         </p:nvSpPr>
         <p:spPr>
           <a:xfrm>
-            <a:off x="914400" y="457200"/>
-            <a:ext cx="10332720" cy="365760"/>
+            <a:off x="822960" y="365760"/>
+            <a:ext cx="10515600" cy="320040"/>
           </a:xfrm>
           <a:prstGeom prst="rect">
             <a:avLst/>
@@ -5434,7 +5464,7 @@
             <a:pPr>
               <a:defRPr sz="1100" b="1">
                 <a:solidFill>
-                  <a:srgbClr val="10B981"/>
+                  <a:srgbClr val="059669"/>
                 </a:solidFill>
               </a:defRPr>
             </a:pPr>
@@ -5452,8 +5482,8 @@
         </p:nvSpPr>
         <p:spPr>
           <a:xfrm>
-            <a:off x="914400" y="777240"/>
-            <a:ext cx="10332720" cy="731520"/>
+            <a:off x="822960" y="640080"/>
+            <a:ext cx="10515600" cy="731520"/>
           </a:xfrm>
           <a:prstGeom prst="rect">
             <a:avLst/>
@@ -5467,14 +5497,14 @@
           <a:lstStyle/>
           <a:p>
             <a:pPr>
-              <a:defRPr sz="2600" b="1">
-                <a:solidFill>
-                  <a:srgbClr val="FFFFFF"/>
+              <a:defRPr sz="2800" b="1">
+                <a:solidFill>
+                  <a:srgbClr val="0F172A"/>
                 </a:solidFill>
               </a:defRPr>
             </a:pPr>
             <a:r>
-              <a:t>Web Dashboard &amp; Project Conclusion</a:t>
+              <a:t>Web Dashboard &amp; Implementation</a:t>
             </a:r>
           </a:p>
         </p:txBody>
@@ -5487,18 +5517,18 @@
         </p:nvSpPr>
         <p:spPr>
           <a:xfrm>
-            <a:off x="914400" y="1645920"/>
-            <a:ext cx="4937760" cy="4389120"/>
+            <a:off x="822960" y="1463040"/>
+            <a:ext cx="5120640" cy="4846320"/>
           </a:xfrm>
           <a:prstGeom prst="roundRect">
             <a:avLst/>
           </a:prstGeom>
           <a:solidFill>
-            <a:srgbClr val="182234"/>
+            <a:srgbClr val="FFFFFF"/>
           </a:solidFill>
-          <a:ln>
+          <a:ln w="25400">
             <a:solidFill>
-              <a:srgbClr val="10B981"/>
+              <a:srgbClr val="059669"/>
             </a:solidFill>
           </a:ln>
         </p:spPr>
@@ -5532,8 +5562,8 @@
         </p:nvSpPr>
         <p:spPr>
           <a:xfrm>
-            <a:off x="1188720" y="1828800"/>
-            <a:ext cx="4389120" cy="4023360"/>
+            <a:off x="1097280" y="1737360"/>
+            <a:ext cx="4572000" cy="4297680"/>
           </a:xfrm>
           <a:prstGeom prst="rect">
             <a:avLst/>
@@ -5547,104 +5577,104 @@
           <a:lstStyle/>
           <a:p>
             <a:pPr>
-              <a:defRPr sz="1400" b="1">
-                <a:solidFill>
-                  <a:srgbClr val="10B981"/>
+              <a:defRPr sz="1800" b="1">
+                <a:solidFill>
+                  <a:srgbClr val="059669"/>
                 </a:solidFill>
               </a:defRPr>
             </a:pPr>
             <a:r>
-              <a:t>💻 TECHNOLOGY STACK</a:t>
+              <a:t>TECHNOLOGY STACK</a:t>
             </a:r>
           </a:p>
           <a:p>
             <a:pPr>
               <a:spcBef>
-                <a:spcPts val="900"/>
+                <a:spcPts val="1200"/>
               </a:spcBef>
-              <a:defRPr sz="1200">
-                <a:solidFill>
-                  <a:srgbClr val="F1F5F9"/>
+              <a:defRPr sz="1500">
+                <a:solidFill>
+                  <a:srgbClr val="0F172A"/>
                 </a:solidFill>
               </a:defRPr>
             </a:pPr>
             <a:r>
-              <a:t>✔  Python: Core programming language.</a:t>
+              <a:t>• Python: Core programming language for data science.</a:t>
             </a:r>
           </a:p>
           <a:p>
             <a:pPr>
               <a:spcBef>
-                <a:spcPts val="900"/>
+                <a:spcPts val="1200"/>
               </a:spcBef>
-              <a:defRPr sz="1200">
-                <a:solidFill>
-                  <a:srgbClr val="F1F5F9"/>
+              <a:defRPr sz="1500">
+                <a:solidFill>
+                  <a:srgbClr val="0F172A"/>
                 </a:solidFill>
               </a:defRPr>
             </a:pPr>
             <a:r>
-              <a:t>✔  Pandas &amp; NumPy: Data processing &amp; cleaning.</a:t>
+              <a:t>• Pandas &amp; NumPy: Data cleaning and preprocessing.</a:t>
             </a:r>
           </a:p>
           <a:p>
             <a:pPr>
               <a:spcBef>
-                <a:spcPts val="900"/>
+                <a:spcPts val="1200"/>
               </a:spcBef>
-              <a:defRPr sz="1200">
-                <a:solidFill>
-                  <a:srgbClr val="F1F5F9"/>
+              <a:defRPr sz="1500">
+                <a:solidFill>
+                  <a:srgbClr val="0F172A"/>
                 </a:solidFill>
               </a:defRPr>
             </a:pPr>
             <a:r>
-              <a:t>✔  Scikit-Learn: Random Forest machine learning model.</a:t>
+              <a:t>• Scikit-Learn: Random Forest machine learning model.</a:t>
             </a:r>
           </a:p>
           <a:p>
             <a:pPr>
               <a:spcBef>
-                <a:spcPts val="900"/>
+                <a:spcPts val="1200"/>
               </a:spcBef>
-              <a:defRPr sz="1200">
-                <a:solidFill>
-                  <a:srgbClr val="F1F5F9"/>
+              <a:defRPr sz="1500">
+                <a:solidFill>
+                  <a:srgbClr val="0F172A"/>
                 </a:solidFill>
               </a:defRPr>
             </a:pPr>
             <a:r>
-              <a:t>✔  Streamlit: Interactive presentation web dashboard.</a:t>
+              <a:t>• Streamlit: Interactive presentation web dashboard.</a:t>
             </a:r>
           </a:p>
           <a:p>
             <a:pPr>
               <a:spcBef>
-                <a:spcPts val="900"/>
+                <a:spcPts val="1200"/>
               </a:spcBef>
-              <a:defRPr sz="1200">
-                <a:solidFill>
-                  <a:srgbClr val="F1F5F9"/>
+              <a:defRPr sz="1500">
+                <a:solidFill>
+                  <a:srgbClr val="0F172A"/>
                 </a:solidFill>
               </a:defRPr>
             </a:pPr>
             <a:r>
-              <a:t>✔  Plotly: Interactive comparison charts &amp; trends.</a:t>
+              <a:t>• Plotly: Interactive charts, trends, and comparisons.</a:t>
             </a:r>
           </a:p>
           <a:p>
             <a:pPr>
               <a:spcBef>
-                <a:spcPts val="900"/>
+                <a:spcPts val="1200"/>
               </a:spcBef>
-              <a:defRPr sz="1200">
-                <a:solidFill>
-                  <a:srgbClr val="F1F5F9"/>
+              <a:defRPr sz="1500">
+                <a:solidFill>
+                  <a:srgbClr val="0F172A"/>
                 </a:solidFill>
               </a:defRPr>
             </a:pPr>
             <a:r>
-              <a:t>✔  GitHub &amp; Streamlit Cloud: Live 24/7 global hosting.</a:t>
+              <a:t>• GitHub &amp; Streamlit Cloud: 24/7 online hosting.</a:t>
             </a:r>
           </a:p>
         </p:txBody>
@@ -5657,18 +5687,18 @@
         </p:nvSpPr>
         <p:spPr>
           <a:xfrm>
-            <a:off x="6309360" y="1645920"/>
-            <a:ext cx="4937760" cy="4389120"/>
+            <a:off x="6217920" y="1463040"/>
+            <a:ext cx="5120640" cy="4846320"/>
           </a:xfrm>
           <a:prstGeom prst="roundRect">
             <a:avLst/>
           </a:prstGeom>
           <a:solidFill>
-            <a:srgbClr val="182234"/>
+            <a:srgbClr val="FFFFFF"/>
           </a:solidFill>
-          <a:ln>
+          <a:ln w="25400">
             <a:solidFill>
-              <a:srgbClr val="38BDF8"/>
+              <a:srgbClr val="0284C7"/>
             </a:solidFill>
           </a:ln>
         </p:spPr>
@@ -5702,8 +5732,8 @@
         </p:nvSpPr>
         <p:spPr>
           <a:xfrm>
-            <a:off x="6583680" y="1828800"/>
-            <a:ext cx="4389120" cy="4023360"/>
+            <a:off x="6492240" y="1737360"/>
+            <a:ext cx="4572000" cy="4297680"/>
           </a:xfrm>
           <a:prstGeom prst="rect">
             <a:avLst/>
@@ -5717,74 +5747,74 @@
           <a:lstStyle/>
           <a:p>
             <a:pPr>
-              <a:defRPr sz="1400" b="1">
-                <a:solidFill>
-                  <a:srgbClr val="38BDF8"/>
+              <a:defRPr sz="1800" b="1">
+                <a:solidFill>
+                  <a:srgbClr val="0284C7"/>
                 </a:solidFill>
               </a:defRPr>
             </a:pPr>
             <a:r>
-              <a:t>🌾 SIMPLE OUTPUT FORMAT</a:t>
+              <a:t>SIMPLE OUTPUT FORMAT</a:t>
             </a:r>
           </a:p>
           <a:p>
             <a:pPr>
               <a:spcBef>
-                <a:spcPts val="1100"/>
+                <a:spcPts val="1400"/>
               </a:spcBef>
-              <a:defRPr sz="1200">
-                <a:solidFill>
-                  <a:srgbClr val="F1F5F9"/>
+              <a:defRPr sz="1500">
+                <a:solidFill>
+                  <a:srgbClr val="0F172A"/>
                 </a:solidFill>
               </a:defRPr>
             </a:pPr>
             <a:r>
-              <a:t>✔  Yield per Hectare: (e.g. 4.80 tonnes/ha).</a:t>
+              <a:t>• Yield per Hectare: Scientific standard unit (e.g. 4.80 t/ha).</a:t>
             </a:r>
           </a:p>
           <a:p>
             <a:pPr>
               <a:spcBef>
-                <a:spcPts val="1100"/>
+                <a:spcPts val="1400"/>
               </a:spcBef>
-              <a:defRPr sz="1200">
-                <a:solidFill>
-                  <a:srgbClr val="F1F5F9"/>
+              <a:defRPr sz="1500">
+                <a:solidFill>
+                  <a:srgbClr val="0F172A"/>
                 </a:solidFill>
               </a:defRPr>
             </a:pPr>
             <a:r>
-              <a:t>✔  Yield per Acre: (e.g. ~1.94 tonnes/acre) for local farmers.</a:t>
+              <a:t>• Yield per Acre: Practical measure for local farmers (e.g. ~1.94 t/acre).</a:t>
             </a:r>
           </a:p>
           <a:p>
             <a:pPr>
               <a:spcBef>
-                <a:spcPts val="1100"/>
+                <a:spcPts val="1400"/>
               </a:spcBef>
-              <a:defRPr sz="1200">
-                <a:solidFill>
-                  <a:srgbClr val="F1F5F9"/>
+              <a:defRPr sz="1500">
+                <a:solidFill>
+                  <a:srgbClr val="0F172A"/>
                 </a:solidFill>
               </a:defRPr>
             </a:pPr>
             <a:r>
-              <a:t>✔  Total Commercial Output: Total weight for the entire farm.</a:t>
+              <a:t>• Total Farm Harvest: Total gross tonnage expected from the entire field.</a:t>
             </a:r>
           </a:p>
           <a:p>
             <a:pPr>
               <a:spcBef>
-                <a:spcPts val="1100"/>
+                <a:spcPts val="1400"/>
               </a:spcBef>
-              <a:defRPr sz="1200">
-                <a:solidFill>
-                  <a:srgbClr val="F1F5F9"/>
+              <a:defRPr sz="1500">
+                <a:solidFill>
+                  <a:srgbClr val="0F172A"/>
                 </a:solidFill>
               </a:defRPr>
             </a:pPr>
             <a:r>
-              <a:t>✔  Commercial Truckloads: (e.g. ≈ 48 ten-tonne trucks) so farmers can easily plan transport.</a:t>
+              <a:t>• Commercial Truckloads: Estimated count of 10-tonne trucks (e.g. ≈ 48 trucks) so transport is planned easily.</a:t>
             </a:r>
           </a:p>
         </p:txBody>

</xml_diff>

<commit_message>
Add full academic review presentation with DFD, ERD, Schema, Form Design and Output Screen
</commit_message>
<xml_diff>
--- a/AgriYield_Presentation.pptx
+++ b/AgriYield_Presentation.pptx
@@ -11,6 +11,8 @@
     <p:sldId id="259" r:id="rId10"/>
     <p:sldId id="260" r:id="rId11"/>
     <p:sldId id="261" r:id="rId12"/>
+    <p:sldId id="262" r:id="rId13"/>
+    <p:sldId id="263" r:id="rId14"/>
   </p:sldIdLst>
   <p:sldSz cx="12191695" cy="6858000" type="screen4x3"/>
   <p:notesSz cx="6858000" cy="9144000"/>
@@ -3169,14 +3171,18 @@
           <a:lstStyle/>
           <a:p>
             <a:pPr>
-              <a:defRPr sz="3600" b="1">
+              <a:defRPr sz="3200" b="1">
                 <a:solidFill>
                   <a:srgbClr val="065F46"/>
                 </a:solidFill>
               </a:defRPr>
             </a:pPr>
             <a:r>
-              <a:t>AgriYield: Crop Yield Prediction System</a:t>
+              <a:t>AgriYield: Data Science-Based Crop Yield</a:t>
+            </a:r>
+            <a:br/>
+            <a:r>
+              <a:t>Analysis and Prediction</a:t>
             </a:r>
           </a:p>
           <a:p>
@@ -3184,14 +3190,14 @@
               <a:spcBef>
                 <a:spcPts val="600"/>
               </a:spcBef>
-              <a:defRPr sz="1800">
+              <a:defRPr sz="1600">
                 <a:solidFill>
                   <a:srgbClr val="334155"/>
                 </a:solidFill>
               </a:defRPr>
             </a:pPr>
             <a:r>
-              <a:t>Data Science-Based Agricultural Analysis &amp; Pre-Harvest Machine Learning Forecasting</a:t>
+              <a:t>Academic Project Review  •  Machine Learning &amp; Web Dashboard Interface</a:t>
             </a:r>
           </a:p>
         </p:txBody>
@@ -3204,7 +3210,7 @@
         </p:nvSpPr>
         <p:spPr>
           <a:xfrm>
-            <a:off x="822960" y="2926080"/>
+            <a:off x="822960" y="3017520"/>
             <a:ext cx="5486400" cy="3291840"/>
           </a:xfrm>
           <a:prstGeom prst="roundRect">
@@ -3249,7 +3255,7 @@
         </p:nvSpPr>
         <p:spPr>
           <a:xfrm>
-            <a:off x="1097280" y="3154680"/>
+            <a:off x="1097280" y="3246120"/>
             <a:ext cx="4937760" cy="2834640"/>
           </a:xfrm>
           <a:prstGeom prst="rect">
@@ -3316,7 +3322,7 @@
               </a:defRPr>
             </a:pPr>
             <a:r>
-              <a:t>Data Science &amp; Machine Learning Investigation</a:t>
+              <a:t>Department of Computer Science &amp; Engineering</a:t>
             </a:r>
           </a:p>
         </p:txBody>
@@ -3329,7 +3335,7 @@
         </p:nvSpPr>
         <p:spPr>
           <a:xfrm>
-            <a:off x="6583680" y="2926080"/>
+            <a:off x="6583680" y="3017520"/>
             <a:ext cx="4754880" cy="3291840"/>
           </a:xfrm>
           <a:prstGeom prst="roundRect">
@@ -3374,7 +3380,7 @@
         </p:nvSpPr>
         <p:spPr>
           <a:xfrm>
-            <a:off x="6858000" y="3154680"/>
+            <a:off x="6858000" y="3246120"/>
             <a:ext cx="4206240" cy="2834640"/>
           </a:xfrm>
           <a:prstGeom prst="rect">
@@ -3396,7 +3402,7 @@
               </a:defRPr>
             </a:pPr>
             <a:r>
-              <a:t>KEY PROJECT HIGHLIGHTS</a:t>
+              <a:t>PROJECT HIGHLIGHTS</a:t>
             </a:r>
           </a:p>
           <a:p>
@@ -3404,14 +3410,14 @@
               <a:spcBef>
                 <a:spcPts val="800"/>
               </a:spcBef>
-              <a:defRPr sz="1450" b="1">
+              <a:defRPr sz="1400" b="1">
                 <a:solidFill>
                   <a:srgbClr val="0F172A"/>
                 </a:solidFill>
               </a:defRPr>
             </a:pPr>
             <a:r>
-              <a:t>•  19,689 Real Census Records (1997–2020)</a:t>
+              <a:t>•  Dataset Scope: 19,689 Records (1997–2020)</a:t>
             </a:r>
           </a:p>
           <a:p>
@@ -3419,14 +3425,14 @@
               <a:spcBef>
                 <a:spcPts val="800"/>
               </a:spcBef>
-              <a:defRPr sz="1450" b="1">
+              <a:defRPr sz="1400" b="1">
                 <a:solidFill>
                   <a:srgbClr val="0F172A"/>
                 </a:solidFill>
               </a:defRPr>
             </a:pPr>
             <a:r>
-              <a:t>•  55 Crops &amp; 30 Indian States Nationwide</a:t>
+              <a:t>•  Coverage: 55 Crops across 30 Indian States</a:t>
             </a:r>
           </a:p>
           <a:p>
@@ -3434,7 +3440,7 @@
               <a:spcBef>
                 <a:spcPts val="800"/>
               </a:spcBef>
-              <a:defRPr sz="1450" b="1">
+              <a:defRPr sz="1400" b="1">
                 <a:solidFill>
                   <a:srgbClr val="0F172A"/>
                 </a:solidFill>
@@ -3449,14 +3455,14 @@
               <a:spcBef>
                 <a:spcPts val="800"/>
               </a:spcBef>
-              <a:defRPr sz="1450" b="1">
+              <a:defRPr sz="1400" b="1">
                 <a:solidFill>
                   <a:srgbClr val="0F172A"/>
                 </a:solidFill>
               </a:defRPr>
             </a:pPr>
             <a:r>
-              <a:t>•  Predictive Accuracy: 96.8% (R² Score)</a:t>
+              <a:t>•  Holdout Accuracy: 96.8% (R² Score)</a:t>
             </a:r>
           </a:p>
           <a:p>
@@ -3464,7 +3470,7 @@
               <a:spcBef>
                 <a:spcPts val="800"/>
               </a:spcBef>
-              <a:defRPr sz="1450" b="1">
+              <a:defRPr sz="1400" b="1">
                 <a:solidFill>
                   <a:srgbClr val="0F172A"/>
                 </a:solidFill>
@@ -3510,8 +3516,8 @@
         </p:nvSpPr>
         <p:spPr>
           <a:xfrm>
-            <a:off x="822960" y="365760"/>
-            <a:ext cx="10515600" cy="320040"/>
+            <a:off x="822960" y="320040"/>
+            <a:ext cx="10515600" cy="274320"/>
           </a:xfrm>
           <a:prstGeom prst="rect">
             <a:avLst/>
@@ -3525,14 +3531,14 @@
           <a:lstStyle/>
           <a:p>
             <a:pPr>
-              <a:defRPr sz="1100" b="1">
+              <a:defRPr sz="1050" b="1">
                 <a:solidFill>
                   <a:srgbClr val="059669"/>
                 </a:solidFill>
               </a:defRPr>
             </a:pPr>
             <a:r>
-              <a:t>AGRIYIELD  •  SLIDE 2 OF 6</a:t>
+              <a:t>AGRIYIELD  •  SLIDE 2 OF 8</a:t>
             </a:r>
           </a:p>
         </p:txBody>
@@ -3545,8 +3551,8 @@
         </p:nvSpPr>
         <p:spPr>
           <a:xfrm>
-            <a:off x="822960" y="640080"/>
-            <a:ext cx="10515600" cy="731520"/>
+            <a:off x="822960" y="594360"/>
+            <a:ext cx="10515600" cy="685800"/>
           </a:xfrm>
           <a:prstGeom prst="rect">
             <a:avLst/>
@@ -3560,14 +3566,14 @@
           <a:lstStyle/>
           <a:p>
             <a:pPr>
-              <a:defRPr sz="2800" b="1">
+              <a:defRPr sz="2600" b="1">
                 <a:solidFill>
                   <a:srgbClr val="0F172A"/>
                 </a:solidFill>
               </a:defRPr>
             </a:pPr>
             <a:r>
-              <a:t>The Real-World Problem &amp; Our Solution</a:t>
+              <a:t>Synopsis of Project</a:t>
             </a:r>
           </a:p>
         </p:txBody>
@@ -3580,18 +3586,18 @@
         </p:nvSpPr>
         <p:spPr>
           <a:xfrm>
-            <a:off x="822960" y="1463040"/>
-            <a:ext cx="5120640" cy="4846320"/>
+            <a:off x="822960" y="1371600"/>
+            <a:ext cx="3383280" cy="4937760"/>
           </a:xfrm>
           <a:prstGeom prst="roundRect">
             <a:avLst/>
           </a:prstGeom>
           <a:solidFill>
-            <a:srgbClr val="FEF2F2"/>
+            <a:srgbClr val="FFFFFF"/>
           </a:solidFill>
           <a:ln w="25400">
             <a:solidFill>
-              <a:srgbClr val="DC2626"/>
+              <a:srgbClr val="059669"/>
             </a:solidFill>
           </a:ln>
         </p:spPr>
@@ -3625,8 +3631,8 @@
         </p:nvSpPr>
         <p:spPr>
           <a:xfrm>
-            <a:off x="1097280" y="1737360"/>
-            <a:ext cx="4572000" cy="4297680"/>
+            <a:off x="1051560" y="1600200"/>
+            <a:ext cx="2926080" cy="4389120"/>
           </a:xfrm>
           <a:prstGeom prst="rect">
             <a:avLst/>
@@ -3640,59 +3646,29 @@
           <a:lstStyle/>
           <a:p>
             <a:pPr>
-              <a:defRPr sz="1800" b="1">
-                <a:solidFill>
-                  <a:srgbClr val="DC2626"/>
+              <a:defRPr sz="1600" b="1">
+                <a:solidFill>
+                  <a:srgbClr val="059669"/>
                 </a:solidFill>
               </a:defRPr>
             </a:pPr>
             <a:r>
-              <a:t>THE PROBLEM TODAY</a:t>
+              <a:t>PROJECT ABSTRACT</a:t>
             </a:r>
           </a:p>
           <a:p>
             <a:pPr>
               <a:spcBef>
-                <a:spcPts val="1600"/>
+                <a:spcPts val="1400"/>
               </a:spcBef>
-              <a:defRPr sz="1550">
+              <a:defRPr sz="1400">
                 <a:solidFill>
                   <a:srgbClr val="0F172A"/>
                 </a:solidFill>
               </a:defRPr>
             </a:pPr>
             <a:r>
-              <a:t>• Post-Harvest Delay: Yield is only measured after harvesting is completely finished through slow manual crop-cutting.</a:t>
-            </a:r>
-          </a:p>
-          <a:p>
-            <a:pPr>
-              <a:spcBef>
-                <a:spcPts val="1600"/>
-              </a:spcBef>
-              <a:defRPr sz="1550">
-                <a:solidFill>
-                  <a:srgbClr val="0F172A"/>
-                </a:solidFill>
-              </a:defRPr>
-            </a:pPr>
-            <a:r>
-              <a:t>• Too Late for Action: When food shortages occur, prices have already spiked and inflation has hurt citizens.</a:t>
-            </a:r>
-          </a:p>
-          <a:p>
-            <a:pPr>
-              <a:spcBef>
-                <a:spcPts val="1600"/>
-              </a:spcBef>
-              <a:defRPr sz="1550">
-                <a:solidFill>
-                  <a:srgbClr val="0F172A"/>
-                </a:solidFill>
-              </a:defRPr>
-            </a:pPr>
-            <a:r>
-              <a:t>• No Advance Planning: Farmers and transport operators cannot plan trucks, storage, or sales months in advance.</a:t>
+              <a:t>AgriYield is a machine learning data science system designed to accurately forecast crop yield prior to harvest. Using 24 years of longitudinal agricultural census records across India, the system captures non-linear relationships between crop species, soil-climate factors, and agricultural inputs to produce reliable harvest estimates.</a:t>
             </a:r>
           </a:p>
         </p:txBody>
@@ -3705,18 +3681,18 @@
         </p:nvSpPr>
         <p:spPr>
           <a:xfrm>
-            <a:off x="6217920" y="1463040"/>
-            <a:ext cx="5120640" cy="4846320"/>
+            <a:off x="4389120" y="1371600"/>
+            <a:ext cx="3383280" cy="4937760"/>
           </a:xfrm>
           <a:prstGeom prst="roundRect">
             <a:avLst/>
           </a:prstGeom>
           <a:solidFill>
-            <a:srgbClr val="F0FDF4"/>
+            <a:srgbClr val="FFFFFF"/>
           </a:solidFill>
           <a:ln w="25400">
             <a:solidFill>
-              <a:srgbClr val="059669"/>
+              <a:srgbClr val="0284C7"/>
             </a:solidFill>
           </a:ln>
         </p:spPr>
@@ -3750,8 +3726,8 @@
         </p:nvSpPr>
         <p:spPr>
           <a:xfrm>
-            <a:off x="6492240" y="1737360"/>
-            <a:ext cx="4572000" cy="4297680"/>
+            <a:off x="4617720" y="1600200"/>
+            <a:ext cx="2926080" cy="4389120"/>
           </a:xfrm>
           <a:prstGeom prst="rect">
             <a:avLst/>
@@ -3765,59 +3741,132 @@
           <a:lstStyle/>
           <a:p>
             <a:pPr>
-              <a:defRPr sz="1800" b="1">
-                <a:solidFill>
-                  <a:srgbClr val="059669"/>
+              <a:defRPr sz="1600" b="1">
+                <a:solidFill>
+                  <a:srgbClr val="0284C7"/>
                 </a:solidFill>
               </a:defRPr>
             </a:pPr>
             <a:r>
-              <a:t>THE AGRIYIELD SOLUTION</a:t>
+              <a:t>PROBLEM STATEMENT</a:t>
             </a:r>
           </a:p>
           <a:p>
             <a:pPr>
               <a:spcBef>
-                <a:spcPts val="1600"/>
+                <a:spcPts val="1400"/>
               </a:spcBef>
-              <a:defRPr sz="1550">
+              <a:defRPr sz="1400">
                 <a:solidFill>
                   <a:srgbClr val="0F172A"/>
                 </a:solidFill>
               </a:defRPr>
             </a:pPr>
             <a:r>
-              <a:t>• Pre-Harvest AI Forecasting: Predicts crop harvest months in advance using data available during planting season.</a:t>
+              <a:t>Traditional agricultural yield estimation relies on manual crop-cutting experiments conducted after harvest. This results in delayed reporting, preventing timely food security interventions, logistics coordination, and market price stabilization.</a:t>
+            </a:r>
+          </a:p>
+        </p:txBody>
+      </p:sp>
+      <p:sp>
+        <p:nvSpPr>
+          <p:cNvPr id="8" name="Rounded Rectangle 7"/>
+          <p:cNvSpPr/>
+          <p:nvPr/>
+        </p:nvSpPr>
+        <p:spPr>
+          <a:xfrm>
+            <a:off x="7955279" y="1371600"/>
+            <a:ext cx="3383280" cy="4937760"/>
+          </a:xfrm>
+          <a:prstGeom prst="roundRect">
+            <a:avLst/>
+          </a:prstGeom>
+          <a:solidFill>
+            <a:srgbClr val="FFFFFF"/>
+          </a:solidFill>
+          <a:ln w="25400">
+            <a:solidFill>
+              <a:srgbClr val="7C3AED"/>
+            </a:solidFill>
+          </a:ln>
+        </p:spPr>
+        <p:style>
+          <a:lnRef idx="1">
+            <a:schemeClr val="accent1"/>
+          </a:lnRef>
+          <a:fillRef idx="3">
+            <a:schemeClr val="accent1"/>
+          </a:fillRef>
+          <a:effectRef idx="2">
+            <a:schemeClr val="accent1"/>
+          </a:effectRef>
+          <a:fontRef idx="minor">
+            <a:schemeClr val="lt1"/>
+          </a:fontRef>
+        </p:style>
+        <p:txBody>
+          <a:bodyPr rtlCol="0" anchor="ctr"/>
+          <a:lstStyle/>
+          <a:p>
+            <a:pPr algn="ctr"/>
+          </a:p>
+        </p:txBody>
+      </p:sp>
+      <p:sp>
+        <p:nvSpPr>
+          <p:cNvPr id="9" name="TextBox 8"/>
+          <p:cNvSpPr txBox="1"/>
+          <p:nvPr/>
+        </p:nvSpPr>
+        <p:spPr>
+          <a:xfrm>
+            <a:off x="8183879" y="1600200"/>
+            <a:ext cx="2926080" cy="4389120"/>
+          </a:xfrm>
+          <a:prstGeom prst="rect">
+            <a:avLst/>
+          </a:prstGeom>
+          <a:noFill/>
+        </p:spPr>
+        <p:txBody>
+          <a:bodyPr wrap="square">
+            <a:spAutoFit/>
+          </a:bodyPr>
+          <a:lstStyle/>
+          <a:p>
+            <a:pPr>
+              <a:defRPr sz="1600" b="1">
+                <a:solidFill>
+                  <a:srgbClr val="7C3AED"/>
+                </a:solidFill>
+              </a:defRPr>
+            </a:pPr>
+            <a:r>
+              <a:t>OBJECTIVES &amp; SCOPE</a:t>
             </a:r>
           </a:p>
           <a:p>
             <a:pPr>
               <a:spcBef>
-                <a:spcPts val="1600"/>
+                <a:spcPts val="1400"/>
               </a:spcBef>
-              <a:defRPr sz="1550">
+              <a:defRPr sz="1400">
                 <a:solidFill>
                   <a:srgbClr val="0F172A"/>
                 </a:solidFill>
               </a:defRPr>
             </a:pPr>
             <a:r>
-              <a:t>• Practical Input Factors: Uses annual rainfall, fertilizer amount, pesticide, land area, and crop genetics.</a:t>
-            </a:r>
-          </a:p>
-          <a:p>
-            <a:pPr>
-              <a:spcBef>
-                <a:spcPts val="1600"/>
-              </a:spcBef>
-              <a:defRPr sz="1550">
-                <a:solidFill>
-                  <a:srgbClr val="0F172A"/>
-                </a:solidFill>
-              </a:defRPr>
-            </a:pPr>
-            <a:r>
-              <a:t>• Farmer-Friendly Outputs: Translates mathematical yield into practical tonnes per acre and commercial truckload counts.</a:t>
+              <a:t>• Predict crop yield (Tonnes/Ha) months before harvest using pre-sowing factors.</a:t>
+            </a:r>
+            <a:br/>
+            <a:r>
+              <a:t>• Prevent target data leakage by strictly excluding post-harvest production.</a:t>
+            </a:r>
+            <a:br/>
+            <a:r>
+              <a:t>• Deploy a farmer-friendly web dashboard providing acre yields and truckload counts.</a:t>
             </a:r>
           </a:p>
         </p:txBody>
@@ -3856,8 +3905,8 @@
         </p:nvSpPr>
         <p:spPr>
           <a:xfrm>
-            <a:off x="822960" y="365760"/>
-            <a:ext cx="10515600" cy="320040"/>
+            <a:off x="822960" y="320040"/>
+            <a:ext cx="10515600" cy="274320"/>
           </a:xfrm>
           <a:prstGeom prst="rect">
             <a:avLst/>
@@ -3871,14 +3920,14 @@
           <a:lstStyle/>
           <a:p>
             <a:pPr>
-              <a:defRPr sz="1100" b="1">
+              <a:defRPr sz="1050" b="1">
                 <a:solidFill>
                   <a:srgbClr val="059669"/>
                 </a:solidFill>
               </a:defRPr>
             </a:pPr>
             <a:r>
-              <a:t>AGRIYIELD  •  SLIDE 3 OF 6</a:t>
+              <a:t>AGRIYIELD  •  SLIDE 3 OF 8</a:t>
             </a:r>
           </a:p>
         </p:txBody>
@@ -3891,8 +3940,8 @@
         </p:nvSpPr>
         <p:spPr>
           <a:xfrm>
-            <a:off x="822960" y="640080"/>
-            <a:ext cx="10515600" cy="731520"/>
+            <a:off x="822960" y="594360"/>
+            <a:ext cx="10515600" cy="685800"/>
           </a:xfrm>
           <a:prstGeom prst="rect">
             <a:avLst/>
@@ -3906,14 +3955,14 @@
           <a:lstStyle/>
           <a:p>
             <a:pPr>
-              <a:defRPr sz="2800" b="1">
+              <a:defRPr sz="2600" b="1">
                 <a:solidFill>
                   <a:srgbClr val="0F172A"/>
                 </a:solidFill>
               </a:defRPr>
             </a:pPr>
             <a:r>
-              <a:t>Dataset Scope &amp; Zero Data Leakage</a:t>
+              <a:t>Module Description</a:t>
             </a:r>
           </a:p>
         </p:txBody>
@@ -3926,8 +3975,8 @@
         </p:nvSpPr>
         <p:spPr>
           <a:xfrm>
-            <a:off x="822960" y="1463040"/>
-            <a:ext cx="5120640" cy="2286000"/>
+            <a:off x="822960" y="1371600"/>
+            <a:ext cx="10545775" cy="868680"/>
           </a:xfrm>
           <a:prstGeom prst="roundRect">
             <a:avLst/>
@@ -3935,7 +3984,7 @@
           <a:solidFill>
             <a:srgbClr val="FFFFFF"/>
           </a:solidFill>
-          <a:ln w="25400">
+          <a:ln w="19050">
             <a:solidFill>
               <a:srgbClr val="059669"/>
             </a:solidFill>
@@ -3971,8 +4020,8 @@
         </p:nvSpPr>
         <p:spPr>
           <a:xfrm>
-            <a:off x="1097280" y="1645920"/>
-            <a:ext cx="4572000" cy="1920240"/>
+            <a:off x="1005840" y="1463040"/>
+            <a:ext cx="10149840" cy="685800"/>
           </a:xfrm>
           <a:prstGeom prst="rect">
             <a:avLst/>
@@ -3986,29 +4035,29 @@
           <a:lstStyle/>
           <a:p>
             <a:pPr>
-              <a:defRPr sz="1800" b="1">
+              <a:defRPr sz="1500" b="1">
                 <a:solidFill>
                   <a:srgbClr val="059669"/>
                 </a:solidFill>
               </a:defRPr>
             </a:pPr>
             <a:r>
-              <a:t>19,689 Records</a:t>
+              <a:t>Module 1: Data Ingestion &amp; Audit</a:t>
             </a:r>
           </a:p>
           <a:p>
             <a:pPr>
               <a:spcBef>
-                <a:spcPts val="800"/>
+                <a:spcPts val="300"/>
               </a:spcBef>
-              <a:defRPr sz="1500">
+              <a:defRPr sz="1250">
                 <a:solidFill>
                   <a:srgbClr val="0F172A"/>
                 </a:solidFill>
               </a:defRPr>
             </a:pPr>
             <a:r>
-              <a:t>24 Years of official Indian farm census records (1997 to 2020) collected from the Ministry of Agriculture &amp; IMD.</a:t>
+              <a:t>Loads 19,689 census records from Ministry of Agriculture &amp; IMD. Validates schema, strips categorical whitespaces, handles zero yields, and isolates Coconut unit scales.</a:t>
             </a:r>
           </a:p>
         </p:txBody>
@@ -4021,8 +4070,8 @@
         </p:nvSpPr>
         <p:spPr>
           <a:xfrm>
-            <a:off x="6217920" y="1463040"/>
-            <a:ext cx="5120640" cy="2286000"/>
+            <a:off x="822960" y="2359152"/>
+            <a:ext cx="10545775" cy="868680"/>
           </a:xfrm>
           <a:prstGeom prst="roundRect">
             <a:avLst/>
@@ -4030,7 +4079,7 @@
           <a:solidFill>
             <a:srgbClr val="FFFFFF"/>
           </a:solidFill>
-          <a:ln w="25400">
+          <a:ln w="19050">
             <a:solidFill>
               <a:srgbClr val="0284C7"/>
             </a:solidFill>
@@ -4066,8 +4115,8 @@
         </p:nvSpPr>
         <p:spPr>
           <a:xfrm>
-            <a:off x="6492240" y="1645920"/>
-            <a:ext cx="4572000" cy="1920240"/>
+            <a:off x="1005840" y="2450592"/>
+            <a:ext cx="10149840" cy="685800"/>
           </a:xfrm>
           <a:prstGeom prst="rect">
             <a:avLst/>
@@ -4081,29 +4130,29 @@
           <a:lstStyle/>
           <a:p>
             <a:pPr>
-              <a:defRPr sz="1800" b="1">
+              <a:defRPr sz="1500" b="1">
                 <a:solidFill>
                   <a:srgbClr val="0284C7"/>
                 </a:solidFill>
               </a:defRPr>
             </a:pPr>
             <a:r>
-              <a:t>55 Crops &amp; 30 States</a:t>
+              <a:t>Module 2: Feature Engineering &amp; Leakage Defense</a:t>
             </a:r>
           </a:p>
           <a:p>
             <a:pPr>
               <a:spcBef>
-                <a:spcPts val="800"/>
+                <a:spcPts val="300"/>
               </a:spcBef>
-              <a:defRPr sz="1500">
+              <a:defRPr sz="1250">
                 <a:solidFill>
                   <a:srgbClr val="0F172A"/>
                 </a:solidFill>
               </a:defRPr>
             </a:pPr>
             <a:r>
-              <a:t>Wide coverage across food grains (Rice, Wheat), pulses (Gram, Moong), oilseeds, and heavy cash crops (Sugarcane).</a:t>
+              <a:t>Calculates Fertilizer/Area and Pesticide/Area rates. Strictly eliminates 'Production' to prevent mathematical leakage. Applies robust log-transforms.</a:t>
             </a:r>
           </a:p>
         </p:txBody>
@@ -4116,8 +4165,8 @@
         </p:nvSpPr>
         <p:spPr>
           <a:xfrm>
-            <a:off x="822960" y="3931920"/>
-            <a:ext cx="5120640" cy="2286000"/>
+            <a:off x="822960" y="3346704"/>
+            <a:ext cx="10545775" cy="868680"/>
           </a:xfrm>
           <a:prstGeom prst="roundRect">
             <a:avLst/>
@@ -4125,7 +4174,7 @@
           <a:solidFill>
             <a:srgbClr val="FFFFFF"/>
           </a:solidFill>
-          <a:ln w="25400">
+          <a:ln w="19050">
             <a:solidFill>
               <a:srgbClr val="7C3AED"/>
             </a:solidFill>
@@ -4161,8 +4210,8 @@
         </p:nvSpPr>
         <p:spPr>
           <a:xfrm>
-            <a:off x="1097280" y="4114800"/>
-            <a:ext cx="4572000" cy="1920240"/>
+            <a:off x="1005840" y="3438144"/>
+            <a:ext cx="10149840" cy="685800"/>
           </a:xfrm>
           <a:prstGeom prst="rect">
             <a:avLst/>
@@ -4176,29 +4225,29 @@
           <a:lstStyle/>
           <a:p>
             <a:pPr>
-              <a:defRPr sz="1800" b="1">
+              <a:defRPr sz="1500" b="1">
                 <a:solidFill>
                   <a:srgbClr val="7C3AED"/>
                 </a:solidFill>
               </a:defRPr>
             </a:pPr>
             <a:r>
-              <a:t>Zero Data Leakage Protocol</a:t>
+              <a:t>Module 3: Model Training &amp; Evaluation</a:t>
             </a:r>
           </a:p>
           <a:p>
             <a:pPr>
               <a:spcBef>
-                <a:spcPts val="800"/>
+                <a:spcPts val="300"/>
               </a:spcBef>
-              <a:defRPr sz="1500">
+              <a:defRPr sz="1250">
                 <a:solidFill>
                   <a:srgbClr val="0F172A"/>
                 </a:solidFill>
               </a:defRPr>
             </a:pPr>
             <a:r>
-              <a:t>Strictly excluded 'Total Production' because Yield = Production / Area. If included, the AI would cheat by dividing instead of predicting.</a:t>
+              <a:t>Executes temporal train/test split (1997–2015 train vs 2016–2020 test). Benchmarks Ridge, Decision Tree, Gradient Boosting, and Random Forest.</a:t>
             </a:r>
           </a:p>
         </p:txBody>
@@ -4211,8 +4260,8 @@
         </p:nvSpPr>
         <p:spPr>
           <a:xfrm>
-            <a:off x="6217920" y="3931920"/>
-            <a:ext cx="5120640" cy="2286000"/>
+            <a:off x="822960" y="4334256"/>
+            <a:ext cx="10545775" cy="868680"/>
           </a:xfrm>
           <a:prstGeom prst="roundRect">
             <a:avLst/>
@@ -4220,7 +4269,7 @@
           <a:solidFill>
             <a:srgbClr val="FFFFFF"/>
           </a:solidFill>
-          <a:ln w="25400">
+          <a:ln w="19050">
             <a:solidFill>
               <a:srgbClr val="D97706"/>
             </a:solidFill>
@@ -4256,8 +4305,8 @@
         </p:nvSpPr>
         <p:spPr>
           <a:xfrm>
-            <a:off x="6492240" y="4114800"/>
-            <a:ext cx="4572000" cy="1920240"/>
+            <a:off x="1005840" y="4425696"/>
+            <a:ext cx="10149840" cy="685800"/>
           </a:xfrm>
           <a:prstGeom prst="rect">
             <a:avLst/>
@@ -4271,29 +4320,124 @@
           <a:lstStyle/>
           <a:p>
             <a:pPr>
-              <a:defRPr sz="1800" b="1">
+              <a:defRPr sz="1500" b="1">
                 <a:solidFill>
                   <a:srgbClr val="D97706"/>
                 </a:solidFill>
               </a:defRPr>
             </a:pPr>
             <a:r>
-              <a:t>Real Future Holdout Testing</a:t>
+              <a:t>Module 4: Prediction &amp; Agronomic Inference</a:t>
             </a:r>
           </a:p>
           <a:p>
             <a:pPr>
               <a:spcBef>
-                <a:spcPts val="800"/>
+                <a:spcPts val="300"/>
               </a:spcBef>
-              <a:defRPr sz="1500">
+              <a:defRPr sz="1250">
                 <a:solidFill>
                   <a:srgbClr val="0F172A"/>
                 </a:solidFill>
               </a:defRPr>
             </a:pPr>
             <a:r>
-              <a:t>Trained on historical years (1997–2015, 15,404 rows) and tested on unseen future years (2016–2020, 4,285 rows).</a:t>
+              <a:t>Accepts user inputs, passes through the serialized pipeline, and outputs predicted yield, 90% confidence weather intervals, and regional benchmarks.</a:t>
+            </a:r>
+          </a:p>
+        </p:txBody>
+      </p:sp>
+      <p:sp>
+        <p:nvSpPr>
+          <p:cNvPr id="12" name="Rounded Rectangle 11"/>
+          <p:cNvSpPr/>
+          <p:nvPr/>
+        </p:nvSpPr>
+        <p:spPr>
+          <a:xfrm>
+            <a:off x="822960" y="5321808"/>
+            <a:ext cx="10545775" cy="868680"/>
+          </a:xfrm>
+          <a:prstGeom prst="roundRect">
+            <a:avLst/>
+          </a:prstGeom>
+          <a:solidFill>
+            <a:srgbClr val="FFFFFF"/>
+          </a:solidFill>
+          <a:ln w="19050">
+            <a:solidFill>
+              <a:srgbClr val="0D9488"/>
+            </a:solidFill>
+          </a:ln>
+        </p:spPr>
+        <p:style>
+          <a:lnRef idx="1">
+            <a:schemeClr val="accent1"/>
+          </a:lnRef>
+          <a:fillRef idx="3">
+            <a:schemeClr val="accent1"/>
+          </a:fillRef>
+          <a:effectRef idx="2">
+            <a:schemeClr val="accent1"/>
+          </a:effectRef>
+          <a:fontRef idx="minor">
+            <a:schemeClr val="lt1"/>
+          </a:fontRef>
+        </p:style>
+        <p:txBody>
+          <a:bodyPr rtlCol="0" anchor="ctr"/>
+          <a:lstStyle/>
+          <a:p>
+            <a:pPr algn="ctr"/>
+          </a:p>
+        </p:txBody>
+      </p:sp>
+      <p:sp>
+        <p:nvSpPr>
+          <p:cNvPr id="13" name="TextBox 12"/>
+          <p:cNvSpPr txBox="1"/>
+          <p:nvPr/>
+        </p:nvSpPr>
+        <p:spPr>
+          <a:xfrm>
+            <a:off x="1005840" y="5413248"/>
+            <a:ext cx="10149840" cy="685800"/>
+          </a:xfrm>
+          <a:prstGeom prst="rect">
+            <a:avLst/>
+          </a:prstGeom>
+          <a:noFill/>
+        </p:spPr>
+        <p:txBody>
+          <a:bodyPr wrap="square">
+            <a:spAutoFit/>
+          </a:bodyPr>
+          <a:lstStyle/>
+          <a:p>
+            <a:pPr>
+              <a:defRPr sz="1500" b="1">
+                <a:solidFill>
+                  <a:srgbClr val="0D9488"/>
+                </a:solidFill>
+              </a:defRPr>
+            </a:pPr>
+            <a:r>
+              <a:t>Module 5: Executive Web Dashboard</a:t>
+            </a:r>
+          </a:p>
+          <a:p>
+            <a:pPr>
+              <a:spcBef>
+                <a:spcPts val="300"/>
+              </a:spcBef>
+              <a:defRPr sz="1250">
+                <a:solidFill>
+                  <a:srgbClr val="0F172A"/>
+                </a:solidFill>
+              </a:defRPr>
+            </a:pPr>
+            <a:r>
+              <a:t>Streamlit presentation layer with quick scenarios, dynamic metric cards, Plotly comparison charts, and plain-language harvest summaries.</a:t>
             </a:r>
           </a:p>
         </p:txBody>
@@ -4332,8 +4476,8 @@
         </p:nvSpPr>
         <p:spPr>
           <a:xfrm>
-            <a:off x="822960" y="365760"/>
-            <a:ext cx="10515600" cy="320040"/>
+            <a:off x="822960" y="320040"/>
+            <a:ext cx="10515600" cy="274320"/>
           </a:xfrm>
           <a:prstGeom prst="rect">
             <a:avLst/>
@@ -4347,14 +4491,14 @@
           <a:lstStyle/>
           <a:p>
             <a:pPr>
-              <a:defRPr sz="1100" b="1">
+              <a:defRPr sz="1050" b="1">
                 <a:solidFill>
                   <a:srgbClr val="059669"/>
                 </a:solidFill>
               </a:defRPr>
             </a:pPr>
             <a:r>
-              <a:t>AGRIYIELD  •  SLIDE 4 OF 6</a:t>
+              <a:t>AGRIYIELD  •  SLIDE 4 OF 8</a:t>
             </a:r>
           </a:p>
         </p:txBody>
@@ -4367,8 +4511,8 @@
         </p:nvSpPr>
         <p:spPr>
           <a:xfrm>
-            <a:off x="822960" y="640080"/>
-            <a:ext cx="10515600" cy="731520"/>
+            <a:off x="822960" y="594360"/>
+            <a:ext cx="10515600" cy="685800"/>
           </a:xfrm>
           <a:prstGeom prst="rect">
             <a:avLst/>
@@ -4382,516 +4526,42 @@
           <a:lstStyle/>
           <a:p>
             <a:pPr>
-              <a:defRPr sz="2800" b="1">
+              <a:defRPr sz="2600" b="1">
                 <a:solidFill>
                   <a:srgbClr val="0F172A"/>
                 </a:solidFill>
               </a:defRPr>
             </a:pPr>
             <a:r>
-              <a:t>Machine Learning Model Selection</a:t>
-            </a:r>
-          </a:p>
-        </p:txBody>
-      </p:sp>
-      <p:graphicFrame>
-        <p:nvGraphicFramePr>
-          <p:cNvPr id="4" name="Table 3"/>
-          <p:cNvGraphicFramePr>
-            <a:graphicFrameLocks noGrp="1"/>
-          </p:cNvGraphicFramePr>
+              <a:t>Data Flow Diagram (DFD) — Level 1 Architecture</a:t>
+            </a:r>
+          </a:p>
+        </p:txBody>
+      </p:sp>
+      <p:pic>
+        <p:nvPicPr>
+          <p:cNvPr id="4" name="Picture 3" descr="dfd_diagram.png"/>
+          <p:cNvPicPr>
+            <a:picLocks noChangeAspect="1"/>
+          </p:cNvPicPr>
           <p:nvPr/>
-        </p:nvGraphicFramePr>
-        <p:xfrm>
-          <a:off x="822960" y="1463040"/>
-          <a:ext cx="10545775" cy="2651760"/>
-        </p:xfrm>
-        <a:graphic>
-          <a:graphicData uri="http://schemas.openxmlformats.org/drawingml/2006/table">
-            <a:tbl>
-              <a:tblPr firstRow="1" bandRow="1">
-                <a:tableStyleId>{5C22544A-7EE6-4342-B048-85BDC9FD1C3A}</a:tableStyleId>
-              </a:tblPr>
-              <a:tblGrid>
-                <a:gridCol w="3474720"/>
-                <a:gridCol w="2286000"/>
-                <a:gridCol w="2286000"/>
-                <a:gridCol w="2499055"/>
-              </a:tblGrid>
-              <a:tr h="530352">
-                <a:tc>
-                  <a:txBody>
-                    <a:bodyPr/>
-                    <a:lstStyle/>
-                    <a:p>
-                      <a:pPr>
-                        <a:defRPr sz="1500" b="1">
-                          <a:solidFill>
-                            <a:srgbClr val="FFFFFF"/>
-                          </a:solidFill>
-                        </a:defRPr>
-                      </a:pPr>
-                      <a:r>
-                        <a:t>Algorithm Tested</a:t>
-                      </a:r>
-                    </a:p>
-                  </a:txBody>
-                  <a:tcPr>
-                    <a:solidFill>
-                      <a:srgbClr val="065F46"/>
-                    </a:solidFill>
-                  </a:tcPr>
-                </a:tc>
-                <a:tc>
-                  <a:txBody>
-                    <a:bodyPr/>
-                    <a:lstStyle/>
-                    <a:p>
-                      <a:pPr>
-                        <a:defRPr sz="1500" b="1">
-                          <a:solidFill>
-                            <a:srgbClr val="FFFFFF"/>
-                          </a:solidFill>
-                        </a:defRPr>
-                      </a:pPr>
-                      <a:r>
-                        <a:t>5-Fold CV R²</a:t>
-                      </a:r>
-                    </a:p>
-                  </a:txBody>
-                  <a:tcPr>
-                    <a:solidFill>
-                      <a:srgbClr val="065F46"/>
-                    </a:solidFill>
-                  </a:tcPr>
-                </a:tc>
-                <a:tc>
-                  <a:txBody>
-                    <a:bodyPr/>
-                    <a:lstStyle/>
-                    <a:p>
-                      <a:pPr>
-                        <a:defRPr sz="1500" b="1">
-                          <a:solidFill>
-                            <a:srgbClr val="FFFFFF"/>
-                          </a:solidFill>
-                        </a:defRPr>
-                      </a:pPr>
-                      <a:r>
-                        <a:t>Holdout Test R²</a:t>
-                      </a:r>
-                    </a:p>
-                  </a:txBody>
-                  <a:tcPr>
-                    <a:solidFill>
-                      <a:srgbClr val="065F46"/>
-                    </a:solidFill>
-                  </a:tcPr>
-                </a:tc>
-                <a:tc>
-                  <a:txBody>
-                    <a:bodyPr/>
-                    <a:lstStyle/>
-                    <a:p>
-                      <a:pPr>
-                        <a:defRPr sz="1500" b="1">
-                          <a:solidFill>
-                            <a:srgbClr val="FFFFFF"/>
-                          </a:solidFill>
-                        </a:defRPr>
-                      </a:pPr>
-                      <a:r>
-                        <a:t>Status &amp; Verdict</a:t>
-                      </a:r>
-                    </a:p>
-                  </a:txBody>
-                  <a:tcPr>
-                    <a:solidFill>
-                      <a:srgbClr val="065F46"/>
-                    </a:solidFill>
-                  </a:tcPr>
-                </a:tc>
-              </a:tr>
-              <a:tr h="530352">
-                <a:tc>
-                  <a:txBody>
-                    <a:bodyPr/>
-                    <a:lstStyle/>
-                    <a:p>
-                      <a:pPr>
-                        <a:defRPr sz="1500">
-                          <a:solidFill>
-                            <a:srgbClr val="0F172A"/>
-                          </a:solidFill>
-                        </a:defRPr>
-                      </a:pPr>
-                      <a:r>
-                        <a:t>1. Linear Regression (Ridge)</a:t>
-                      </a:r>
-                    </a:p>
-                  </a:txBody>
-                  <a:tcPr>
-                    <a:solidFill>
-                      <a:srgbClr val="FFFFFF"/>
-                    </a:solidFill>
-                  </a:tcPr>
-                </a:tc>
-                <a:tc>
-                  <a:txBody>
-                    <a:bodyPr/>
-                    <a:lstStyle/>
-                    <a:p>
-                      <a:pPr>
-                        <a:defRPr sz="1500">
-                          <a:solidFill>
-                            <a:srgbClr val="0F172A"/>
-                          </a:solidFill>
-                        </a:defRPr>
-                      </a:pPr>
-                      <a:r>
-                        <a:t>57.8%</a:t>
-                      </a:r>
-                    </a:p>
-                  </a:txBody>
-                  <a:tcPr>
-                    <a:solidFill>
-                      <a:srgbClr val="FFFFFF"/>
-                    </a:solidFill>
-                  </a:tcPr>
-                </a:tc>
-                <a:tc>
-                  <a:txBody>
-                    <a:bodyPr/>
-                    <a:lstStyle/>
-                    <a:p>
-                      <a:pPr>
-                        <a:defRPr sz="1500">
-                          <a:solidFill>
-                            <a:srgbClr val="0F172A"/>
-                          </a:solidFill>
-                        </a:defRPr>
-                      </a:pPr>
-                      <a:r>
-                        <a:t>59.6%</a:t>
-                      </a:r>
-                    </a:p>
-                  </a:txBody>
-                  <a:tcPr>
-                    <a:solidFill>
-                      <a:srgbClr val="FFFFFF"/>
-                    </a:solidFill>
-                  </a:tcPr>
-                </a:tc>
-                <a:tc>
-                  <a:txBody>
-                    <a:bodyPr/>
-                    <a:lstStyle/>
-                    <a:p>
-                      <a:pPr>
-                        <a:defRPr sz="1500">
-                          <a:solidFill>
-                            <a:srgbClr val="0F172A"/>
-                          </a:solidFill>
-                        </a:defRPr>
-                      </a:pPr>
-                      <a:r>
-                        <a:t>Underfits (Poor for Biology)</a:t>
-                      </a:r>
-                    </a:p>
-                  </a:txBody>
-                  <a:tcPr>
-                    <a:solidFill>
-                      <a:srgbClr val="FFFFFF"/>
-                    </a:solidFill>
-                  </a:tcPr>
-                </a:tc>
-              </a:tr>
-              <a:tr h="530352">
-                <a:tc>
-                  <a:txBody>
-                    <a:bodyPr/>
-                    <a:lstStyle/>
-                    <a:p>
-                      <a:pPr>
-                        <a:defRPr sz="1500">
-                          <a:solidFill>
-                            <a:srgbClr val="0F172A"/>
-                          </a:solidFill>
-                        </a:defRPr>
-                      </a:pPr>
-                      <a:r>
-                        <a:t>2. Decision Tree Regressor</a:t>
-                      </a:r>
-                    </a:p>
-                  </a:txBody>
-                  <a:tcPr>
-                    <a:solidFill>
-                      <a:srgbClr val="FFFFFF"/>
-                    </a:solidFill>
-                  </a:tcPr>
-                </a:tc>
-                <a:tc>
-                  <a:txBody>
-                    <a:bodyPr/>
-                    <a:lstStyle/>
-                    <a:p>
-                      <a:pPr>
-                        <a:defRPr sz="1500">
-                          <a:solidFill>
-                            <a:srgbClr val="0F172A"/>
-                          </a:solidFill>
-                        </a:defRPr>
-                      </a:pPr>
-                      <a:r>
-                        <a:t>91.2%</a:t>
-                      </a:r>
-                    </a:p>
-                  </a:txBody>
-                  <a:tcPr>
-                    <a:solidFill>
-                      <a:srgbClr val="FFFFFF"/>
-                    </a:solidFill>
-                  </a:tcPr>
-                </a:tc>
-                <a:tc>
-                  <a:txBody>
-                    <a:bodyPr/>
-                    <a:lstStyle/>
-                    <a:p>
-                      <a:pPr>
-                        <a:defRPr sz="1500">
-                          <a:solidFill>
-                            <a:srgbClr val="0F172A"/>
-                          </a:solidFill>
-                        </a:defRPr>
-                      </a:pPr>
-                      <a:r>
-                        <a:t>92.4%</a:t>
-                      </a:r>
-                    </a:p>
-                  </a:txBody>
-                  <a:tcPr>
-                    <a:solidFill>
-                      <a:srgbClr val="FFFFFF"/>
-                    </a:solidFill>
-                  </a:tcPr>
-                </a:tc>
-                <a:tc>
-                  <a:txBody>
-                    <a:bodyPr/>
-                    <a:lstStyle/>
-                    <a:p>
-                      <a:pPr>
-                        <a:defRPr sz="1500">
-                          <a:solidFill>
-                            <a:srgbClr val="0F172A"/>
-                          </a:solidFill>
-                        </a:defRPr>
-                      </a:pPr>
-                      <a:r>
-                        <a:t>Good Baseline Tree</a:t>
-                      </a:r>
-                    </a:p>
-                  </a:txBody>
-                  <a:tcPr>
-                    <a:solidFill>
-                      <a:srgbClr val="FFFFFF"/>
-                    </a:solidFill>
-                  </a:tcPr>
-                </a:tc>
-              </a:tr>
-              <a:tr h="530352">
-                <a:tc>
-                  <a:txBody>
-                    <a:bodyPr/>
-                    <a:lstStyle/>
-                    <a:p>
-                      <a:pPr>
-                        <a:defRPr sz="1500">
-                          <a:solidFill>
-                            <a:srgbClr val="0F172A"/>
-                          </a:solidFill>
-                        </a:defRPr>
-                      </a:pPr>
-                      <a:r>
-                        <a:t>3. Gradient Boosting Regressor</a:t>
-                      </a:r>
-                    </a:p>
-                  </a:txBody>
-                  <a:tcPr>
-                    <a:solidFill>
-                      <a:srgbClr val="FFFFFF"/>
-                    </a:solidFill>
-                  </a:tcPr>
-                </a:tc>
-                <a:tc>
-                  <a:txBody>
-                    <a:bodyPr/>
-                    <a:lstStyle/>
-                    <a:p>
-                      <a:pPr>
-                        <a:defRPr sz="1500">
-                          <a:solidFill>
-                            <a:srgbClr val="0F172A"/>
-                          </a:solidFill>
-                        </a:defRPr>
-                      </a:pPr>
-                      <a:r>
-                        <a:t>93.1%</a:t>
-                      </a:r>
-                    </a:p>
-                  </a:txBody>
-                  <a:tcPr>
-                    <a:solidFill>
-                      <a:srgbClr val="FFFFFF"/>
-                    </a:solidFill>
-                  </a:tcPr>
-                </a:tc>
-                <a:tc>
-                  <a:txBody>
-                    <a:bodyPr/>
-                    <a:lstStyle/>
-                    <a:p>
-                      <a:pPr>
-                        <a:defRPr sz="1500">
-                          <a:solidFill>
-                            <a:srgbClr val="0F172A"/>
-                          </a:solidFill>
-                        </a:defRPr>
-                      </a:pPr>
-                      <a:r>
-                        <a:t>94.1%</a:t>
-                      </a:r>
-                    </a:p>
-                  </a:txBody>
-                  <a:tcPr>
-                    <a:solidFill>
-                      <a:srgbClr val="FFFFFF"/>
-                    </a:solidFill>
-                  </a:tcPr>
-                </a:tc>
-                <a:tc>
-                  <a:txBody>
-                    <a:bodyPr/>
-                    <a:lstStyle/>
-                    <a:p>
-                      <a:pPr>
-                        <a:defRPr sz="1500">
-                          <a:solidFill>
-                            <a:srgbClr val="0F172A"/>
-                          </a:solidFill>
-                        </a:defRPr>
-                      </a:pPr>
-                      <a:r>
-                        <a:t>Strong Non-Linear Fit</a:t>
-                      </a:r>
-                    </a:p>
-                  </a:txBody>
-                  <a:tcPr>
-                    <a:solidFill>
-                      <a:srgbClr val="FFFFFF"/>
-                    </a:solidFill>
-                  </a:tcPr>
-                </a:tc>
-              </a:tr>
-              <a:tr h="530352">
-                <a:tc>
-                  <a:txBody>
-                    <a:bodyPr/>
-                    <a:lstStyle/>
-                    <a:p>
-                      <a:pPr>
-                        <a:defRPr sz="1500" b="1">
-                          <a:solidFill>
-                            <a:srgbClr val="065F46"/>
-                          </a:solidFill>
-                        </a:defRPr>
-                      </a:pPr>
-                      <a:r>
-                        <a:t>4. Random Forest Regressor</a:t>
-                      </a:r>
-                    </a:p>
-                  </a:txBody>
-                  <a:tcPr>
-                    <a:solidFill>
-                      <a:srgbClr val="F0FDF4"/>
-                    </a:solidFill>
-                  </a:tcPr>
-                </a:tc>
-                <a:tc>
-                  <a:txBody>
-                    <a:bodyPr/>
-                    <a:lstStyle/>
-                    <a:p>
-                      <a:pPr>
-                        <a:defRPr sz="1500" b="1">
-                          <a:solidFill>
-                            <a:srgbClr val="065F46"/>
-                          </a:solidFill>
-                        </a:defRPr>
-                      </a:pPr>
-                      <a:r>
-                        <a:t>95.9%</a:t>
-                      </a:r>
-                    </a:p>
-                  </a:txBody>
-                  <a:tcPr>
-                    <a:solidFill>
-                      <a:srgbClr val="F0FDF4"/>
-                    </a:solidFill>
-                  </a:tcPr>
-                </a:tc>
-                <a:tc>
-                  <a:txBody>
-                    <a:bodyPr/>
-                    <a:lstStyle/>
-                    <a:p>
-                      <a:pPr>
-                        <a:defRPr sz="1500" b="1">
-                          <a:solidFill>
-                            <a:srgbClr val="065F46"/>
-                          </a:solidFill>
-                        </a:defRPr>
-                      </a:pPr>
-                      <a:r>
-                        <a:t>96.8%</a:t>
-                      </a:r>
-                    </a:p>
-                  </a:txBody>
-                  <a:tcPr>
-                    <a:solidFill>
-                      <a:srgbClr val="F0FDF4"/>
-                    </a:solidFill>
-                  </a:tcPr>
-                </a:tc>
-                <a:tc>
-                  <a:txBody>
-                    <a:bodyPr/>
-                    <a:lstStyle/>
-                    <a:p>
-                      <a:pPr>
-                        <a:defRPr sz="1500" b="1">
-                          <a:solidFill>
-                            <a:srgbClr val="065F46"/>
-                          </a:solidFill>
-                        </a:defRPr>
-                      </a:pPr>
-                      <a:r>
-                        <a:t>CHAMPION MODEL (Winner)</a:t>
-                      </a:r>
-                    </a:p>
-                  </a:txBody>
-                  <a:tcPr>
-                    <a:solidFill>
-                      <a:srgbClr val="F0FDF4"/>
-                    </a:solidFill>
-                  </a:tcPr>
-                </a:tc>
-              </a:tr>
-            </a:tbl>
-          </a:graphicData>
-        </a:graphic>
-      </p:graphicFrame>
+        </p:nvPicPr>
+        <p:blipFill>
+          <a:blip r:embed="rId2"/>
+          <a:stretch>
+            <a:fillRect/>
+          </a:stretch>
+        </p:blipFill>
+        <p:spPr>
+          <a:xfrm>
+            <a:off x="822960" y="1371600"/>
+            <a:ext cx="7132320" cy="3890356"/>
+          </a:xfrm>
+          <a:prstGeom prst="rect">
+            <a:avLst/>
+          </a:prstGeom>
+        </p:spPr>
+      </p:pic>
       <p:sp>
         <p:nvSpPr>
           <p:cNvPr id="5" name="Rounded Rectangle 4"/>
@@ -4900,8 +4570,8 @@
         </p:nvSpPr>
         <p:spPr>
           <a:xfrm>
-            <a:off x="822960" y="4389120"/>
-            <a:ext cx="10545775" cy="1920240"/>
+            <a:off x="8229600" y="1371600"/>
+            <a:ext cx="3139135" cy="4937760"/>
           </a:xfrm>
           <a:prstGeom prst="roundRect">
             <a:avLst/>
@@ -4945,8 +4615,8 @@
         </p:nvSpPr>
         <p:spPr>
           <a:xfrm>
-            <a:off x="1097280" y="4526280"/>
-            <a:ext cx="9966960" cy="1645920"/>
+            <a:off x="8412480" y="1600200"/>
+            <a:ext cx="2743200" cy="4389120"/>
           </a:xfrm>
           <a:prstGeom prst="rect">
             <a:avLst/>
@@ -4960,59 +4630,104 @@
           <a:lstStyle/>
           <a:p>
             <a:pPr>
-              <a:defRPr sz="1700" b="1">
-                <a:solidFill>
-                  <a:srgbClr val="065F46"/>
+              <a:defRPr sz="1600" b="1">
+                <a:solidFill>
+                  <a:srgbClr val="059669"/>
                 </a:solidFill>
               </a:defRPr>
             </a:pPr>
             <a:r>
-              <a:t>WHY RANDOM FOREST WON (96.8% ACCURACY):</a:t>
+              <a:t>DFD FLOW SUMMARY</a:t>
             </a:r>
           </a:p>
           <a:p>
             <a:pPr>
               <a:spcBef>
-                <a:spcPts val="600"/>
+                <a:spcPts val="1000"/>
               </a:spcBef>
-              <a:defRPr sz="1500">
+              <a:defRPr sz="1250">
                 <a:solidFill>
                   <a:srgbClr val="0F172A"/>
                 </a:solidFill>
               </a:defRPr>
             </a:pPr>
             <a:r>
-              <a:t>•  Nature is not a straight line: Doubling rain or fertilizer does NOT double crop output.</a:t>
+              <a:t>• User / Officer: Enters crop, state, season, area, and inputs.</a:t>
             </a:r>
           </a:p>
           <a:p>
             <a:pPr>
               <a:spcBef>
-                <a:spcPts val="600"/>
+                <a:spcPts val="1000"/>
               </a:spcBef>
-              <a:defRPr sz="1500">
+              <a:defRPr sz="1250">
                 <a:solidFill>
                   <a:srgbClr val="0F172A"/>
                 </a:solidFill>
               </a:defRPr>
             </a:pPr>
             <a:r>
-              <a:t>•  Random Forest uses 120 decision trees to capture real-world saturating biological limits.</a:t>
+              <a:t>• Process 1.0: Validates domain bounds and ensures non-negativity.</a:t>
             </a:r>
           </a:p>
           <a:p>
             <a:pPr>
               <a:spcBef>
-                <a:spcPts val="600"/>
+                <a:spcPts val="1000"/>
               </a:spcBef>
-              <a:defRPr sz="1500">
+              <a:defRPr sz="1250">
                 <a:solidFill>
                   <a:srgbClr val="0F172A"/>
                 </a:solidFill>
               </a:defRPr>
             </a:pPr>
             <a:r>
-              <a:t>•  Combined with a target log-transform (ln(1+y)) to guarantee positive yield predictions.</a:t>
+              <a:t>• Process 2.0: Computes application rates and scales features.</a:t>
+            </a:r>
+          </a:p>
+          <a:p>
+            <a:pPr>
+              <a:spcBef>
+                <a:spcPts val="1000"/>
+              </a:spcBef>
+              <a:defRPr sz="1250">
+                <a:solidFill>
+                  <a:srgbClr val="0F172A"/>
+                </a:solidFill>
+              </a:defRPr>
+            </a:pPr>
+            <a:r>
+              <a:t>• Process 3.0: Random Forest queries model weights (D2) and predicts.</a:t>
+            </a:r>
+          </a:p>
+          <a:p>
+            <a:pPr>
+              <a:spcBef>
+                <a:spcPts val="1000"/>
+              </a:spcBef>
+              <a:defRPr sz="1250">
+                <a:solidFill>
+                  <a:srgbClr val="0F172A"/>
+                </a:solidFill>
+              </a:defRPr>
+            </a:pPr>
+            <a:r>
+              <a:t>• Process 4.0: Translates raw yield into acre and truckload units.</a:t>
+            </a:r>
+          </a:p>
+          <a:p>
+            <a:pPr>
+              <a:spcBef>
+                <a:spcPts val="1000"/>
+              </a:spcBef>
+              <a:defRPr sz="1250">
+                <a:solidFill>
+                  <a:srgbClr val="0F172A"/>
+                </a:solidFill>
+              </a:defRPr>
+            </a:pPr>
+            <a:r>
+              <a:t>• Stores D1 &amp; D2: Census database and pre-trained model artifacts.</a:t>
             </a:r>
           </a:p>
         </p:txBody>
@@ -5051,8 +4766,8 @@
         </p:nvSpPr>
         <p:spPr>
           <a:xfrm>
-            <a:off x="822960" y="365760"/>
-            <a:ext cx="10515600" cy="320040"/>
+            <a:off x="822960" y="320040"/>
+            <a:ext cx="10515600" cy="274320"/>
           </a:xfrm>
           <a:prstGeom prst="rect">
             <a:avLst/>
@@ -5066,14 +4781,14 @@
           <a:lstStyle/>
           <a:p>
             <a:pPr>
-              <a:defRPr sz="1100" b="1">
+              <a:defRPr sz="1050" b="1">
                 <a:solidFill>
                   <a:srgbClr val="059669"/>
                 </a:solidFill>
               </a:defRPr>
             </a:pPr>
             <a:r>
-              <a:t>AGRIYIELD  •  SLIDE 5 OF 6</a:t>
+              <a:t>AGRIYIELD  •  SLIDE 5 OF 8</a:t>
             </a:r>
           </a:p>
         </p:txBody>
@@ -5086,8 +4801,8 @@
         </p:nvSpPr>
         <p:spPr>
           <a:xfrm>
-            <a:off x="822960" y="640080"/>
-            <a:ext cx="10515600" cy="731520"/>
+            <a:off x="822960" y="594360"/>
+            <a:ext cx="10515600" cy="685800"/>
           </a:xfrm>
           <a:prstGeom prst="rect">
             <a:avLst/>
@@ -5101,28 +4816,52 @@
           <a:lstStyle/>
           <a:p>
             <a:pPr>
-              <a:defRPr sz="2800" b="1">
+              <a:defRPr sz="2600" b="1">
                 <a:solidFill>
                   <a:srgbClr val="0F172A"/>
                 </a:solidFill>
               </a:defRPr>
             </a:pPr>
             <a:r>
-              <a:t>3 Key Insights Discovered from the Data</a:t>
-            </a:r>
-          </a:p>
-        </p:txBody>
-      </p:sp>
-      <p:sp>
-        <p:nvSpPr>
-          <p:cNvPr id="4" name="Rounded Rectangle 3"/>
+              <a:t>Entity-Relationship Diagram (ERD)</a:t>
+            </a:r>
+          </a:p>
+        </p:txBody>
+      </p:sp>
+      <p:pic>
+        <p:nvPicPr>
+          <p:cNvPr id="4" name="Picture 3" descr="erd_diagram.png"/>
+          <p:cNvPicPr>
+            <a:picLocks noChangeAspect="1"/>
+          </p:cNvPicPr>
+          <p:nvPr/>
+        </p:nvPicPr>
+        <p:blipFill>
+          <a:blip r:embed="rId2"/>
+          <a:stretch>
+            <a:fillRect/>
+          </a:stretch>
+        </p:blipFill>
+        <p:spPr>
+          <a:xfrm>
+            <a:off x="822960" y="1371600"/>
+            <a:ext cx="7132320" cy="3890356"/>
+          </a:xfrm>
+          <a:prstGeom prst="rect">
+            <a:avLst/>
+          </a:prstGeom>
+        </p:spPr>
+      </p:pic>
+      <p:sp>
+        <p:nvSpPr>
+          <p:cNvPr id="5" name="Rounded Rectangle 4"/>
           <p:cNvSpPr/>
           <p:nvPr/>
         </p:nvSpPr>
         <p:spPr>
           <a:xfrm>
-            <a:off x="822960" y="1463040"/>
-            <a:ext cx="3383280" cy="4846320"/>
+            <a:off x="8229600" y="1371600"/>
+            <a:ext cx="3139135" cy="4937760"/>
           </a:xfrm>
           <a:prstGeom prst="roundRect">
             <a:avLst/>
@@ -5132,7 +4871,7 @@
           </a:solidFill>
           <a:ln w="25400">
             <a:solidFill>
-              <a:srgbClr val="059669"/>
+              <a:srgbClr val="0284C7"/>
             </a:solidFill>
           </a:ln>
         </p:spPr>
@@ -5160,14 +4899,14 @@
       </p:sp>
       <p:sp>
         <p:nvSpPr>
-          <p:cNvPr id="5" name="TextBox 4"/>
+          <p:cNvPr id="6" name="TextBox 5"/>
           <p:cNvSpPr txBox="1"/>
           <p:nvPr/>
         </p:nvSpPr>
         <p:spPr>
           <a:xfrm>
-            <a:off x="1051560" y="1737360"/>
-            <a:ext cx="2926080" cy="4297680"/>
+            <a:off x="8412480" y="1600200"/>
+            <a:ext cx="2743200" cy="4389120"/>
           </a:xfrm>
           <a:prstGeom prst="rect">
             <a:avLst/>
@@ -5181,234 +4920,104 @@
           <a:lstStyle/>
           <a:p>
             <a:pPr>
-              <a:defRPr sz="1700" b="1">
-                <a:solidFill>
-                  <a:srgbClr val="059669"/>
+              <a:defRPr sz="1600" b="1">
+                <a:solidFill>
+                  <a:srgbClr val="0284C7"/>
                 </a:solidFill>
               </a:defRPr>
             </a:pPr>
             <a:r>
-              <a:t>1. CROP GENETICS DECIDE YIELD</a:t>
+              <a:t>ERD ENTITIES &amp; SCHEMA</a:t>
             </a:r>
           </a:p>
           <a:p>
             <a:pPr>
               <a:spcBef>
-                <a:spcPts val="1600"/>
+                <a:spcPts val="1000"/>
               </a:spcBef>
-              <a:defRPr sz="1550">
+              <a:defRPr sz="1250">
                 <a:solidFill>
                   <a:srgbClr val="0F172A"/>
                 </a:solidFill>
               </a:defRPr>
             </a:pPr>
             <a:r>
-              <a:t>Accounts for 71.8% of prediction importance.</a:t>
-            </a:r>
-            <a:br/>
-            <a:br/>
-            <a:r>
-              <a:t>Sugarcane naturally yields ~52 tonnes/ha, whereas Wheat and Rice yield 2–4 tonnes/ha.</a:t>
-            </a:r>
-          </a:p>
-        </p:txBody>
-      </p:sp>
-      <p:sp>
-        <p:nvSpPr>
-          <p:cNvPr id="6" name="Rounded Rectangle 5"/>
-          <p:cNvSpPr/>
-          <p:nvPr/>
-        </p:nvSpPr>
-        <p:spPr>
-          <a:xfrm>
-            <a:off x="4389120" y="1463040"/>
-            <a:ext cx="3383280" cy="4846320"/>
-          </a:xfrm>
-          <a:prstGeom prst="roundRect">
-            <a:avLst/>
-          </a:prstGeom>
-          <a:solidFill>
-            <a:srgbClr val="FFFFFF"/>
-          </a:solidFill>
-          <a:ln w="25400">
-            <a:solidFill>
-              <a:srgbClr val="0284C7"/>
-            </a:solidFill>
-          </a:ln>
-        </p:spPr>
-        <p:style>
-          <a:lnRef idx="1">
-            <a:schemeClr val="accent1"/>
-          </a:lnRef>
-          <a:fillRef idx="3">
-            <a:schemeClr val="accent1"/>
-          </a:fillRef>
-          <a:effectRef idx="2">
-            <a:schemeClr val="accent1"/>
-          </a:effectRef>
-          <a:fontRef idx="minor">
-            <a:schemeClr val="lt1"/>
-          </a:fontRef>
-        </p:style>
-        <p:txBody>
-          <a:bodyPr rtlCol="0" anchor="ctr"/>
-          <a:lstStyle/>
-          <a:p>
-            <a:pPr algn="ctr"/>
-          </a:p>
-        </p:txBody>
-      </p:sp>
-      <p:sp>
-        <p:nvSpPr>
-          <p:cNvPr id="7" name="TextBox 6"/>
-          <p:cNvSpPr txBox="1"/>
-          <p:nvPr/>
-        </p:nvSpPr>
-        <p:spPr>
-          <a:xfrm>
-            <a:off x="4617720" y="1737360"/>
-            <a:ext cx="2926080" cy="4297680"/>
-          </a:xfrm>
-          <a:prstGeom prst="rect">
-            <a:avLst/>
-          </a:prstGeom>
-          <a:noFill/>
-        </p:spPr>
-        <p:txBody>
-          <a:bodyPr wrap="square">
-            <a:spAutoFit/>
-          </a:bodyPr>
-          <a:lstStyle/>
-          <a:p>
-            <a:pPr>
-              <a:defRPr sz="1700" b="1">
-                <a:solidFill>
-                  <a:srgbClr val="0284C7"/>
-                </a:solidFill>
-              </a:defRPr>
-            </a:pPr>
-            <a:r>
-              <a:t>2. THE FERTILIZER PARADOX</a:t>
+              <a:t>• STATE Entity: Contains State_ID (PK), Name, and historical average yield.</a:t>
             </a:r>
           </a:p>
           <a:p>
             <a:pPr>
               <a:spcBef>
-                <a:spcPts val="1600"/>
+                <a:spcPts val="1000"/>
               </a:spcBef>
-              <a:defRPr sz="1550">
+              <a:defRPr sz="1250">
                 <a:solidFill>
                   <a:srgbClr val="0F172A"/>
                 </a:solidFill>
               </a:defRPr>
             </a:pPr>
             <a:r>
-              <a:t>Fertilizer boosts cash crops (+0.17 for Sugarcane).</a:t>
-            </a:r>
-            <a:br/>
-            <a:br/>
-            <a:r>
-              <a:t>BUT excess chemical fertilizer hurts pulses (Moong/Gram) because pulses naturally fix nitrogen!</a:t>
-            </a:r>
-          </a:p>
-        </p:txBody>
-      </p:sp>
-      <p:sp>
-        <p:nvSpPr>
-          <p:cNvPr id="8" name="Rounded Rectangle 7"/>
-          <p:cNvSpPr/>
-          <p:nvPr/>
-        </p:nvSpPr>
-        <p:spPr>
-          <a:xfrm>
-            <a:off x="7955279" y="1463040"/>
-            <a:ext cx="3383280" cy="4846320"/>
-          </a:xfrm>
-          <a:prstGeom prst="roundRect">
-            <a:avLst/>
-          </a:prstGeom>
-          <a:solidFill>
-            <a:srgbClr val="FFFFFF"/>
-          </a:solidFill>
-          <a:ln w="25400">
-            <a:solidFill>
-              <a:srgbClr val="D97706"/>
-            </a:solidFill>
-          </a:ln>
-        </p:spPr>
-        <p:style>
-          <a:lnRef idx="1">
-            <a:schemeClr val="accent1"/>
-          </a:lnRef>
-          <a:fillRef idx="3">
-            <a:schemeClr val="accent1"/>
-          </a:fillRef>
-          <a:effectRef idx="2">
-            <a:schemeClr val="accent1"/>
-          </a:effectRef>
-          <a:fontRef idx="minor">
-            <a:schemeClr val="lt1"/>
-          </a:fontRef>
-        </p:style>
-        <p:txBody>
-          <a:bodyPr rtlCol="0" anchor="ctr"/>
-          <a:lstStyle/>
-          <a:p>
-            <a:pPr algn="ctr"/>
-          </a:p>
-        </p:txBody>
-      </p:sp>
-      <p:sp>
-        <p:nvSpPr>
-          <p:cNvPr id="9" name="TextBox 8"/>
-          <p:cNvSpPr txBox="1"/>
-          <p:nvPr/>
-        </p:nvSpPr>
-        <p:spPr>
-          <a:xfrm>
-            <a:off x="8183879" y="1737360"/>
-            <a:ext cx="2926080" cy="4297680"/>
-          </a:xfrm>
-          <a:prstGeom prst="rect">
-            <a:avLst/>
-          </a:prstGeom>
-          <a:noFill/>
-        </p:spPr>
-        <p:txBody>
-          <a:bodyPr wrap="square">
-            <a:spAutoFit/>
-          </a:bodyPr>
-          <a:lstStyle/>
-          <a:p>
-            <a:pPr>
-              <a:defRPr sz="1700" b="1">
-                <a:solidFill>
-                  <a:srgbClr val="D97706"/>
-                </a:solidFill>
-              </a:defRPr>
-            </a:pPr>
-            <a:r>
-              <a:t>3. RAINFALL LIMIT (2,000 mm)</a:t>
+              <a:t>• CROP Entity: Contains Crop_ID (PK), species name, category, and scale.</a:t>
             </a:r>
           </a:p>
           <a:p>
             <a:pPr>
               <a:spcBef>
-                <a:spcPts val="1600"/>
+                <a:spcPts val="1000"/>
               </a:spcBef>
-              <a:defRPr sz="1550">
+              <a:defRPr sz="1250">
                 <a:solidFill>
                   <a:srgbClr val="0F172A"/>
                 </a:solidFill>
               </a:defRPr>
             </a:pPr>
             <a:r>
-              <a:t>Rain boosts crop yield up to ~2,000 mm per year.</a:t>
-            </a:r>
-            <a:br/>
-            <a:br/>
-            <a:r>
-              <a:t>Beyond 2,000 mm, waterlogging, root rot, and fungal disease cap maximum crop productivity.</a:t>
+              <a:t>• SEASON Entity: Defines cropping calendar (Kharif, Rabi, Whole Year).</a:t>
+            </a:r>
+          </a:p>
+          <a:p>
+            <a:pPr>
+              <a:spcBef>
+                <a:spcPts val="1000"/>
+              </a:spcBef>
+              <a:defRPr sz="1250">
+                <a:solidFill>
+                  <a:srgbClr val="0F172A"/>
+                </a:solidFill>
+              </a:defRPr>
+            </a:pPr>
+            <a:r>
+              <a:t>• CULTIVATION_RECORD: Central entity storing area, rainfall, fertilizer, and pesticide.</a:t>
+            </a:r>
+          </a:p>
+          <a:p>
+            <a:pPr>
+              <a:spcBef>
+                <a:spcPts val="1000"/>
+              </a:spcBef>
+              <a:defRPr sz="1250">
+                <a:solidFill>
+                  <a:srgbClr val="0F172A"/>
+                </a:solidFill>
+              </a:defRPr>
+            </a:pPr>
+            <a:r>
+              <a:t>• YIELD_PREDICTION: Output entity storing point predictions, acre rates, and truckloads.</a:t>
+            </a:r>
+          </a:p>
+          <a:p>
+            <a:pPr>
+              <a:spcBef>
+                <a:spcPts val="1000"/>
+              </a:spcBef>
+              <a:defRPr sz="1250">
+                <a:solidFill>
+                  <a:srgbClr val="0F172A"/>
+                </a:solidFill>
+              </a:defRPr>
+            </a:pPr>
+            <a:r>
+              <a:t>• Cardinality: 1:M relations connect master entities to cultivation events.</a:t>
             </a:r>
           </a:p>
         </p:txBody>
@@ -5447,8 +5056,8 @@
         </p:nvSpPr>
         <p:spPr>
           <a:xfrm>
-            <a:off x="822960" y="365760"/>
-            <a:ext cx="10515600" cy="320040"/>
+            <a:off x="822960" y="320040"/>
+            <a:ext cx="10515600" cy="274320"/>
           </a:xfrm>
           <a:prstGeom prst="rect">
             <a:avLst/>
@@ -5462,14 +5071,14 @@
           <a:lstStyle/>
           <a:p>
             <a:pPr>
-              <a:defRPr sz="1100" b="1">
+              <a:defRPr sz="1050" b="1">
                 <a:solidFill>
                   <a:srgbClr val="059669"/>
                 </a:solidFill>
               </a:defRPr>
             </a:pPr>
             <a:r>
-              <a:t>AGRIYIELD  •  SLIDE 6 OF 6</a:t>
+              <a:t>AGRIYIELD  •  SLIDE 6 OF 8</a:t>
             </a:r>
           </a:p>
         </p:txBody>
@@ -5482,8 +5091,8 @@
         </p:nvSpPr>
         <p:spPr>
           <a:xfrm>
-            <a:off x="822960" y="640080"/>
-            <a:ext cx="10515600" cy="731520"/>
+            <a:off x="822960" y="594360"/>
+            <a:ext cx="10515600" cy="685800"/>
           </a:xfrm>
           <a:prstGeom prst="rect">
             <a:avLst/>
@@ -5497,28 +5106,1343 @@
           <a:lstStyle/>
           <a:p>
             <a:pPr>
-              <a:defRPr sz="2800" b="1">
+              <a:defRPr sz="2600" b="1">
                 <a:solidFill>
                   <a:srgbClr val="0F172A"/>
                 </a:solidFill>
               </a:defRPr>
             </a:pPr>
             <a:r>
-              <a:t>Web Dashboard &amp; Implementation</a:t>
-            </a:r>
-          </a:p>
-        </p:txBody>
-      </p:sp>
-      <p:sp>
-        <p:nvSpPr>
-          <p:cNvPr id="4" name="Rounded Rectangle 3"/>
+              <a:t>Table Design &amp; Relational Schema</a:t>
+            </a:r>
+          </a:p>
+        </p:txBody>
+      </p:sp>
+      <p:sp>
+        <p:nvSpPr>
+          <p:cNvPr id="4" name="TextBox 3"/>
+          <p:cNvSpPr txBox="1"/>
+          <p:nvPr/>
+        </p:nvSpPr>
+        <p:spPr>
+          <a:xfrm>
+            <a:off x="822960" y="1280160"/>
+            <a:ext cx="10515600" cy="365760"/>
+          </a:xfrm>
+          <a:prstGeom prst="rect">
+            <a:avLst/>
+          </a:prstGeom>
+          <a:noFill/>
+        </p:spPr>
+        <p:txBody>
+          <a:bodyPr wrap="none">
+            <a:spAutoFit/>
+          </a:bodyPr>
+          <a:lstStyle/>
+          <a:p>
+            <a:pPr>
+              <a:defRPr sz="1300" b="1">
+                <a:solidFill>
+                  <a:srgbClr val="065F46"/>
+                </a:solidFill>
+              </a:defRPr>
+            </a:pPr>
+            <a:r>
+              <a:t>TABLE 1: CROP_CENSUS_RECORDS (Core Census Series — 19,689 Rows)</a:t>
+            </a:r>
+          </a:p>
+        </p:txBody>
+      </p:sp>
+      <p:graphicFrame>
+        <p:nvGraphicFramePr>
+          <p:cNvPr id="5" name="Table 4"/>
+          <p:cNvGraphicFramePr>
+            <a:graphicFrameLocks noGrp="1"/>
+          </p:cNvGraphicFramePr>
+          <p:nvPr/>
+        </p:nvGraphicFramePr>
+        <p:xfrm>
+          <a:off x="822960" y="1645920"/>
+          <a:ext cx="10545775" cy="1737360"/>
+        </p:xfrm>
+        <a:graphic>
+          <a:graphicData uri="http://schemas.openxmlformats.org/drawingml/2006/table">
+            <a:tbl>
+              <a:tblPr firstRow="1" bandRow="1">
+                <a:tableStyleId>{5C22544A-7EE6-4342-B048-85BDC9FD1C3A}</a:tableStyleId>
+              </a:tblPr>
+              <a:tblGrid>
+                <a:gridCol w="2560320"/>
+                <a:gridCol w="2011680"/>
+                <a:gridCol w="1645920"/>
+                <a:gridCol w="4327855"/>
+              </a:tblGrid>
+              <a:tr h="289560">
+                <a:tc>
+                  <a:txBody>
+                    <a:bodyPr/>
+                    <a:lstStyle/>
+                    <a:p>
+                      <a:pPr>
+                        <a:defRPr sz="1200" b="1">
+                          <a:solidFill>
+                            <a:srgbClr val="FFFFFF"/>
+                          </a:solidFill>
+                        </a:defRPr>
+                      </a:pPr>
+                      <a:r>
+                        <a:t>Field Name</a:t>
+                      </a:r>
+                    </a:p>
+                  </a:txBody>
+                  <a:tcPr>
+                    <a:solidFill>
+                      <a:srgbClr val="065F46"/>
+                    </a:solidFill>
+                  </a:tcPr>
+                </a:tc>
+                <a:tc>
+                  <a:txBody>
+                    <a:bodyPr/>
+                    <a:lstStyle/>
+                    <a:p>
+                      <a:pPr>
+                        <a:defRPr sz="1200" b="1">
+                          <a:solidFill>
+                            <a:srgbClr val="FFFFFF"/>
+                          </a:solidFill>
+                        </a:defRPr>
+                      </a:pPr>
+                      <a:r>
+                        <a:t>Data Type</a:t>
+                      </a:r>
+                    </a:p>
+                  </a:txBody>
+                  <a:tcPr>
+                    <a:solidFill>
+                      <a:srgbClr val="065F46"/>
+                    </a:solidFill>
+                  </a:tcPr>
+                </a:tc>
+                <a:tc>
+                  <a:txBody>
+                    <a:bodyPr/>
+                    <a:lstStyle/>
+                    <a:p>
+                      <a:pPr>
+                        <a:defRPr sz="1200" b="1">
+                          <a:solidFill>
+                            <a:srgbClr val="FFFFFF"/>
+                          </a:solidFill>
+                        </a:defRPr>
+                      </a:pPr>
+                      <a:r>
+                        <a:t>Constraints</a:t>
+                      </a:r>
+                    </a:p>
+                  </a:txBody>
+                  <a:tcPr>
+                    <a:solidFill>
+                      <a:srgbClr val="065F46"/>
+                    </a:solidFill>
+                  </a:tcPr>
+                </a:tc>
+                <a:tc>
+                  <a:txBody>
+                    <a:bodyPr/>
+                    <a:lstStyle/>
+                    <a:p>
+                      <a:pPr>
+                        <a:defRPr sz="1200" b="1">
+                          <a:solidFill>
+                            <a:srgbClr val="FFFFFF"/>
+                          </a:solidFill>
+                        </a:defRPr>
+                      </a:pPr>
+                      <a:r>
+                        <a:t>Description</a:t>
+                      </a:r>
+                    </a:p>
+                  </a:txBody>
+                  <a:tcPr>
+                    <a:solidFill>
+                      <a:srgbClr val="065F46"/>
+                    </a:solidFill>
+                  </a:tcPr>
+                </a:tc>
+              </a:tr>
+              <a:tr h="289560">
+                <a:tc>
+                  <a:txBody>
+                    <a:bodyPr/>
+                    <a:lstStyle/>
+                    <a:p>
+                      <a:pPr>
+                        <a:defRPr sz="1150">
+                          <a:solidFill>
+                            <a:srgbClr val="0F172A"/>
+                          </a:solidFill>
+                        </a:defRPr>
+                      </a:pPr>
+                      <a:r>
+                        <a:t>Record_ID</a:t>
+                      </a:r>
+                    </a:p>
+                  </a:txBody>
+                  <a:tcPr>
+                    <a:solidFill>
+                      <a:srgbClr val="FFFFFF"/>
+                    </a:solidFill>
+                  </a:tcPr>
+                </a:tc>
+                <a:tc>
+                  <a:txBody>
+                    <a:bodyPr/>
+                    <a:lstStyle/>
+                    <a:p>
+                      <a:pPr>
+                        <a:defRPr sz="1150">
+                          <a:solidFill>
+                            <a:srgbClr val="0F172A"/>
+                          </a:solidFill>
+                        </a:defRPr>
+                      </a:pPr>
+                      <a:r>
+                        <a:t>INTEGER</a:t>
+                      </a:r>
+                    </a:p>
+                  </a:txBody>
+                  <a:tcPr>
+                    <a:solidFill>
+                      <a:srgbClr val="FFFFFF"/>
+                    </a:solidFill>
+                  </a:tcPr>
+                </a:tc>
+                <a:tc>
+                  <a:txBody>
+                    <a:bodyPr/>
+                    <a:lstStyle/>
+                    <a:p>
+                      <a:pPr>
+                        <a:defRPr sz="1150">
+                          <a:solidFill>
+                            <a:srgbClr val="0F172A"/>
+                          </a:solidFill>
+                        </a:defRPr>
+                      </a:pPr>
+                      <a:r>
+                        <a:t>PRIMARY KEY</a:t>
+                      </a:r>
+                    </a:p>
+                  </a:txBody>
+                  <a:tcPr>
+                    <a:solidFill>
+                      <a:srgbClr val="FFFFFF"/>
+                    </a:solidFill>
+                  </a:tcPr>
+                </a:tc>
+                <a:tc>
+                  <a:txBody>
+                    <a:bodyPr/>
+                    <a:lstStyle/>
+                    <a:p>
+                      <a:pPr>
+                        <a:defRPr sz="1150">
+                          <a:solidFill>
+                            <a:srgbClr val="0F172A"/>
+                          </a:solidFill>
+                        </a:defRPr>
+                      </a:pPr>
+                      <a:r>
+                        <a:t>Unique auto-increment identifier</a:t>
+                      </a:r>
+                    </a:p>
+                  </a:txBody>
+                  <a:tcPr>
+                    <a:solidFill>
+                      <a:srgbClr val="FFFFFF"/>
+                    </a:solidFill>
+                  </a:tcPr>
+                </a:tc>
+              </a:tr>
+              <a:tr h="289560">
+                <a:tc>
+                  <a:txBody>
+                    <a:bodyPr/>
+                    <a:lstStyle/>
+                    <a:p>
+                      <a:pPr>
+                        <a:defRPr sz="1150">
+                          <a:solidFill>
+                            <a:srgbClr val="0F172A"/>
+                          </a:solidFill>
+                        </a:defRPr>
+                      </a:pPr>
+                      <a:r>
+                        <a:t>Crop</a:t>
+                      </a:r>
+                    </a:p>
+                  </a:txBody>
+                  <a:tcPr>
+                    <a:solidFill>
+                      <a:srgbClr val="FFFFFF"/>
+                    </a:solidFill>
+                  </a:tcPr>
+                </a:tc>
+                <a:tc>
+                  <a:txBody>
+                    <a:bodyPr/>
+                    <a:lstStyle/>
+                    <a:p>
+                      <a:pPr>
+                        <a:defRPr sz="1150">
+                          <a:solidFill>
+                            <a:srgbClr val="0F172A"/>
+                          </a:solidFill>
+                        </a:defRPr>
+                      </a:pPr>
+                      <a:r>
+                        <a:t>VARCHAR(50)</a:t>
+                      </a:r>
+                    </a:p>
+                  </a:txBody>
+                  <a:tcPr>
+                    <a:solidFill>
+                      <a:srgbClr val="FFFFFF"/>
+                    </a:solidFill>
+                  </a:tcPr>
+                </a:tc>
+                <a:tc>
+                  <a:txBody>
+                    <a:bodyPr/>
+                    <a:lstStyle/>
+                    <a:p>
+                      <a:pPr>
+                        <a:defRPr sz="1150">
+                          <a:solidFill>
+                            <a:srgbClr val="0F172A"/>
+                          </a:solidFill>
+                        </a:defRPr>
+                      </a:pPr>
+                      <a:r>
+                        <a:t>NOT NULL</a:t>
+                      </a:r>
+                    </a:p>
+                  </a:txBody>
+                  <a:tcPr>
+                    <a:solidFill>
+                      <a:srgbClr val="FFFFFF"/>
+                    </a:solidFill>
+                  </a:tcPr>
+                </a:tc>
+                <a:tc>
+                  <a:txBody>
+                    <a:bodyPr/>
+                    <a:lstStyle/>
+                    <a:p>
+                      <a:pPr>
+                        <a:defRPr sz="1150">
+                          <a:solidFill>
+                            <a:srgbClr val="0F172A"/>
+                          </a:solidFill>
+                        </a:defRPr>
+                      </a:pPr>
+                      <a:r>
+                        <a:t>Standardized crop species (e.g. Wheat, Rice, Sugarcane)</a:t>
+                      </a:r>
+                    </a:p>
+                  </a:txBody>
+                  <a:tcPr>
+                    <a:solidFill>
+                      <a:srgbClr val="FFFFFF"/>
+                    </a:solidFill>
+                  </a:tcPr>
+                </a:tc>
+              </a:tr>
+              <a:tr h="289560">
+                <a:tc>
+                  <a:txBody>
+                    <a:bodyPr/>
+                    <a:lstStyle/>
+                    <a:p>
+                      <a:pPr>
+                        <a:defRPr sz="1150">
+                          <a:solidFill>
+                            <a:srgbClr val="0F172A"/>
+                          </a:solidFill>
+                        </a:defRPr>
+                      </a:pPr>
+                      <a:r>
+                        <a:t>State</a:t>
+                      </a:r>
+                    </a:p>
+                  </a:txBody>
+                  <a:tcPr>
+                    <a:solidFill>
+                      <a:srgbClr val="FFFFFF"/>
+                    </a:solidFill>
+                  </a:tcPr>
+                </a:tc>
+                <a:tc>
+                  <a:txBody>
+                    <a:bodyPr/>
+                    <a:lstStyle/>
+                    <a:p>
+                      <a:pPr>
+                        <a:defRPr sz="1150">
+                          <a:solidFill>
+                            <a:srgbClr val="0F172A"/>
+                          </a:solidFill>
+                        </a:defRPr>
+                      </a:pPr>
+                      <a:r>
+                        <a:t>VARCHAR(50)</a:t>
+                      </a:r>
+                    </a:p>
+                  </a:txBody>
+                  <a:tcPr>
+                    <a:solidFill>
+                      <a:srgbClr val="FFFFFF"/>
+                    </a:solidFill>
+                  </a:tcPr>
+                </a:tc>
+                <a:tc>
+                  <a:txBody>
+                    <a:bodyPr/>
+                    <a:lstStyle/>
+                    <a:p>
+                      <a:pPr>
+                        <a:defRPr sz="1150">
+                          <a:solidFill>
+                            <a:srgbClr val="0F172A"/>
+                          </a:solidFill>
+                        </a:defRPr>
+                      </a:pPr>
+                      <a:r>
+                        <a:t>NOT NULL</a:t>
+                      </a:r>
+                    </a:p>
+                  </a:txBody>
+                  <a:tcPr>
+                    <a:solidFill>
+                      <a:srgbClr val="FFFFFF"/>
+                    </a:solidFill>
+                  </a:tcPr>
+                </a:tc>
+                <a:tc>
+                  <a:txBody>
+                    <a:bodyPr/>
+                    <a:lstStyle/>
+                    <a:p>
+                      <a:pPr>
+                        <a:defRPr sz="1150">
+                          <a:solidFill>
+                            <a:srgbClr val="0F172A"/>
+                          </a:solidFill>
+                        </a:defRPr>
+                      </a:pPr>
+                      <a:r>
+                        <a:t>Indian state or union territory administrative region</a:t>
+                      </a:r>
+                    </a:p>
+                  </a:txBody>
+                  <a:tcPr>
+                    <a:solidFill>
+                      <a:srgbClr val="FFFFFF"/>
+                    </a:solidFill>
+                  </a:tcPr>
+                </a:tc>
+              </a:tr>
+              <a:tr h="289560">
+                <a:tc>
+                  <a:txBody>
+                    <a:bodyPr/>
+                    <a:lstStyle/>
+                    <a:p>
+                      <a:pPr>
+                        <a:defRPr sz="1150">
+                          <a:solidFill>
+                            <a:srgbClr val="0F172A"/>
+                          </a:solidFill>
+                        </a:defRPr>
+                      </a:pPr>
+                      <a:r>
+                        <a:t>Season</a:t>
+                      </a:r>
+                    </a:p>
+                  </a:txBody>
+                  <a:tcPr>
+                    <a:solidFill>
+                      <a:srgbClr val="FFFFFF"/>
+                    </a:solidFill>
+                  </a:tcPr>
+                </a:tc>
+                <a:tc>
+                  <a:txBody>
+                    <a:bodyPr/>
+                    <a:lstStyle/>
+                    <a:p>
+                      <a:pPr>
+                        <a:defRPr sz="1150">
+                          <a:solidFill>
+                            <a:srgbClr val="0F172A"/>
+                          </a:solidFill>
+                        </a:defRPr>
+                      </a:pPr>
+                      <a:r>
+                        <a:t>VARCHAR(30)</a:t>
+                      </a:r>
+                    </a:p>
+                  </a:txBody>
+                  <a:tcPr>
+                    <a:solidFill>
+                      <a:srgbClr val="FFFFFF"/>
+                    </a:solidFill>
+                  </a:tcPr>
+                </a:tc>
+                <a:tc>
+                  <a:txBody>
+                    <a:bodyPr/>
+                    <a:lstStyle/>
+                    <a:p>
+                      <a:pPr>
+                        <a:defRPr sz="1150">
+                          <a:solidFill>
+                            <a:srgbClr val="0F172A"/>
+                          </a:solidFill>
+                        </a:defRPr>
+                      </a:pPr>
+                      <a:r>
+                        <a:t>NOT NULL</a:t>
+                      </a:r>
+                    </a:p>
+                  </a:txBody>
+                  <a:tcPr>
+                    <a:solidFill>
+                      <a:srgbClr val="FFFFFF"/>
+                    </a:solidFill>
+                  </a:tcPr>
+                </a:tc>
+                <a:tc>
+                  <a:txBody>
+                    <a:bodyPr/>
+                    <a:lstStyle/>
+                    <a:p>
+                      <a:pPr>
+                        <a:defRPr sz="1150">
+                          <a:solidFill>
+                            <a:srgbClr val="0F172A"/>
+                          </a:solidFill>
+                        </a:defRPr>
+                      </a:pPr>
+                      <a:r>
+                        <a:t>Cropping window (Kharif, Rabi, Summer, Whole Year)</a:t>
+                      </a:r>
+                    </a:p>
+                  </a:txBody>
+                  <a:tcPr>
+                    <a:solidFill>
+                      <a:srgbClr val="FFFFFF"/>
+                    </a:solidFill>
+                  </a:tcPr>
+                </a:tc>
+              </a:tr>
+              <a:tr h="289560">
+                <a:tc>
+                  <a:txBody>
+                    <a:bodyPr/>
+                    <a:lstStyle/>
+                    <a:p>
+                      <a:pPr>
+                        <a:defRPr sz="1150">
+                          <a:solidFill>
+                            <a:srgbClr val="0F172A"/>
+                          </a:solidFill>
+                        </a:defRPr>
+                      </a:pPr>
+                      <a:r>
+                        <a:t>Area / Rainfall</a:t>
+                      </a:r>
+                    </a:p>
+                  </a:txBody>
+                  <a:tcPr>
+                    <a:solidFill>
+                      <a:srgbClr val="FFFFFF"/>
+                    </a:solidFill>
+                  </a:tcPr>
+                </a:tc>
+                <a:tc>
+                  <a:txBody>
+                    <a:bodyPr/>
+                    <a:lstStyle/>
+                    <a:p>
+                      <a:pPr>
+                        <a:defRPr sz="1150">
+                          <a:solidFill>
+                            <a:srgbClr val="0F172A"/>
+                          </a:solidFill>
+                        </a:defRPr>
+                      </a:pPr>
+                      <a:r>
+                        <a:t>DOUBLE PRECISION</a:t>
+                      </a:r>
+                    </a:p>
+                  </a:txBody>
+                  <a:tcPr>
+                    <a:solidFill>
+                      <a:srgbClr val="FFFFFF"/>
+                    </a:solidFill>
+                  </a:tcPr>
+                </a:tc>
+                <a:tc>
+                  <a:txBody>
+                    <a:bodyPr/>
+                    <a:lstStyle/>
+                    <a:p>
+                      <a:pPr>
+                        <a:defRPr sz="1150">
+                          <a:solidFill>
+                            <a:srgbClr val="0F172A"/>
+                          </a:solidFill>
+                        </a:defRPr>
+                      </a:pPr>
+                      <a:r>
+                        <a:t>CHECK (&gt;= 0)</a:t>
+                      </a:r>
+                    </a:p>
+                  </a:txBody>
+                  <a:tcPr>
+                    <a:solidFill>
+                      <a:srgbClr val="FFFFFF"/>
+                    </a:solidFill>
+                  </a:tcPr>
+                </a:tc>
+                <a:tc>
+                  <a:txBody>
+                    <a:bodyPr/>
+                    <a:lstStyle/>
+                    <a:p>
+                      <a:pPr>
+                        <a:defRPr sz="1150">
+                          <a:solidFill>
+                            <a:srgbClr val="0F172A"/>
+                          </a:solidFill>
+                        </a:defRPr>
+                      </a:pPr>
+                      <a:r>
+                        <a:t>Cultivated hectares (ha) and annual precipitation (mm)</a:t>
+                      </a:r>
+                    </a:p>
+                  </a:txBody>
+                  <a:tcPr>
+                    <a:solidFill>
+                      <a:srgbClr val="FFFFFF"/>
+                    </a:solidFill>
+                  </a:tcPr>
+                </a:tc>
+              </a:tr>
+            </a:tbl>
+          </a:graphicData>
+        </a:graphic>
+      </p:graphicFrame>
+      <p:sp>
+        <p:nvSpPr>
+          <p:cNvPr id="6" name="TextBox 5"/>
+          <p:cNvSpPr txBox="1"/>
+          <p:nvPr/>
+        </p:nvSpPr>
+        <p:spPr>
+          <a:xfrm>
+            <a:off x="822960" y="3566160"/>
+            <a:ext cx="10515600" cy="365760"/>
+          </a:xfrm>
+          <a:prstGeom prst="rect">
+            <a:avLst/>
+          </a:prstGeom>
+          <a:noFill/>
+        </p:spPr>
+        <p:txBody>
+          <a:bodyPr wrap="none">
+            <a:spAutoFit/>
+          </a:bodyPr>
+          <a:lstStyle/>
+          <a:p>
+            <a:pPr>
+              <a:defRPr sz="1300" b="1">
+                <a:solidFill>
+                  <a:srgbClr val="0284C7"/>
+                </a:solidFill>
+              </a:defRPr>
+            </a:pPr>
+            <a:r>
+              <a:t>TABLE 2: YIELD_PREDICTIONS_LOG (Inference Output Schema)</a:t>
+            </a:r>
+          </a:p>
+        </p:txBody>
+      </p:sp>
+      <p:graphicFrame>
+        <p:nvGraphicFramePr>
+          <p:cNvPr id="7" name="Table 6"/>
+          <p:cNvGraphicFramePr>
+            <a:graphicFrameLocks noGrp="1"/>
+          </p:cNvGraphicFramePr>
+          <p:nvPr/>
+        </p:nvGraphicFramePr>
+        <p:xfrm>
+          <a:off x="822960" y="3931920"/>
+          <a:ext cx="10545775" cy="1463040"/>
+        </p:xfrm>
+        <a:graphic>
+          <a:graphicData uri="http://schemas.openxmlformats.org/drawingml/2006/table">
+            <a:tbl>
+              <a:tblPr firstRow="1" bandRow="1">
+                <a:tableStyleId>{5C22544A-7EE6-4342-B048-85BDC9FD1C3A}</a:tableStyleId>
+              </a:tblPr>
+              <a:tblGrid>
+                <a:gridCol w="2560320"/>
+                <a:gridCol w="2011680"/>
+                <a:gridCol w="1645920"/>
+                <a:gridCol w="4327855"/>
+              </a:tblGrid>
+              <a:tr h="292608">
+                <a:tc>
+                  <a:txBody>
+                    <a:bodyPr/>
+                    <a:lstStyle/>
+                    <a:p>
+                      <a:pPr>
+                        <a:defRPr sz="1200" b="1">
+                          <a:solidFill>
+                            <a:srgbClr val="FFFFFF"/>
+                          </a:solidFill>
+                        </a:defRPr>
+                      </a:pPr>
+                      <a:r>
+                        <a:t>Field Name</a:t>
+                      </a:r>
+                    </a:p>
+                  </a:txBody>
+                  <a:tcPr>
+                    <a:solidFill>
+                      <a:srgbClr val="0284C7"/>
+                    </a:solidFill>
+                  </a:tcPr>
+                </a:tc>
+                <a:tc>
+                  <a:txBody>
+                    <a:bodyPr/>
+                    <a:lstStyle/>
+                    <a:p>
+                      <a:pPr>
+                        <a:defRPr sz="1200" b="1">
+                          <a:solidFill>
+                            <a:srgbClr val="FFFFFF"/>
+                          </a:solidFill>
+                        </a:defRPr>
+                      </a:pPr>
+                      <a:r>
+                        <a:t>Data Type</a:t>
+                      </a:r>
+                    </a:p>
+                  </a:txBody>
+                  <a:tcPr>
+                    <a:solidFill>
+                      <a:srgbClr val="0284C7"/>
+                    </a:solidFill>
+                  </a:tcPr>
+                </a:tc>
+                <a:tc>
+                  <a:txBody>
+                    <a:bodyPr/>
+                    <a:lstStyle/>
+                    <a:p>
+                      <a:pPr>
+                        <a:defRPr sz="1200" b="1">
+                          <a:solidFill>
+                            <a:srgbClr val="FFFFFF"/>
+                          </a:solidFill>
+                        </a:defRPr>
+                      </a:pPr>
+                      <a:r>
+                        <a:t>Constraints</a:t>
+                      </a:r>
+                    </a:p>
+                  </a:txBody>
+                  <a:tcPr>
+                    <a:solidFill>
+                      <a:srgbClr val="0284C7"/>
+                    </a:solidFill>
+                  </a:tcPr>
+                </a:tc>
+                <a:tc>
+                  <a:txBody>
+                    <a:bodyPr/>
+                    <a:lstStyle/>
+                    <a:p>
+                      <a:pPr>
+                        <a:defRPr sz="1200" b="1">
+                          <a:solidFill>
+                            <a:srgbClr val="FFFFFF"/>
+                          </a:solidFill>
+                        </a:defRPr>
+                      </a:pPr>
+                      <a:r>
+                        <a:t>Description</a:t>
+                      </a:r>
+                    </a:p>
+                  </a:txBody>
+                  <a:tcPr>
+                    <a:solidFill>
+                      <a:srgbClr val="0284C7"/>
+                    </a:solidFill>
+                  </a:tcPr>
+                </a:tc>
+              </a:tr>
+              <a:tr h="292608">
+                <a:tc>
+                  <a:txBody>
+                    <a:bodyPr/>
+                    <a:lstStyle/>
+                    <a:p>
+                      <a:pPr>
+                        <a:defRPr sz="1150">
+                          <a:solidFill>
+                            <a:srgbClr val="0F172A"/>
+                          </a:solidFill>
+                        </a:defRPr>
+                      </a:pPr>
+                      <a:r>
+                        <a:t>Prediction_ID</a:t>
+                      </a:r>
+                    </a:p>
+                  </a:txBody>
+                  <a:tcPr>
+                    <a:solidFill>
+                      <a:srgbClr val="FFFFFF"/>
+                    </a:solidFill>
+                  </a:tcPr>
+                </a:tc>
+                <a:tc>
+                  <a:txBody>
+                    <a:bodyPr/>
+                    <a:lstStyle/>
+                    <a:p>
+                      <a:pPr>
+                        <a:defRPr sz="1150">
+                          <a:solidFill>
+                            <a:srgbClr val="0F172A"/>
+                          </a:solidFill>
+                        </a:defRPr>
+                      </a:pPr>
+                      <a:r>
+                        <a:t>INTEGER</a:t>
+                      </a:r>
+                    </a:p>
+                  </a:txBody>
+                  <a:tcPr>
+                    <a:solidFill>
+                      <a:srgbClr val="FFFFFF"/>
+                    </a:solidFill>
+                  </a:tcPr>
+                </a:tc>
+                <a:tc>
+                  <a:txBody>
+                    <a:bodyPr/>
+                    <a:lstStyle/>
+                    <a:p>
+                      <a:pPr>
+                        <a:defRPr sz="1150">
+                          <a:solidFill>
+                            <a:srgbClr val="0F172A"/>
+                          </a:solidFill>
+                        </a:defRPr>
+                      </a:pPr>
+                      <a:r>
+                        <a:t>PRIMARY KEY</a:t>
+                      </a:r>
+                    </a:p>
+                  </a:txBody>
+                  <a:tcPr>
+                    <a:solidFill>
+                      <a:srgbClr val="FFFFFF"/>
+                    </a:solidFill>
+                  </a:tcPr>
+                </a:tc>
+                <a:tc>
+                  <a:txBody>
+                    <a:bodyPr/>
+                    <a:lstStyle/>
+                    <a:p>
+                      <a:pPr>
+                        <a:defRPr sz="1150">
+                          <a:solidFill>
+                            <a:srgbClr val="0F172A"/>
+                          </a:solidFill>
+                        </a:defRPr>
+                      </a:pPr>
+                      <a:r>
+                        <a:t>Unique prediction transaction identifier</a:t>
+                      </a:r>
+                    </a:p>
+                  </a:txBody>
+                  <a:tcPr>
+                    <a:solidFill>
+                      <a:srgbClr val="FFFFFF"/>
+                    </a:solidFill>
+                  </a:tcPr>
+                </a:tc>
+              </a:tr>
+              <a:tr h="292608">
+                <a:tc>
+                  <a:txBody>
+                    <a:bodyPr/>
+                    <a:lstStyle/>
+                    <a:p>
+                      <a:pPr>
+                        <a:defRPr sz="1150">
+                          <a:solidFill>
+                            <a:srgbClr val="0F172A"/>
+                          </a:solidFill>
+                        </a:defRPr>
+                      </a:pPr>
+                      <a:r>
+                        <a:t>Predicted_Yield</a:t>
+                      </a:r>
+                    </a:p>
+                  </a:txBody>
+                  <a:tcPr>
+                    <a:solidFill>
+                      <a:srgbClr val="FFFFFF"/>
+                    </a:solidFill>
+                  </a:tcPr>
+                </a:tc>
+                <a:tc>
+                  <a:txBody>
+                    <a:bodyPr/>
+                    <a:lstStyle/>
+                    <a:p>
+                      <a:pPr>
+                        <a:defRPr sz="1150">
+                          <a:solidFill>
+                            <a:srgbClr val="0F172A"/>
+                          </a:solidFill>
+                        </a:defRPr>
+                      </a:pPr>
+                      <a:r>
+                        <a:t>DOUBLE PRECISION</a:t>
+                      </a:r>
+                    </a:p>
+                  </a:txBody>
+                  <a:tcPr>
+                    <a:solidFill>
+                      <a:srgbClr val="FFFFFF"/>
+                    </a:solidFill>
+                  </a:tcPr>
+                </a:tc>
+                <a:tc>
+                  <a:txBody>
+                    <a:bodyPr/>
+                    <a:lstStyle/>
+                    <a:p>
+                      <a:pPr>
+                        <a:defRPr sz="1150">
+                          <a:solidFill>
+                            <a:srgbClr val="0F172A"/>
+                          </a:solidFill>
+                        </a:defRPr>
+                      </a:pPr>
+                      <a:r>
+                        <a:t>NOT NULL</a:t>
+                      </a:r>
+                    </a:p>
+                  </a:txBody>
+                  <a:tcPr>
+                    <a:solidFill>
+                      <a:srgbClr val="FFFFFF"/>
+                    </a:solidFill>
+                  </a:tcPr>
+                </a:tc>
+                <a:tc>
+                  <a:txBody>
+                    <a:bodyPr/>
+                    <a:lstStyle/>
+                    <a:p>
+                      <a:pPr>
+                        <a:defRPr sz="1150">
+                          <a:solidFill>
+                            <a:srgbClr val="0F172A"/>
+                          </a:solidFill>
+                        </a:defRPr>
+                      </a:pPr>
+                      <a:r>
+                        <a:t>Predicted agricultural rate in Tonnes per Hectare (t/ha)</a:t>
+                      </a:r>
+                    </a:p>
+                  </a:txBody>
+                  <a:tcPr>
+                    <a:solidFill>
+                      <a:srgbClr val="FFFFFF"/>
+                    </a:solidFill>
+                  </a:tcPr>
+                </a:tc>
+              </a:tr>
+              <a:tr h="292608">
+                <a:tc>
+                  <a:txBody>
+                    <a:bodyPr/>
+                    <a:lstStyle/>
+                    <a:p>
+                      <a:pPr>
+                        <a:defRPr sz="1150">
+                          <a:solidFill>
+                            <a:srgbClr val="0F172A"/>
+                          </a:solidFill>
+                        </a:defRPr>
+                      </a:pPr>
+                      <a:r>
+                        <a:t>Yield_Per_Acre</a:t>
+                      </a:r>
+                    </a:p>
+                  </a:txBody>
+                  <a:tcPr>
+                    <a:solidFill>
+                      <a:srgbClr val="FFFFFF"/>
+                    </a:solidFill>
+                  </a:tcPr>
+                </a:tc>
+                <a:tc>
+                  <a:txBody>
+                    <a:bodyPr/>
+                    <a:lstStyle/>
+                    <a:p>
+                      <a:pPr>
+                        <a:defRPr sz="1150">
+                          <a:solidFill>
+                            <a:srgbClr val="0F172A"/>
+                          </a:solidFill>
+                        </a:defRPr>
+                      </a:pPr>
+                      <a:r>
+                        <a:t>DOUBLE PRECISION</a:t>
+                      </a:r>
+                    </a:p>
+                  </a:txBody>
+                  <a:tcPr>
+                    <a:solidFill>
+                      <a:srgbClr val="FFFFFF"/>
+                    </a:solidFill>
+                  </a:tcPr>
+                </a:tc>
+                <a:tc>
+                  <a:txBody>
+                    <a:bodyPr/>
+                    <a:lstStyle/>
+                    <a:p>
+                      <a:pPr>
+                        <a:defRPr sz="1150">
+                          <a:solidFill>
+                            <a:srgbClr val="0F172A"/>
+                          </a:solidFill>
+                        </a:defRPr>
+                      </a:pPr>
+                      <a:r>
+                        <a:t>NOT NULL</a:t>
+                      </a:r>
+                    </a:p>
+                  </a:txBody>
+                  <a:tcPr>
+                    <a:solidFill>
+                      <a:srgbClr val="FFFFFF"/>
+                    </a:solidFill>
+                  </a:tcPr>
+                </a:tc>
+                <a:tc>
+                  <a:txBody>
+                    <a:bodyPr/>
+                    <a:lstStyle/>
+                    <a:p>
+                      <a:pPr>
+                        <a:defRPr sz="1150">
+                          <a:solidFill>
+                            <a:srgbClr val="0F172A"/>
+                          </a:solidFill>
+                        </a:defRPr>
+                      </a:pPr>
+                      <a:r>
+                        <a:t>Acre equivalent conversion (Predicted_Yield / 2.471)</a:t>
+                      </a:r>
+                    </a:p>
+                  </a:txBody>
+                  <a:tcPr>
+                    <a:solidFill>
+                      <a:srgbClr val="FFFFFF"/>
+                    </a:solidFill>
+                  </a:tcPr>
+                </a:tc>
+              </a:tr>
+              <a:tr h="292608">
+                <a:tc>
+                  <a:txBody>
+                    <a:bodyPr/>
+                    <a:lstStyle/>
+                    <a:p>
+                      <a:pPr>
+                        <a:defRPr sz="1150">
+                          <a:solidFill>
+                            <a:srgbClr val="0F172A"/>
+                          </a:solidFill>
+                        </a:defRPr>
+                      </a:pPr>
+                      <a:r>
+                        <a:t>Total_Commercial_Tonnes</a:t>
+                      </a:r>
+                    </a:p>
+                  </a:txBody>
+                  <a:tcPr>
+                    <a:solidFill>
+                      <a:srgbClr val="FFFFFF"/>
+                    </a:solidFill>
+                  </a:tcPr>
+                </a:tc>
+                <a:tc>
+                  <a:txBody>
+                    <a:bodyPr/>
+                    <a:lstStyle/>
+                    <a:p>
+                      <a:pPr>
+                        <a:defRPr sz="1150">
+                          <a:solidFill>
+                            <a:srgbClr val="0F172A"/>
+                          </a:solidFill>
+                        </a:defRPr>
+                      </a:pPr>
+                      <a:r>
+                        <a:t>DOUBLE PRECISION</a:t>
+                      </a:r>
+                    </a:p>
+                  </a:txBody>
+                  <a:tcPr>
+                    <a:solidFill>
+                      <a:srgbClr val="FFFFFF"/>
+                    </a:solidFill>
+                  </a:tcPr>
+                </a:tc>
+                <a:tc>
+                  <a:txBody>
+                    <a:bodyPr/>
+                    <a:lstStyle/>
+                    <a:p>
+                      <a:pPr>
+                        <a:defRPr sz="1150">
+                          <a:solidFill>
+                            <a:srgbClr val="0F172A"/>
+                          </a:solidFill>
+                        </a:defRPr>
+                      </a:pPr>
+                      <a:r>
+                        <a:t>NOT NULL</a:t>
+                      </a:r>
+                    </a:p>
+                  </a:txBody>
+                  <a:tcPr>
+                    <a:solidFill>
+                      <a:srgbClr val="FFFFFF"/>
+                    </a:solidFill>
+                  </a:tcPr>
+                </a:tc>
+                <a:tc>
+                  <a:txBody>
+                    <a:bodyPr/>
+                    <a:lstStyle/>
+                    <a:p>
+                      <a:pPr>
+                        <a:defRPr sz="1150">
+                          <a:solidFill>
+                            <a:srgbClr val="0F172A"/>
+                          </a:solidFill>
+                        </a:defRPr>
+                      </a:pPr>
+                      <a:r>
+                        <a:t>Gross harvest weight for entire farm (Predicted_Yield * Area)</a:t>
+                      </a:r>
+                    </a:p>
+                  </a:txBody>
+                  <a:tcPr>
+                    <a:solidFill>
+                      <a:srgbClr val="FFFFFF"/>
+                    </a:solidFill>
+                  </a:tcPr>
+                </a:tc>
+              </a:tr>
+            </a:tbl>
+          </a:graphicData>
+        </a:graphic>
+      </p:graphicFrame>
+      <p:sp>
+        <p:nvSpPr>
+          <p:cNvPr id="8" name="TextBox 7"/>
+          <p:cNvSpPr txBox="1"/>
+          <p:nvPr/>
+        </p:nvSpPr>
+        <p:spPr>
+          <a:xfrm>
+            <a:off x="822960" y="5577840"/>
+            <a:ext cx="10515600" cy="822960"/>
+          </a:xfrm>
+          <a:prstGeom prst="rect">
+            <a:avLst/>
+          </a:prstGeom>
+          <a:noFill/>
+        </p:spPr>
+        <p:txBody>
+          <a:bodyPr wrap="none">
+            <a:spAutoFit/>
+          </a:bodyPr>
+          <a:lstStyle/>
+          <a:p>
+            <a:pPr>
+              <a:defRPr sz="1200" b="1">
+                <a:solidFill>
+                  <a:srgbClr val="065F46"/>
+                </a:solidFill>
+              </a:defRPr>
+            </a:pPr>
+            <a:r>
+              <a:t>🛡️ Schema Integrity Note: 'Production' is explicitly omitted from training schemas to enforce zero data leakage.</a:t>
+            </a:r>
+          </a:p>
+        </p:txBody>
+      </p:sp>
+    </p:spTree>
+  </p:cSld>
+  <p:clrMapOvr>
+    <a:masterClrMapping/>
+  </p:clrMapOvr>
+</p:sld>
+</file>
+
+<file path=ppt/slides/slide7.xml><?xml version="1.0" encoding="utf-8"?>
+<p:sld xmlns:a="http://schemas.openxmlformats.org/drawingml/2006/main" xmlns:p="http://schemas.openxmlformats.org/presentationml/2006/main" xmlns:r="http://schemas.openxmlformats.org/officeDocument/2006/relationships">
+  <p:cSld>
+    <p:bg>
+      <p:bgPr>
+        <a:solidFill>
+          <a:srgbClr val="F8FAFC"/>
+        </a:solidFill>
+        <a:effectLst/>
+      </p:bgPr>
+    </p:bg>
+    <p:spTree>
+      <p:nvGrpSpPr>
+        <p:cNvPr id="1" name=""/>
+        <p:cNvGrpSpPr/>
+        <p:nvPr/>
+      </p:nvGrpSpPr>
+      <p:grpSpPr/>
+      <p:sp>
+        <p:nvSpPr>
+          <p:cNvPr id="2" name="TextBox 1"/>
+          <p:cNvSpPr txBox="1"/>
+          <p:nvPr/>
+        </p:nvSpPr>
+        <p:spPr>
+          <a:xfrm>
+            <a:off x="822960" y="320040"/>
+            <a:ext cx="10515600" cy="274320"/>
+          </a:xfrm>
+          <a:prstGeom prst="rect">
+            <a:avLst/>
+          </a:prstGeom>
+          <a:noFill/>
+        </p:spPr>
+        <p:txBody>
+          <a:bodyPr wrap="none">
+            <a:spAutoFit/>
+          </a:bodyPr>
+          <a:lstStyle/>
+          <a:p>
+            <a:pPr>
+              <a:defRPr sz="1050" b="1">
+                <a:solidFill>
+                  <a:srgbClr val="059669"/>
+                </a:solidFill>
+              </a:defRPr>
+            </a:pPr>
+            <a:r>
+              <a:t>AGRIYIELD  •  SLIDE 7 OF 8</a:t>
+            </a:r>
+          </a:p>
+        </p:txBody>
+      </p:sp>
+      <p:sp>
+        <p:nvSpPr>
+          <p:cNvPr id="3" name="TextBox 2"/>
+          <p:cNvSpPr txBox="1"/>
+          <p:nvPr/>
+        </p:nvSpPr>
+        <p:spPr>
+          <a:xfrm>
+            <a:off x="822960" y="594360"/>
+            <a:ext cx="10515600" cy="685800"/>
+          </a:xfrm>
+          <a:prstGeom prst="rect">
+            <a:avLst/>
+          </a:prstGeom>
+          <a:noFill/>
+        </p:spPr>
+        <p:txBody>
+          <a:bodyPr wrap="none">
+            <a:spAutoFit/>
+          </a:bodyPr>
+          <a:lstStyle/>
+          <a:p>
+            <a:pPr>
+              <a:defRPr sz="2600" b="1">
+                <a:solidFill>
+                  <a:srgbClr val="0F172A"/>
+                </a:solidFill>
+              </a:defRPr>
+            </a:pPr>
+            <a:r>
+              <a:t>Form Design (User Input Interface)</a:t>
+            </a:r>
+          </a:p>
+        </p:txBody>
+      </p:sp>
+      <p:pic>
+        <p:nvPicPr>
+          <p:cNvPr id="4" name="Picture 3" descr="form_design_screenshot.png"/>
+          <p:cNvPicPr>
+            <a:picLocks noChangeAspect="1"/>
+          </p:cNvPicPr>
+          <p:nvPr/>
+        </p:nvPicPr>
+        <p:blipFill>
+          <a:blip r:embed="rId2"/>
+          <a:stretch>
+            <a:fillRect/>
+          </a:stretch>
+        </p:blipFill>
+        <p:spPr>
+          <a:xfrm>
+            <a:off x="822960" y="1371600"/>
+            <a:ext cx="6583680" cy="2314575"/>
+          </a:xfrm>
+          <a:prstGeom prst="rect">
+            <a:avLst/>
+          </a:prstGeom>
+        </p:spPr>
+      </p:pic>
+      <p:sp>
+        <p:nvSpPr>
+          <p:cNvPr id="5" name="Rounded Rectangle 4"/>
           <p:cNvSpPr/>
           <p:nvPr/>
         </p:nvSpPr>
         <p:spPr>
           <a:xfrm>
-            <a:off x="822960" y="1463040"/>
-            <a:ext cx="5120640" cy="4846320"/>
+            <a:off x="7589520" y="1371600"/>
+            <a:ext cx="3779215" cy="4937760"/>
           </a:xfrm>
           <a:prstGeom prst="roundRect">
             <a:avLst/>
@@ -5556,14 +6480,14 @@
       </p:sp>
       <p:sp>
         <p:nvSpPr>
-          <p:cNvPr id="5" name="TextBox 4"/>
+          <p:cNvPr id="6" name="TextBox 5"/>
           <p:cNvSpPr txBox="1"/>
           <p:nvPr/>
         </p:nvSpPr>
         <p:spPr>
           <a:xfrm>
-            <a:off x="1097280" y="1737360"/>
-            <a:ext cx="4572000" cy="4297680"/>
+            <a:off x="7818120" y="1600200"/>
+            <a:ext cx="3291840" cy="4389120"/>
           </a:xfrm>
           <a:prstGeom prst="rect">
             <a:avLst/>
@@ -5577,118 +6501,238 @@
           <a:lstStyle/>
           <a:p>
             <a:pPr>
-              <a:defRPr sz="1800" b="1">
+              <a:defRPr sz="1600" b="1">
                 <a:solidFill>
                   <a:srgbClr val="059669"/>
                 </a:solidFill>
               </a:defRPr>
             </a:pPr>
             <a:r>
-              <a:t>TECHNOLOGY STACK</a:t>
+              <a:t>INPUT FORM SPECIFICATIONS</a:t>
             </a:r>
           </a:p>
           <a:p>
             <a:pPr>
               <a:spcBef>
-                <a:spcPts val="1200"/>
+                <a:spcPts val="800"/>
               </a:spcBef>
-              <a:defRPr sz="1500">
+              <a:defRPr sz="1200">
                 <a:solidFill>
                   <a:srgbClr val="0F172A"/>
                 </a:solidFill>
               </a:defRPr>
             </a:pPr>
             <a:r>
-              <a:t>• Python: Core programming language for data science.</a:t>
+              <a:t>• Quick Demonstration Presets: 1-Click buttons for Punjab Wheat, West Bengal Rice, and Maharashtra Sugarcane.</a:t>
             </a:r>
           </a:p>
           <a:p>
             <a:pPr>
               <a:spcBef>
-                <a:spcPts val="1200"/>
+                <a:spcPts val="800"/>
               </a:spcBef>
-              <a:defRPr sz="1500">
+              <a:defRPr sz="1200">
                 <a:solidFill>
                   <a:srgbClr val="0F172A"/>
                 </a:solidFill>
               </a:defRPr>
             </a:pPr>
             <a:r>
-              <a:t>• Pandas &amp; NumPy: Data cleaning and preprocessing.</a:t>
+              <a:t>• Crop &amp; State Dropdowns: Select from 55 authentic crops and 30 Indian states.</a:t>
             </a:r>
           </a:p>
           <a:p>
             <a:pPr>
               <a:spcBef>
-                <a:spcPts val="1200"/>
+                <a:spcPts val="800"/>
               </a:spcBef>
-              <a:defRPr sz="1500">
+              <a:defRPr sz="1200">
                 <a:solidFill>
                   <a:srgbClr val="0F172A"/>
                 </a:solidFill>
               </a:defRPr>
             </a:pPr>
             <a:r>
-              <a:t>• Scikit-Learn: Random Forest machine learning model.</a:t>
+              <a:t>• Cropping Season: Select from Kharif, Rabi, Summer, Autumn, Winter, or Whole Year.</a:t>
             </a:r>
           </a:p>
           <a:p>
             <a:pPr>
               <a:spcBef>
-                <a:spcPts val="1200"/>
+                <a:spcPts val="800"/>
               </a:spcBef>
-              <a:defRPr sz="1500">
+              <a:defRPr sz="1200">
                 <a:solidFill>
                   <a:srgbClr val="0F172A"/>
                 </a:solidFill>
               </a:defRPr>
             </a:pPr>
             <a:r>
-              <a:t>• Streamlit: Interactive presentation web dashboard.</a:t>
+              <a:t>• Cultivated Area: Numeric input in Hectares (district or farm acreage).</a:t>
             </a:r>
           </a:p>
           <a:p>
             <a:pPr>
               <a:spcBef>
-                <a:spcPts val="1200"/>
+                <a:spcPts val="800"/>
               </a:spcBef>
-              <a:defRPr sz="1500">
+              <a:defRPr sz="1200">
                 <a:solidFill>
                   <a:srgbClr val="0F172A"/>
                 </a:solidFill>
               </a:defRPr>
             </a:pPr>
             <a:r>
-              <a:t>• Plotly: Interactive charts, trends, and comparisons.</a:t>
+              <a:t>• Rainfall &amp; Inputs: Annual precipitation (mm), total fertilizer (kg), and pesticide (kg).</a:t>
             </a:r>
           </a:p>
           <a:p>
             <a:pPr>
               <a:spcBef>
-                <a:spcPts val="1200"/>
+                <a:spcPts val="800"/>
               </a:spcBef>
-              <a:defRPr sz="1500">
+              <a:defRPr sz="1200">
                 <a:solidFill>
                   <a:srgbClr val="0F172A"/>
                 </a:solidFill>
               </a:defRPr>
             </a:pPr>
             <a:r>
-              <a:t>• GitHub &amp; Streamlit Cloud: 24/7 online hosting.</a:t>
-            </a:r>
-          </a:p>
-        </p:txBody>
-      </p:sp>
-      <p:sp>
-        <p:nvSpPr>
-          <p:cNvPr id="6" name="Rounded Rectangle 5"/>
+              <a:t>• Action Trigger: Prominent green 'Calculate Predicted Yield' execution button.</a:t>
+            </a:r>
+          </a:p>
+        </p:txBody>
+      </p:sp>
+    </p:spTree>
+  </p:cSld>
+  <p:clrMapOvr>
+    <a:masterClrMapping/>
+  </p:clrMapOvr>
+</p:sld>
+</file>
+
+<file path=ppt/slides/slide8.xml><?xml version="1.0" encoding="utf-8"?>
+<p:sld xmlns:a="http://schemas.openxmlformats.org/drawingml/2006/main" xmlns:p="http://schemas.openxmlformats.org/presentationml/2006/main" xmlns:r="http://schemas.openxmlformats.org/officeDocument/2006/relationships">
+  <p:cSld>
+    <p:bg>
+      <p:bgPr>
+        <a:solidFill>
+          <a:srgbClr val="F8FAFC"/>
+        </a:solidFill>
+        <a:effectLst/>
+      </p:bgPr>
+    </p:bg>
+    <p:spTree>
+      <p:nvGrpSpPr>
+        <p:cNvPr id="1" name=""/>
+        <p:cNvGrpSpPr/>
+        <p:nvPr/>
+      </p:nvGrpSpPr>
+      <p:grpSpPr/>
+      <p:sp>
+        <p:nvSpPr>
+          <p:cNvPr id="2" name="TextBox 1"/>
+          <p:cNvSpPr txBox="1"/>
+          <p:nvPr/>
+        </p:nvSpPr>
+        <p:spPr>
+          <a:xfrm>
+            <a:off x="822960" y="320040"/>
+            <a:ext cx="10515600" cy="274320"/>
+          </a:xfrm>
+          <a:prstGeom prst="rect">
+            <a:avLst/>
+          </a:prstGeom>
+          <a:noFill/>
+        </p:spPr>
+        <p:txBody>
+          <a:bodyPr wrap="none">
+            <a:spAutoFit/>
+          </a:bodyPr>
+          <a:lstStyle/>
+          <a:p>
+            <a:pPr>
+              <a:defRPr sz="1050" b="1">
+                <a:solidFill>
+                  <a:srgbClr val="059669"/>
+                </a:solidFill>
+              </a:defRPr>
+            </a:pPr>
+            <a:r>
+              <a:t>AGRIYIELD  •  SLIDE 8 OF 8</a:t>
+            </a:r>
+          </a:p>
+        </p:txBody>
+      </p:sp>
+      <p:sp>
+        <p:nvSpPr>
+          <p:cNvPr id="3" name="TextBox 2"/>
+          <p:cNvSpPr txBox="1"/>
+          <p:nvPr/>
+        </p:nvSpPr>
+        <p:spPr>
+          <a:xfrm>
+            <a:off x="822960" y="594360"/>
+            <a:ext cx="10515600" cy="685800"/>
+          </a:xfrm>
+          <a:prstGeom prst="rect">
+            <a:avLst/>
+          </a:prstGeom>
+          <a:noFill/>
+        </p:spPr>
+        <p:txBody>
+          <a:bodyPr wrap="none">
+            <a:spAutoFit/>
+          </a:bodyPr>
+          <a:lstStyle/>
+          <a:p>
+            <a:pPr>
+              <a:defRPr sz="2600" b="1">
+                <a:solidFill>
+                  <a:srgbClr val="0F172A"/>
+                </a:solidFill>
+              </a:defRPr>
+            </a:pPr>
+            <a:r>
+              <a:t>Output Screen (Prediction Results)</a:t>
+            </a:r>
+          </a:p>
+        </p:txBody>
+      </p:sp>
+      <p:pic>
+        <p:nvPicPr>
+          <p:cNvPr id="4" name="Picture 3" descr="output_screen_screenshot.png"/>
+          <p:cNvPicPr>
+            <a:picLocks noChangeAspect="1"/>
+          </p:cNvPicPr>
+          <p:nvPr/>
+        </p:nvPicPr>
+        <p:blipFill>
+          <a:blip r:embed="rId2"/>
+          <a:stretch>
+            <a:fillRect/>
+          </a:stretch>
+        </p:blipFill>
+        <p:spPr>
+          <a:xfrm>
+            <a:off x="822960" y="1371600"/>
+            <a:ext cx="6583680" cy="2147411"/>
+          </a:xfrm>
+          <a:prstGeom prst="rect">
+            <a:avLst/>
+          </a:prstGeom>
+        </p:spPr>
+      </p:pic>
+      <p:sp>
+        <p:nvSpPr>
+          <p:cNvPr id="5" name="Rounded Rectangle 4"/>
           <p:cNvSpPr/>
           <p:nvPr/>
         </p:nvSpPr>
         <p:spPr>
           <a:xfrm>
-            <a:off x="6217920" y="1463040"/>
-            <a:ext cx="5120640" cy="4846320"/>
+            <a:off x="7589520" y="1371600"/>
+            <a:ext cx="3779215" cy="4937760"/>
           </a:xfrm>
           <a:prstGeom prst="roundRect">
             <a:avLst/>
@@ -5726,14 +6770,14 @@
       </p:sp>
       <p:sp>
         <p:nvSpPr>
-          <p:cNvPr id="7" name="TextBox 6"/>
+          <p:cNvPr id="6" name="TextBox 5"/>
           <p:cNvSpPr txBox="1"/>
           <p:nvPr/>
         </p:nvSpPr>
         <p:spPr>
           <a:xfrm>
-            <a:off x="6492240" y="1737360"/>
-            <a:ext cx="4572000" cy="4297680"/>
+            <a:off x="7818120" y="1600200"/>
+            <a:ext cx="3291840" cy="4389120"/>
           </a:xfrm>
           <a:prstGeom prst="rect">
             <a:avLst/>
@@ -5747,74 +6791,89 @@
           <a:lstStyle/>
           <a:p>
             <a:pPr>
-              <a:defRPr sz="1800" b="1">
+              <a:defRPr sz="1600" b="1">
                 <a:solidFill>
                   <a:srgbClr val="0284C7"/>
                 </a:solidFill>
               </a:defRPr>
             </a:pPr>
             <a:r>
-              <a:t>SIMPLE OUTPUT FORMAT</a:t>
+              <a:t>OUTPUT SCREEN COMPONENTS</a:t>
             </a:r>
           </a:p>
           <a:p>
             <a:pPr>
               <a:spcBef>
-                <a:spcPts val="1400"/>
+                <a:spcPts val="800"/>
               </a:spcBef>
-              <a:defRPr sz="1500">
+              <a:defRPr sz="1200">
                 <a:solidFill>
                   <a:srgbClr val="0F172A"/>
                 </a:solidFill>
               </a:defRPr>
             </a:pPr>
             <a:r>
-              <a:t>• Yield per Hectare: Scientific standard unit (e.g. 4.80 t/ha).</a:t>
+              <a:t>• Simple Summary Box: Provides a plain-language harvest summary stating total tonnes and acre equivalents.</a:t>
             </a:r>
           </a:p>
           <a:p>
             <a:pPr>
               <a:spcBef>
-                <a:spcPts val="1400"/>
+                <a:spcPts val="800"/>
               </a:spcBef>
-              <a:defRPr sz="1500">
+              <a:defRPr sz="1200">
                 <a:solidFill>
                   <a:srgbClr val="0F172A"/>
                 </a:solidFill>
               </a:defRPr>
             </a:pPr>
             <a:r>
-              <a:t>• Yield per Acre: Practical measure for local farmers (e.g. ~1.94 t/acre).</a:t>
+              <a:t>• Card 1 — Harvest Rate: Displays yield rate (e.g. 3.00 t/ha and 1.21 tonnes/acre) with state productivity tier badge.</a:t>
             </a:r>
           </a:p>
           <a:p>
             <a:pPr>
               <a:spcBef>
-                <a:spcPts val="1400"/>
+                <a:spcPts val="800"/>
               </a:spcBef>
-              <a:defRPr sz="1500">
+              <a:defRPr sz="1200">
                 <a:solidFill>
                   <a:srgbClr val="0F172A"/>
                 </a:solidFill>
               </a:defRPr>
             </a:pPr>
             <a:r>
-              <a:t>• Total Farm Harvest: Total gross tonnage expected from the entire field.</a:t>
+              <a:t>• Card 2 — Total Production: Displays gross farm tonnage (30,000 tonnes) and commercial 10-tonne truckload counts (3,000 trucks).</a:t>
             </a:r>
           </a:p>
           <a:p>
             <a:pPr>
               <a:spcBef>
-                <a:spcPts val="1400"/>
+                <a:spcPts val="800"/>
               </a:spcBef>
-              <a:defRPr sz="1500">
+              <a:defRPr sz="1200">
                 <a:solidFill>
                   <a:srgbClr val="0F172A"/>
                 </a:solidFill>
               </a:defRPr>
             </a:pPr>
             <a:r>
-              <a:t>• Commercial Truckloads: Estimated count of 10-tonne trucks (e.g. ≈ 48 trucks) so transport is planned easily.</a:t>
+              <a:t>• Card 3 — Weather Sensitivity: 90% confidence range (2.5 – 3.5 t/ha) accounting for dry vs. favorable monsoon seasons.</a:t>
+            </a:r>
+          </a:p>
+          <a:p>
+            <a:pPr>
+              <a:spcBef>
+                <a:spcPts val="800"/>
+              </a:spcBef>
+              <a:defRPr sz="1200">
+                <a:solidFill>
+                  <a:srgbClr val="0F172A"/>
+                </a:solidFill>
+              </a:defRPr>
+            </a:pPr>
+            <a:r>
+              <a:t>• Benchmark Comparison: Interactive bar chart comparing farm prediction with state average and national average.</a:t>
             </a:r>
           </a:p>
         </p:txBody>

</xml_diff>